<commit_message>
Changes to be committed: 	modified:   Admin/Course Attendance.xlsx 	renamed:    Stage1-C++-Beginner/2790-Knowing Variables/2790-Knowing Variables.pptx -> Stage1-C++-Beginner/2790-Know the Variables/2790-Know the Variables.pptx 	renamed:    Stage1-C++-Beginner/2790-Knowing Variables/cast -> Stage1-C++-Beginner/2790-Know the Variables/cast 	renamed:    Stage1-C++-Beginner/2790-Knowing Variables/cast.cpp -> Stage1-C++-Beginner/2790-Know the Variables/cast.cpp 	modified:   Stage1-C++-Beginner/2791-Branching 1.pptx 	new file:   Stage1-C++-Beginner/2791-Branching 1/2791-Branching 1.pptx 	modified:   Stage3-Informatics-Elementary-B/Trees/Elementary B - Trees.pptx
</commit_message>
<xml_diff>
--- a/Stage1-C++-Beginner/2791-Branching 1.pptx
+++ b/Stage1-C++-Beginner/2791-Branching 1.pptx
@@ -125,7 +125,7 @@
 <file path=ppt/revisionInfo.xml><?xml version="1.0" encoding="utf-8"?>
 <p1510:revInfo xmlns:a="http://schemas.openxmlformats.org/drawingml/2006/main" xmlns:r="http://schemas.openxmlformats.org/officeDocument/2006/relationships" xmlns:p1510="http://schemas.microsoft.com/office/powerpoint/2015/10/main">
   <p1510:revLst>
-    <p1510:client id="{1AB4ECCA-9332-41DB-8CB6-28EB9B0FD45E}" v="410" dt="2023-09-18T05:48:21.729"/>
+    <p1510:client id="{DF40FBBE-8D3C-E440-BF98-1EA218419C39}" v="50" dt="2026-08-08T12:05:53.481"/>
   </p1510:revLst>
 </p1510:revInfo>
 </file>
@@ -133,75 +133,28 @@
 <file path=ppt/changesInfos/changesInfo1.xml><?xml version="1.0" encoding="utf-8"?>
 <pc:chgInfo xmlns:a="http://schemas.openxmlformats.org/drawingml/2006/main" xmlns:r="http://schemas.openxmlformats.org/officeDocument/2006/relationships" xmlns:ac="http://schemas.microsoft.com/office/drawing/2013/main/command" xmlns:pc="http://schemas.microsoft.com/office/powerpoint/2013/main/command">
   <pc:docChgLst>
-    <pc:chgData name="Bryan Sun" userId="851caa7714272873" providerId="LiveId" clId="{1AB4ECCA-9332-41DB-8CB6-28EB9B0FD45E}"/>
-    <pc:docChg chg="undo custSel modSld">
-      <pc:chgData name="Bryan Sun" userId="851caa7714272873" providerId="LiveId" clId="{1AB4ECCA-9332-41DB-8CB6-28EB9B0FD45E}" dt="2023-09-18T05:48:37.021" v="1828" actId="1076"/>
+    <pc:chgData name="Bryan Sun" userId="851caa7714272873" providerId="LiveId" clId="{1DF0C224-3A3E-55A6-A8D1-F8F2208D385B}"/>
+    <pc:docChg chg="modSld">
+      <pc:chgData name="Bryan Sun" userId="851caa7714272873" providerId="LiveId" clId="{1DF0C224-3A3E-55A6-A8D1-F8F2208D385B}" dt="2026-08-08T12:12:54.398" v="114" actId="14100"/>
       <pc:docMkLst>
         <pc:docMk/>
       </pc:docMkLst>
       <pc:sldChg chg="modSp mod">
-        <pc:chgData name="Bryan Sun" userId="851caa7714272873" providerId="LiveId" clId="{1AB4ECCA-9332-41DB-8CB6-28EB9B0FD45E}" dt="2023-09-18T02:55:45.340" v="4" actId="20577"/>
-        <pc:sldMkLst>
-          <pc:docMk/>
-          <pc:sldMk cId="0" sldId="256"/>
-        </pc:sldMkLst>
-        <pc:spChg chg="mod">
-          <ac:chgData name="Bryan Sun" userId="851caa7714272873" providerId="LiveId" clId="{1AB4ECCA-9332-41DB-8CB6-28EB9B0FD45E}" dt="2023-09-18T02:55:37.806" v="0" actId="20577"/>
-          <ac:spMkLst>
-            <pc:docMk/>
-            <pc:sldMk cId="0" sldId="256"/>
-            <ac:spMk id="2" creationId="{00000000-0000-0000-0000-000000000000}"/>
-          </ac:spMkLst>
-        </pc:spChg>
-        <pc:spChg chg="mod">
-          <ac:chgData name="Bryan Sun" userId="851caa7714272873" providerId="LiveId" clId="{1AB4ECCA-9332-41DB-8CB6-28EB9B0FD45E}" dt="2023-09-18T02:55:45.340" v="4" actId="20577"/>
-          <ac:spMkLst>
-            <pc:docMk/>
-            <pc:sldMk cId="0" sldId="256"/>
-            <ac:spMk id="3" creationId="{00000000-0000-0000-0000-000000000000}"/>
-          </ac:spMkLst>
-        </pc:spChg>
-      </pc:sldChg>
-      <pc:sldChg chg="delSp modSp mod delAnim">
-        <pc:chgData name="Bryan Sun" userId="851caa7714272873" providerId="LiveId" clId="{1AB4ECCA-9332-41DB-8CB6-28EB9B0FD45E}" dt="2023-09-18T03:40:05.384" v="1018" actId="1076"/>
+        <pc:chgData name="Bryan Sun" userId="851caa7714272873" providerId="LiveId" clId="{1DF0C224-3A3E-55A6-A8D1-F8F2208D385B}" dt="2026-08-08T12:12:54.398" v="114" actId="14100"/>
         <pc:sldMkLst>
           <pc:docMk/>
           <pc:sldMk cId="0" sldId="332"/>
         </pc:sldMkLst>
         <pc:spChg chg="mod">
-          <ac:chgData name="Bryan Sun" userId="851caa7714272873" providerId="LiveId" clId="{1AB4ECCA-9332-41DB-8CB6-28EB9B0FD45E}" dt="2023-09-18T03:37:59.709" v="924" actId="1076"/>
-          <ac:spMkLst>
-            <pc:docMk/>
-            <pc:sldMk cId="0" sldId="332"/>
-            <ac:spMk id="7" creationId="{00000000-0000-0000-0000-000000000000}"/>
-          </ac:spMkLst>
-        </pc:spChg>
-        <pc:spChg chg="mod">
-          <ac:chgData name="Bryan Sun" userId="851caa7714272873" providerId="LiveId" clId="{1AB4ECCA-9332-41DB-8CB6-28EB9B0FD45E}" dt="2023-09-18T03:34:35.263" v="691" actId="1076"/>
-          <ac:spMkLst>
-            <pc:docMk/>
-            <pc:sldMk cId="0" sldId="332"/>
-            <ac:spMk id="9" creationId="{00000000-0000-0000-0000-000000000000}"/>
-          </ac:spMkLst>
-        </pc:spChg>
-        <pc:spChg chg="mod">
-          <ac:chgData name="Bryan Sun" userId="851caa7714272873" providerId="LiveId" clId="{1AB4ECCA-9332-41DB-8CB6-28EB9B0FD45E}" dt="2023-09-18T03:40:05.384" v="1018" actId="1076"/>
+          <ac:chgData name="Bryan Sun" userId="851caa7714272873" providerId="LiveId" clId="{1DF0C224-3A3E-55A6-A8D1-F8F2208D385B}" dt="2026-08-08T12:12:54.398" v="114" actId="14100"/>
           <ac:spMkLst>
             <pc:docMk/>
             <pc:sldMk cId="0" sldId="332"/>
             <ac:spMk id="14" creationId="{00000000-0000-0000-0000-000000000000}"/>
           </ac:spMkLst>
         </pc:spChg>
-        <pc:graphicFrameChg chg="del">
-          <ac:chgData name="Bryan Sun" userId="851caa7714272873" providerId="LiveId" clId="{1AB4ECCA-9332-41DB-8CB6-28EB9B0FD45E}" dt="2023-09-18T03:23:14.779" v="283" actId="478"/>
-          <ac:graphicFrameMkLst>
-            <pc:docMk/>
-            <pc:sldMk cId="0" sldId="332"/>
-            <ac:graphicFrameMk id="2" creationId="{00000000-0000-0000-0000-000000000000}"/>
-          </ac:graphicFrameMkLst>
-        </pc:graphicFrameChg>
         <pc:graphicFrameChg chg="mod modGraphic">
-          <ac:chgData name="Bryan Sun" userId="851caa7714272873" providerId="LiveId" clId="{1AB4ECCA-9332-41DB-8CB6-28EB9B0FD45E}" dt="2023-09-18T03:34:26.140" v="690" actId="14734"/>
+          <ac:chgData name="Bryan Sun" userId="851caa7714272873" providerId="LiveId" clId="{1DF0C224-3A3E-55A6-A8D1-F8F2208D385B}" dt="2026-08-08T12:10:11.421" v="111" actId="14734"/>
           <ac:graphicFrameMkLst>
             <pc:docMk/>
             <pc:sldMk cId="0" sldId="332"/>
@@ -209,92 +162,38 @@
           </ac:graphicFrameMkLst>
         </pc:graphicFrameChg>
       </pc:sldChg>
-      <pc:sldChg chg="modSp">
-        <pc:chgData name="Bryan Sun" userId="851caa7714272873" providerId="LiveId" clId="{1AB4ECCA-9332-41DB-8CB6-28EB9B0FD45E}" dt="2023-09-18T05:42:49.175" v="1665" actId="20577"/>
-        <pc:sldMkLst>
-          <pc:docMk/>
-          <pc:sldMk cId="0" sldId="334"/>
-        </pc:sldMkLst>
-        <pc:spChg chg="mod">
-          <ac:chgData name="Bryan Sun" userId="851caa7714272873" providerId="LiveId" clId="{1AB4ECCA-9332-41DB-8CB6-28EB9B0FD45E}" dt="2023-09-18T05:42:49.175" v="1665" actId="20577"/>
-          <ac:spMkLst>
-            <pc:docMk/>
-            <pc:sldMk cId="0" sldId="334"/>
-            <ac:spMk id="9" creationId="{00000000-0000-0000-0000-000000000000}"/>
-          </ac:spMkLst>
-        </pc:spChg>
-      </pc:sldChg>
-      <pc:sldChg chg="delSp modSp mod delAnim">
-        <pc:chgData name="Bryan Sun" userId="851caa7714272873" providerId="LiveId" clId="{1AB4ECCA-9332-41DB-8CB6-28EB9B0FD45E}" dt="2023-09-18T05:40:45.845" v="1562" actId="948"/>
-        <pc:sldMkLst>
-          <pc:docMk/>
-          <pc:sldMk cId="0" sldId="346"/>
-        </pc:sldMkLst>
-        <pc:spChg chg="mod">
-          <ac:chgData name="Bryan Sun" userId="851caa7714272873" providerId="LiveId" clId="{1AB4ECCA-9332-41DB-8CB6-28EB9B0FD45E}" dt="2023-09-18T05:40:20.516" v="1559" actId="404"/>
-          <ac:spMkLst>
-            <pc:docMk/>
-            <pc:sldMk cId="0" sldId="346"/>
-            <ac:spMk id="7" creationId="{00000000-0000-0000-0000-000000000000}"/>
-          </ac:spMkLst>
-        </pc:spChg>
-        <pc:spChg chg="mod">
-          <ac:chgData name="Bryan Sun" userId="851caa7714272873" providerId="LiveId" clId="{1AB4ECCA-9332-41DB-8CB6-28EB9B0FD45E}" dt="2023-09-18T03:40:22.064" v="1020" actId="14100"/>
-          <ac:spMkLst>
-            <pc:docMk/>
-            <pc:sldMk cId="0" sldId="346"/>
-            <ac:spMk id="14" creationId="{00000000-0000-0000-0000-000000000000}"/>
-          </ac:spMkLst>
-        </pc:spChg>
-        <pc:graphicFrameChg chg="del">
-          <ac:chgData name="Bryan Sun" userId="851caa7714272873" providerId="LiveId" clId="{1AB4ECCA-9332-41DB-8CB6-28EB9B0FD45E}" dt="2023-09-18T03:40:18.045" v="1019" actId="478"/>
-          <ac:graphicFrameMkLst>
-            <pc:docMk/>
-            <pc:sldMk cId="0" sldId="346"/>
-            <ac:graphicFrameMk id="2" creationId="{00000000-0000-0000-0000-000000000000}"/>
-          </ac:graphicFrameMkLst>
-        </pc:graphicFrameChg>
-        <pc:graphicFrameChg chg="mod modGraphic">
-          <ac:chgData name="Bryan Sun" userId="851caa7714272873" providerId="LiveId" clId="{1AB4ECCA-9332-41DB-8CB6-28EB9B0FD45E}" dt="2023-09-18T05:40:45.845" v="1562" actId="948"/>
-          <ac:graphicFrameMkLst>
-            <pc:docMk/>
-            <pc:sldMk cId="0" sldId="346"/>
-            <ac:graphicFrameMk id="13" creationId="{00000000-0000-0000-0000-000000000000}"/>
-          </ac:graphicFrameMkLst>
-        </pc:graphicFrameChg>
-      </pc:sldChg>
-      <pc:sldChg chg="addSp delSp modSp mod delAnim modAnim">
-        <pc:chgData name="Bryan Sun" userId="851caa7714272873" providerId="LiveId" clId="{1AB4ECCA-9332-41DB-8CB6-28EB9B0FD45E}" dt="2023-09-18T03:20:06.016" v="226" actId="113"/>
+      <pc:sldChg chg="addSp delSp modSp mod">
+        <pc:chgData name="Bryan Sun" userId="851caa7714272873" providerId="LiveId" clId="{1DF0C224-3A3E-55A6-A8D1-F8F2208D385B}" dt="2026-08-08T12:04:12.963" v="66" actId="20577"/>
         <pc:sldMkLst>
           <pc:docMk/>
           <pc:sldMk cId="0" sldId="347"/>
         </pc:sldMkLst>
-        <pc:spChg chg="add mod">
-          <ac:chgData name="Bryan Sun" userId="851caa7714272873" providerId="LiveId" clId="{1AB4ECCA-9332-41DB-8CB6-28EB9B0FD45E}" dt="2023-09-18T03:20:06.016" v="226" actId="113"/>
+        <pc:spChg chg="mod">
+          <ac:chgData name="Bryan Sun" userId="851caa7714272873" providerId="LiveId" clId="{1DF0C224-3A3E-55A6-A8D1-F8F2208D385B}" dt="2026-08-08T12:02:09.449" v="22" actId="2711"/>
           <ac:spMkLst>
             <pc:docMk/>
             <pc:sldMk cId="0" sldId="347"/>
             <ac:spMk id="2" creationId="{44C57198-F243-2509-7F4A-3CC081D6161E}"/>
           </ac:spMkLst>
         </pc:spChg>
+        <pc:spChg chg="add del mod">
+          <ac:chgData name="Bryan Sun" userId="851caa7714272873" providerId="LiveId" clId="{1DF0C224-3A3E-55A6-A8D1-F8F2208D385B}" dt="2026-08-08T12:02:14.479" v="25"/>
+          <ac:spMkLst>
+            <pc:docMk/>
+            <pc:sldMk cId="0" sldId="347"/>
+            <ac:spMk id="3" creationId="{4238FF9E-35DD-B1F2-E7A5-6CCE12B592DE}"/>
+          </ac:spMkLst>
+        </pc:spChg>
         <pc:spChg chg="mod">
-          <ac:chgData name="Bryan Sun" userId="851caa7714272873" providerId="LiveId" clId="{1AB4ECCA-9332-41DB-8CB6-28EB9B0FD45E}" dt="2023-09-18T03:19:01.616" v="182" actId="6549"/>
+          <ac:chgData name="Bryan Sun" userId="851caa7714272873" providerId="LiveId" clId="{1DF0C224-3A3E-55A6-A8D1-F8F2208D385B}" dt="2026-08-08T12:04:12.963" v="66" actId="20577"/>
           <ac:spMkLst>
             <pc:docMk/>
             <pc:sldMk cId="0" sldId="347"/>
             <ac:spMk id="4" creationId="{00000000-0000-0000-0000-000000000000}"/>
           </ac:spMkLst>
         </pc:spChg>
-        <pc:spChg chg="del">
-          <ac:chgData name="Bryan Sun" userId="851caa7714272873" providerId="LiveId" clId="{1AB4ECCA-9332-41DB-8CB6-28EB9B0FD45E}" dt="2023-09-18T03:19:57.607" v="224" actId="478"/>
-          <ac:spMkLst>
-            <pc:docMk/>
-            <pc:sldMk cId="0" sldId="347"/>
-            <ac:spMk id="7" creationId="{00000000-0000-0000-0000-000000000000}"/>
-          </ac:spMkLst>
-        </pc:spChg>
         <pc:spChg chg="mod">
-          <ac:chgData name="Bryan Sun" userId="851caa7714272873" providerId="LiveId" clId="{1AB4ECCA-9332-41DB-8CB6-28EB9B0FD45E}" dt="2023-09-18T03:18:40.315" v="174" actId="6549"/>
+          <ac:chgData name="Bryan Sun" userId="851caa7714272873" providerId="LiveId" clId="{1DF0C224-3A3E-55A6-A8D1-F8F2208D385B}" dt="2026-08-08T12:04:01.625" v="46" actId="20577"/>
           <ac:spMkLst>
             <pc:docMk/>
             <pc:sldMk cId="0" sldId="347"/>
@@ -302,7 +201,7 @@
           </ac:spMkLst>
         </pc:spChg>
         <pc:spChg chg="mod">
-          <ac:chgData name="Bryan Sun" userId="851caa7714272873" providerId="LiveId" clId="{1AB4ECCA-9332-41DB-8CB6-28EB9B0FD45E}" dt="2023-09-18T03:18:32.284" v="170" actId="20577"/>
+          <ac:chgData name="Bryan Sun" userId="851caa7714272873" providerId="LiveId" clId="{1DF0C224-3A3E-55A6-A8D1-F8F2208D385B}" dt="2026-08-08T12:03:57.804" v="38" actId="20577"/>
           <ac:spMkLst>
             <pc:docMk/>
             <pc:sldMk cId="0" sldId="347"/>
@@ -310,7 +209,7 @@
           </ac:spMkLst>
         </pc:spChg>
         <pc:spChg chg="mod">
-          <ac:chgData name="Bryan Sun" userId="851caa7714272873" providerId="LiveId" clId="{1AB4ECCA-9332-41DB-8CB6-28EB9B0FD45E}" dt="2023-09-18T03:18:08.611" v="164" actId="6549"/>
+          <ac:chgData name="Bryan Sun" userId="851caa7714272873" providerId="LiveId" clId="{1DF0C224-3A3E-55A6-A8D1-F8F2208D385B}" dt="2026-08-08T12:02:09.449" v="22" actId="2711"/>
           <ac:spMkLst>
             <pc:docMk/>
             <pc:sldMk cId="0" sldId="347"/>
@@ -319,13 +218,13 @@
         </pc:spChg>
       </pc:sldChg>
       <pc:sldChg chg="modSp mod">
-        <pc:chgData name="Bryan Sun" userId="851caa7714272873" providerId="LiveId" clId="{1AB4ECCA-9332-41DB-8CB6-28EB9B0FD45E}" dt="2023-09-18T03:20:20.588" v="227" actId="113"/>
+        <pc:chgData name="Bryan Sun" userId="851caa7714272873" providerId="LiveId" clId="{1DF0C224-3A3E-55A6-A8D1-F8F2208D385B}" dt="2026-08-08T12:01:38.886" v="14" actId="20577"/>
         <pc:sldMkLst>
           <pc:docMk/>
           <pc:sldMk cId="0" sldId="348"/>
         </pc:sldMkLst>
         <pc:spChg chg="mod">
-          <ac:chgData name="Bryan Sun" userId="851caa7714272873" providerId="LiveId" clId="{1AB4ECCA-9332-41DB-8CB6-28EB9B0FD45E}" dt="2023-09-18T03:20:20.588" v="227" actId="113"/>
+          <ac:chgData name="Bryan Sun" userId="851caa7714272873" providerId="LiveId" clId="{1DF0C224-3A3E-55A6-A8D1-F8F2208D385B}" dt="2026-08-08T11:54:36.734" v="5" actId="14100"/>
           <ac:spMkLst>
             <pc:docMk/>
             <pc:sldMk cId="0" sldId="348"/>
@@ -333,7 +232,7 @@
           </ac:spMkLst>
         </pc:spChg>
         <pc:spChg chg="mod">
-          <ac:chgData name="Bryan Sun" userId="851caa7714272873" providerId="LiveId" clId="{1AB4ECCA-9332-41DB-8CB6-28EB9B0FD45E}" dt="2023-09-18T03:14:34.044" v="53" actId="20577"/>
+          <ac:chgData name="Bryan Sun" userId="851caa7714272873" providerId="LiveId" clId="{1DF0C224-3A3E-55A6-A8D1-F8F2208D385B}" dt="2026-08-08T11:52:47.946" v="3" actId="1076"/>
           <ac:spMkLst>
             <pc:docMk/>
             <pc:sldMk cId="0" sldId="348"/>
@@ -341,7 +240,7 @@
           </ac:spMkLst>
         </pc:spChg>
         <pc:spChg chg="mod">
-          <ac:chgData name="Bryan Sun" userId="851caa7714272873" providerId="LiveId" clId="{1AB4ECCA-9332-41DB-8CB6-28EB9B0FD45E}" dt="2023-09-18T03:15:06.206" v="69" actId="6549"/>
+          <ac:chgData name="Bryan Sun" userId="851caa7714272873" providerId="LiveId" clId="{1DF0C224-3A3E-55A6-A8D1-F8F2208D385B}" dt="2026-08-08T11:54:34.128" v="4" actId="1076"/>
           <ac:spMkLst>
             <pc:docMk/>
             <pc:sldMk cId="0" sldId="348"/>
@@ -349,7 +248,7 @@
           </ac:spMkLst>
         </pc:spChg>
         <pc:spChg chg="mod">
-          <ac:chgData name="Bryan Sun" userId="851caa7714272873" providerId="LiveId" clId="{1AB4ECCA-9332-41DB-8CB6-28EB9B0FD45E}" dt="2023-09-18T03:14:17.556" v="44" actId="6549"/>
+          <ac:chgData name="Bryan Sun" userId="851caa7714272873" providerId="LiveId" clId="{1DF0C224-3A3E-55A6-A8D1-F8F2208D385B}" dt="2026-08-08T11:52:47.946" v="3" actId="1076"/>
           <ac:spMkLst>
             <pc:docMk/>
             <pc:sldMk cId="0" sldId="348"/>
@@ -357,7 +256,7 @@
           </ac:spMkLst>
         </pc:spChg>
         <pc:spChg chg="mod">
-          <ac:chgData name="Bryan Sun" userId="851caa7714272873" providerId="LiveId" clId="{1AB4ECCA-9332-41DB-8CB6-28EB9B0FD45E}" dt="2023-09-18T02:56:00.913" v="13" actId="20577"/>
+          <ac:chgData name="Bryan Sun" userId="851caa7714272873" providerId="LiveId" clId="{1DF0C224-3A3E-55A6-A8D1-F8F2208D385B}" dt="2026-08-08T12:01:38.886" v="14" actId="20577"/>
           <ac:spMkLst>
             <pc:docMk/>
             <pc:sldMk cId="0" sldId="348"/>
@@ -365,77 +264,14 @@
           </ac:spMkLst>
         </pc:spChg>
       </pc:sldChg>
-      <pc:sldChg chg="modSp mod modAnim">
-        <pc:chgData name="Bryan Sun" userId="851caa7714272873" providerId="LiveId" clId="{1AB4ECCA-9332-41DB-8CB6-28EB9B0FD45E}" dt="2023-09-18T05:48:37.021" v="1828" actId="1076"/>
-        <pc:sldMkLst>
-          <pc:docMk/>
-          <pc:sldMk cId="0" sldId="349"/>
-        </pc:sldMkLst>
-        <pc:spChg chg="mod">
-          <ac:chgData name="Bryan Sun" userId="851caa7714272873" providerId="LiveId" clId="{1AB4ECCA-9332-41DB-8CB6-28EB9B0FD45E}" dt="2023-09-18T02:56:23.175" v="16" actId="27636"/>
-          <ac:spMkLst>
-            <pc:docMk/>
-            <pc:sldMk cId="0" sldId="349"/>
-            <ac:spMk id="3" creationId="{00000000-0000-0000-0000-000000000000}"/>
-          </ac:spMkLst>
-        </pc:spChg>
-        <pc:spChg chg="mod">
-          <ac:chgData name="Bryan Sun" userId="851caa7714272873" providerId="LiveId" clId="{1AB4ECCA-9332-41DB-8CB6-28EB9B0FD45E}" dt="2023-09-18T05:48:26.097" v="1825" actId="14100"/>
-          <ac:spMkLst>
-            <pc:docMk/>
-            <pc:sldMk cId="0" sldId="349"/>
-            <ac:spMk id="4" creationId="{00000000-0000-0000-0000-000000000000}"/>
-          </ac:spMkLst>
-        </pc:spChg>
-        <pc:spChg chg="mod">
-          <ac:chgData name="Bryan Sun" userId="851caa7714272873" providerId="LiveId" clId="{1AB4ECCA-9332-41DB-8CB6-28EB9B0FD45E}" dt="2023-09-18T05:48:33.515" v="1827" actId="14100"/>
-          <ac:spMkLst>
-            <pc:docMk/>
-            <pc:sldMk cId="0" sldId="349"/>
-            <ac:spMk id="5" creationId="{00000000-0000-0000-0000-000000000000}"/>
-          </ac:spMkLst>
-        </pc:spChg>
-        <pc:spChg chg="mod">
-          <ac:chgData name="Bryan Sun" userId="851caa7714272873" providerId="LiveId" clId="{1AB4ECCA-9332-41DB-8CB6-28EB9B0FD45E}" dt="2023-09-18T05:46:15.605" v="1784" actId="6549"/>
-          <ac:spMkLst>
-            <pc:docMk/>
-            <pc:sldMk cId="0" sldId="349"/>
-            <ac:spMk id="7" creationId="{D1C4DA1E-0E27-4278-8937-C18E89BEEB22}"/>
-          </ac:spMkLst>
-        </pc:spChg>
-        <pc:spChg chg="mod">
-          <ac:chgData name="Bryan Sun" userId="851caa7714272873" providerId="LiveId" clId="{1AB4ECCA-9332-41DB-8CB6-28EB9B0FD45E}" dt="2023-09-18T05:46:43.207" v="1815" actId="6549"/>
-          <ac:spMkLst>
-            <pc:docMk/>
-            <pc:sldMk cId="0" sldId="349"/>
-            <ac:spMk id="10" creationId="{316004B2-B87C-47EE-809B-30BE54BA7DC5}"/>
-          </ac:spMkLst>
-        </pc:spChg>
-        <pc:spChg chg="mod">
-          <ac:chgData name="Bryan Sun" userId="851caa7714272873" providerId="LiveId" clId="{1AB4ECCA-9332-41DB-8CB6-28EB9B0FD45E}" dt="2023-09-18T05:47:59.156" v="1818" actId="14100"/>
-          <ac:spMkLst>
-            <pc:docMk/>
-            <pc:sldMk cId="0" sldId="349"/>
-            <ac:spMk id="11" creationId="{6DDE1F6C-50FA-4819-AFF6-1A43AA1917AB}"/>
-          </ac:spMkLst>
-        </pc:spChg>
-        <pc:spChg chg="mod">
-          <ac:chgData name="Bryan Sun" userId="851caa7714272873" providerId="LiveId" clId="{1AB4ECCA-9332-41DB-8CB6-28EB9B0FD45E}" dt="2023-09-18T05:48:37.021" v="1828" actId="1076"/>
-          <ac:spMkLst>
-            <pc:docMk/>
-            <pc:sldMk cId="0" sldId="349"/>
-            <ac:spMk id="13" creationId="{8C3A882D-8799-4F52-997D-B5F263794D0E}"/>
-          </ac:spMkLst>
-        </pc:spChg>
-      </pc:sldChg>
-      <pc:sldChg chg="delSp modSp mod delAnim">
-        <pc:chgData name="Bryan Sun" userId="851caa7714272873" providerId="LiveId" clId="{1AB4ECCA-9332-41DB-8CB6-28EB9B0FD45E}" dt="2023-09-18T03:23:35.469" v="289" actId="14100"/>
+      <pc:sldChg chg="modSp mod">
+        <pc:chgData name="Bryan Sun" userId="851caa7714272873" providerId="LiveId" clId="{1DF0C224-3A3E-55A6-A8D1-F8F2208D385B}" dt="2026-08-08T12:05:53.481" v="99" actId="6549"/>
         <pc:sldMkLst>
           <pc:docMk/>
           <pc:sldMk cId="570729498" sldId="356"/>
         </pc:sldMkLst>
         <pc:spChg chg="mod">
-          <ac:chgData name="Bryan Sun" userId="851caa7714272873" providerId="LiveId" clId="{1AB4ECCA-9332-41DB-8CB6-28EB9B0FD45E}" dt="2023-09-18T03:23:27.540" v="286" actId="403"/>
+          <ac:chgData name="Bryan Sun" userId="851caa7714272873" providerId="LiveId" clId="{1DF0C224-3A3E-55A6-A8D1-F8F2208D385B}" dt="2026-08-08T12:05:01.594" v="69" actId="1076"/>
           <ac:spMkLst>
             <pc:docMk/>
             <pc:sldMk cId="570729498" sldId="356"/>
@@ -443,57 +279,75 @@
           </ac:spMkLst>
         </pc:spChg>
         <pc:spChg chg="mod">
-          <ac:chgData name="Bryan Sun" userId="851caa7714272873" providerId="LiveId" clId="{1AB4ECCA-9332-41DB-8CB6-28EB9B0FD45E}" dt="2023-09-18T03:23:35.469" v="289" actId="14100"/>
+          <ac:chgData name="Bryan Sun" userId="851caa7714272873" providerId="LiveId" clId="{1DF0C224-3A3E-55A6-A8D1-F8F2208D385B}" dt="2026-08-08T12:05:32.900" v="85" actId="20577"/>
           <ac:spMkLst>
             <pc:docMk/>
             <pc:sldMk cId="570729498" sldId="356"/>
-            <ac:spMk id="8" creationId="{00000000-0000-0000-0000-000000000000}"/>
+            <ac:spMk id="9" creationId="{380B6C86-C0F7-4F16-ABAE-9083EACAAFFF}"/>
           </ac:spMkLst>
         </pc:spChg>
-        <pc:graphicFrameChg chg="modGraphic">
-          <ac:chgData name="Bryan Sun" userId="851caa7714272873" providerId="LiveId" clId="{1AB4ECCA-9332-41DB-8CB6-28EB9B0FD45E}" dt="2023-09-18T03:22:21.444" v="282" actId="14100"/>
-          <ac:graphicFrameMkLst>
+        <pc:spChg chg="mod">
+          <ac:chgData name="Bryan Sun" userId="851caa7714272873" providerId="LiveId" clId="{1DF0C224-3A3E-55A6-A8D1-F8F2208D385B}" dt="2026-08-08T12:04:33.953" v="67" actId="2711"/>
+          <ac:spMkLst>
             <pc:docMk/>
             <pc:sldMk cId="570729498" sldId="356"/>
-            <ac:graphicFrameMk id="2" creationId="{00000000-0000-0000-0000-000000000000}"/>
-          </ac:graphicFrameMkLst>
-        </pc:graphicFrameChg>
-        <pc:graphicFrameChg chg="del mod">
-          <ac:chgData name="Bryan Sun" userId="851caa7714272873" providerId="LiveId" clId="{1AB4ECCA-9332-41DB-8CB6-28EB9B0FD45E}" dt="2023-09-18T03:22:06.160" v="278" actId="478"/>
-          <ac:graphicFrameMkLst>
+            <ac:spMk id="11" creationId="{00000000-0000-0000-0000-000000000000}"/>
+          </ac:spMkLst>
+        </pc:spChg>
+        <pc:spChg chg="mod">
+          <ac:chgData name="Bryan Sun" userId="851caa7714272873" providerId="LiveId" clId="{1DF0C224-3A3E-55A6-A8D1-F8F2208D385B}" dt="2026-08-08T12:04:33.953" v="67" actId="2711"/>
+          <ac:spMkLst>
             <pc:docMk/>
             <pc:sldMk cId="570729498" sldId="356"/>
-            <ac:graphicFrameMk id="22" creationId="{34AA7200-EF27-4ED5-AA54-3122F7589EA5}"/>
-          </ac:graphicFrameMkLst>
-        </pc:graphicFrameChg>
-      </pc:sldChg>
-      <pc:sldChg chg="modSp mod">
-        <pc:chgData name="Bryan Sun" userId="851caa7714272873" providerId="LiveId" clId="{1AB4ECCA-9332-41DB-8CB6-28EB9B0FD45E}" dt="2023-09-18T05:43:27.006" v="1685" actId="20577"/>
-        <pc:sldMkLst>
-          <pc:docMk/>
-          <pc:sldMk cId="3967702150" sldId="357"/>
-        </pc:sldMkLst>
+            <ac:spMk id="12" creationId="{7E3B97FB-EFC8-489F-9D40-38E20999FFAF}"/>
+          </ac:spMkLst>
+        </pc:spChg>
         <pc:spChg chg="mod">
-          <ac:chgData name="Bryan Sun" userId="851caa7714272873" providerId="LiveId" clId="{1AB4ECCA-9332-41DB-8CB6-28EB9B0FD45E}" dt="2023-09-18T05:43:27.006" v="1685" actId="20577"/>
+          <ac:chgData name="Bryan Sun" userId="851caa7714272873" providerId="LiveId" clId="{1DF0C224-3A3E-55A6-A8D1-F8F2208D385B}" dt="2026-08-08T12:04:33.953" v="67" actId="2711"/>
           <ac:spMkLst>
             <pc:docMk/>
-            <pc:sldMk cId="3967702150" sldId="357"/>
-            <ac:spMk id="9" creationId="{8F79F9D7-B619-4E66-B6E5-9174630E3410}"/>
+            <pc:sldMk cId="570729498" sldId="356"/>
+            <ac:spMk id="13" creationId="{674E961C-C62D-4535-A492-01D97D8EEB74}"/>
           </ac:spMkLst>
         </pc:spChg>
-      </pc:sldChg>
-      <pc:sldChg chg="modSp mod">
-        <pc:chgData name="Bryan Sun" userId="851caa7714272873" providerId="LiveId" clId="{1AB4ECCA-9332-41DB-8CB6-28EB9B0FD45E}" dt="2023-09-18T05:44:13.710" v="1703" actId="20577"/>
-        <pc:sldMkLst>
-          <pc:docMk/>
-          <pc:sldMk cId="3205945023" sldId="358"/>
-        </pc:sldMkLst>
         <pc:spChg chg="mod">
-          <ac:chgData name="Bryan Sun" userId="851caa7714272873" providerId="LiveId" clId="{1AB4ECCA-9332-41DB-8CB6-28EB9B0FD45E}" dt="2023-09-18T05:44:13.710" v="1703" actId="20577"/>
+          <ac:chgData name="Bryan Sun" userId="851caa7714272873" providerId="LiveId" clId="{1DF0C224-3A3E-55A6-A8D1-F8F2208D385B}" dt="2026-08-08T12:04:33.953" v="67" actId="2711"/>
           <ac:spMkLst>
             <pc:docMk/>
-            <pc:sldMk cId="3205945023" sldId="358"/>
-            <ac:spMk id="9" creationId="{8F79F9D7-B619-4E66-B6E5-9174630E3410}"/>
+            <pc:sldMk cId="570729498" sldId="356"/>
+            <ac:spMk id="14" creationId="{EAB15225-CA85-48EC-AD93-A38367B514F4}"/>
+          </ac:spMkLst>
+        </pc:spChg>
+        <pc:spChg chg="mod">
+          <ac:chgData name="Bryan Sun" userId="851caa7714272873" providerId="LiveId" clId="{1DF0C224-3A3E-55A6-A8D1-F8F2208D385B}" dt="2026-08-08T12:04:33.953" v="67" actId="2711"/>
+          <ac:spMkLst>
+            <pc:docMk/>
+            <pc:sldMk cId="570729498" sldId="356"/>
+            <ac:spMk id="15" creationId="{071208D6-B094-453B-86F3-8DA1BD4DA1F0}"/>
+          </ac:spMkLst>
+        </pc:spChg>
+        <pc:spChg chg="mod">
+          <ac:chgData name="Bryan Sun" userId="851caa7714272873" providerId="LiveId" clId="{1DF0C224-3A3E-55A6-A8D1-F8F2208D385B}" dt="2026-08-08T12:05:53.481" v="99" actId="6549"/>
+          <ac:spMkLst>
+            <pc:docMk/>
+            <pc:sldMk cId="570729498" sldId="356"/>
+            <ac:spMk id="16" creationId="{5614E8B9-6C0E-4F34-B185-13E93B944086}"/>
+          </ac:spMkLst>
+        </pc:spChg>
+        <pc:spChg chg="mod">
+          <ac:chgData name="Bryan Sun" userId="851caa7714272873" providerId="LiveId" clId="{1DF0C224-3A3E-55A6-A8D1-F8F2208D385B}" dt="2026-08-08T12:04:33.953" v="67" actId="2711"/>
+          <ac:spMkLst>
+            <pc:docMk/>
+            <pc:sldMk cId="570729498" sldId="356"/>
+            <ac:spMk id="18" creationId="{2D39150C-2CC9-459E-BB65-A7FC6327A9A1}"/>
+          </ac:spMkLst>
+        </pc:spChg>
+        <pc:spChg chg="mod">
+          <ac:chgData name="Bryan Sun" userId="851caa7714272873" providerId="LiveId" clId="{1DF0C224-3A3E-55A6-A8D1-F8F2208D385B}" dt="2026-08-08T12:04:33.953" v="67" actId="2711"/>
+          <ac:spMkLst>
+            <pc:docMk/>
+            <pc:sldMk cId="570729498" sldId="356"/>
+            <ac:spMk id="20" creationId="{6F29B7EA-E941-4092-8797-C13567BBFEC9}"/>
           </ac:spMkLst>
         </pc:spChg>
       </pc:sldChg>
@@ -602,6 +456,13 @@
               <a:noFill/>
             </a:ln>
           </p:spPr>
+          <p:txBody>
+            <a:bodyPr/>
+            <a:lstStyle/>
+            <a:p>
+              <a:endParaRPr lang="en-AU"/>
+            </a:p>
+          </p:txBody>
         </p:sp>
         <p:sp>
           <p:nvSpPr>
@@ -680,6 +541,13 @@
               <a:noFill/>
             </a:ln>
           </p:spPr>
+          <p:txBody>
+            <a:bodyPr/>
+            <a:lstStyle/>
+            <a:p>
+              <a:endParaRPr lang="en-AU"/>
+            </a:p>
+          </p:txBody>
         </p:sp>
         <p:sp>
           <p:nvSpPr>
@@ -758,6 +626,13 @@
               <a:noFill/>
             </a:ln>
           </p:spPr>
+          <p:txBody>
+            <a:bodyPr/>
+            <a:lstStyle/>
+            <a:p>
+              <a:endParaRPr lang="en-AU"/>
+            </a:p>
+          </p:txBody>
         </p:sp>
         <p:sp>
           <p:nvSpPr>
@@ -780,6 +655,13 @@
               <a:noFill/>
             </a:ln>
           </p:spPr>
+          <p:txBody>
+            <a:bodyPr/>
+            <a:lstStyle/>
+            <a:p>
+              <a:endParaRPr lang="en-AU"/>
+            </a:p>
+          </p:txBody>
         </p:sp>
         <p:sp>
           <p:nvSpPr>
@@ -858,6 +740,13 @@
               <a:noFill/>
             </a:ln>
           </p:spPr>
+          <p:txBody>
+            <a:bodyPr/>
+            <a:lstStyle/>
+            <a:p>
+              <a:endParaRPr lang="en-AU"/>
+            </a:p>
+          </p:txBody>
         </p:sp>
         <p:sp>
           <p:nvSpPr>
@@ -908,6 +797,13 @@
               <a:noFill/>
             </a:ln>
           </p:spPr>
+          <p:txBody>
+            <a:bodyPr/>
+            <a:lstStyle/>
+            <a:p>
+              <a:endParaRPr lang="en-AU"/>
+            </a:p>
+          </p:txBody>
         </p:sp>
         <p:sp>
           <p:nvSpPr>
@@ -958,6 +854,13 @@
               <a:noFill/>
             </a:ln>
           </p:spPr>
+          <p:txBody>
+            <a:bodyPr/>
+            <a:lstStyle/>
+            <a:p>
+              <a:endParaRPr lang="en-AU"/>
+            </a:p>
+          </p:txBody>
         </p:sp>
         <p:sp>
           <p:nvSpPr>
@@ -1036,6 +939,13 @@
               <a:noFill/>
             </a:ln>
           </p:spPr>
+          <p:txBody>
+            <a:bodyPr/>
+            <a:lstStyle/>
+            <a:p>
+              <a:endParaRPr lang="en-AU"/>
+            </a:p>
+          </p:txBody>
         </p:sp>
         <p:sp>
           <p:nvSpPr>
@@ -1086,6 +996,13 @@
               <a:noFill/>
             </a:ln>
           </p:spPr>
+          <p:txBody>
+            <a:bodyPr/>
+            <a:lstStyle/>
+            <a:p>
+              <a:endParaRPr lang="en-AU"/>
+            </a:p>
+          </p:txBody>
         </p:sp>
         <p:sp>
           <p:nvSpPr>
@@ -1136,6 +1053,13 @@
               <a:noFill/>
             </a:ln>
           </p:spPr>
+          <p:txBody>
+            <a:bodyPr/>
+            <a:lstStyle/>
+            <a:p>
+              <a:endParaRPr lang="en-AU"/>
+            </a:p>
+          </p:txBody>
         </p:sp>
         <p:sp>
           <p:nvSpPr>
@@ -1214,6 +1138,13 @@
               <a:noFill/>
             </a:ln>
           </p:spPr>
+          <p:txBody>
+            <a:bodyPr/>
+            <a:lstStyle/>
+            <a:p>
+              <a:endParaRPr lang="en-AU"/>
+            </a:p>
+          </p:txBody>
         </p:sp>
         <p:sp>
           <p:nvSpPr>
@@ -1292,6 +1223,13 @@
               <a:noFill/>
             </a:ln>
           </p:spPr>
+          <p:txBody>
+            <a:bodyPr/>
+            <a:lstStyle/>
+            <a:p>
+              <a:endParaRPr lang="en-AU"/>
+            </a:p>
+          </p:txBody>
         </p:sp>
         <p:sp>
           <p:nvSpPr>
@@ -1342,6 +1280,13 @@
               <a:noFill/>
             </a:ln>
           </p:spPr>
+          <p:txBody>
+            <a:bodyPr/>
+            <a:lstStyle/>
+            <a:p>
+              <a:endParaRPr lang="en-AU"/>
+            </a:p>
+          </p:txBody>
         </p:sp>
         <p:sp>
           <p:nvSpPr>
@@ -1440,6 +1385,13 @@
               <a:noFill/>
             </a:ln>
           </p:spPr>
+          <p:txBody>
+            <a:bodyPr/>
+            <a:lstStyle/>
+            <a:p>
+              <a:endParaRPr lang="en-AU"/>
+            </a:p>
+          </p:txBody>
         </p:sp>
         <p:sp>
           <p:nvSpPr>
@@ -1490,6 +1442,13 @@
               <a:noFill/>
             </a:ln>
           </p:spPr>
+          <p:txBody>
+            <a:bodyPr/>
+            <a:lstStyle/>
+            <a:p>
+              <a:endParaRPr lang="en-AU"/>
+            </a:p>
+          </p:txBody>
         </p:sp>
         <p:sp>
           <p:nvSpPr>
@@ -1568,6 +1527,13 @@
               <a:noFill/>
             </a:ln>
           </p:spPr>
+          <p:txBody>
+            <a:bodyPr/>
+            <a:lstStyle/>
+            <a:p>
+              <a:endParaRPr lang="en-AU"/>
+            </a:p>
+          </p:txBody>
         </p:sp>
         <p:sp>
           <p:nvSpPr>
@@ -1646,6 +1612,13 @@
               <a:noFill/>
             </a:ln>
           </p:spPr>
+          <p:txBody>
+            <a:bodyPr/>
+            <a:lstStyle/>
+            <a:p>
+              <a:endParaRPr lang="en-AU"/>
+            </a:p>
+          </p:txBody>
         </p:sp>
         <p:sp>
           <p:nvSpPr>
@@ -1696,6 +1669,13 @@
               <a:noFill/>
             </a:ln>
           </p:spPr>
+          <p:txBody>
+            <a:bodyPr/>
+            <a:lstStyle/>
+            <a:p>
+              <a:endParaRPr lang="en-AU"/>
+            </a:p>
+          </p:txBody>
         </p:sp>
         <p:sp>
           <p:nvSpPr>
@@ -1774,6 +1754,13 @@
               <a:noFill/>
             </a:ln>
           </p:spPr>
+          <p:txBody>
+            <a:bodyPr/>
+            <a:lstStyle/>
+            <a:p>
+              <a:endParaRPr lang="en-AU"/>
+            </a:p>
+          </p:txBody>
         </p:sp>
         <p:sp>
           <p:nvSpPr>
@@ -1852,6 +1839,13 @@
               <a:noFill/>
             </a:ln>
           </p:spPr>
+          <p:txBody>
+            <a:bodyPr/>
+            <a:lstStyle/>
+            <a:p>
+              <a:endParaRPr lang="en-AU"/>
+            </a:p>
+          </p:txBody>
         </p:sp>
         <p:sp>
           <p:nvSpPr>
@@ -1896,6 +1890,13 @@
               <a:noFill/>
             </a:ln>
           </p:spPr>
+          <p:txBody>
+            <a:bodyPr/>
+            <a:lstStyle/>
+            <a:p>
+              <a:endParaRPr lang="en-AU"/>
+            </a:p>
+          </p:txBody>
         </p:sp>
         <p:sp>
           <p:nvSpPr>
@@ -1974,6 +1975,13 @@
               <a:noFill/>
             </a:ln>
           </p:spPr>
+          <p:txBody>
+            <a:bodyPr/>
+            <a:lstStyle/>
+            <a:p>
+              <a:endParaRPr lang="en-AU"/>
+            </a:p>
+          </p:txBody>
         </p:sp>
         <p:sp>
           <p:nvSpPr>
@@ -2018,6 +2026,13 @@
               <a:noFill/>
             </a:ln>
           </p:spPr>
+          <p:txBody>
+            <a:bodyPr/>
+            <a:lstStyle/>
+            <a:p>
+              <a:endParaRPr lang="en-AU"/>
+            </a:p>
+          </p:txBody>
         </p:sp>
         <p:sp>
           <p:nvSpPr>
@@ -2096,6 +2111,13 @@
               <a:noFill/>
             </a:ln>
           </p:spPr>
+          <p:txBody>
+            <a:bodyPr/>
+            <a:lstStyle/>
+            <a:p>
+              <a:endParaRPr lang="en-AU"/>
+            </a:p>
+          </p:txBody>
         </p:sp>
         <p:sp>
           <p:nvSpPr>
@@ -2152,6 +2174,13 @@
               <a:noFill/>
             </a:ln>
           </p:spPr>
+          <p:txBody>
+            <a:bodyPr/>
+            <a:lstStyle/>
+            <a:p>
+              <a:endParaRPr lang="en-AU"/>
+            </a:p>
+          </p:txBody>
         </p:sp>
         <p:sp>
           <p:nvSpPr>
@@ -2230,6 +2259,13 @@
               <a:noFill/>
             </a:ln>
           </p:spPr>
+          <p:txBody>
+            <a:bodyPr/>
+            <a:lstStyle/>
+            <a:p>
+              <a:endParaRPr lang="en-AU"/>
+            </a:p>
+          </p:txBody>
         </p:sp>
         <p:sp>
           <p:nvSpPr>
@@ -2286,6 +2322,13 @@
               <a:noFill/>
             </a:ln>
           </p:spPr>
+          <p:txBody>
+            <a:bodyPr/>
+            <a:lstStyle/>
+            <a:p>
+              <a:endParaRPr lang="en-AU"/>
+            </a:p>
+          </p:txBody>
         </p:sp>
         <p:sp>
           <p:nvSpPr>
@@ -2364,6 +2407,13 @@
               <a:noFill/>
             </a:ln>
           </p:spPr>
+          <p:txBody>
+            <a:bodyPr/>
+            <a:lstStyle/>
+            <a:p>
+              <a:endParaRPr lang="en-AU"/>
+            </a:p>
+          </p:txBody>
         </p:sp>
         <p:sp>
           <p:nvSpPr>
@@ -2386,6 +2436,13 @@
               <a:noFill/>
             </a:ln>
           </p:spPr>
+          <p:txBody>
+            <a:bodyPr/>
+            <a:lstStyle/>
+            <a:p>
+              <a:endParaRPr lang="en-AU"/>
+            </a:p>
+          </p:txBody>
         </p:sp>
         <p:sp>
           <p:nvSpPr>
@@ -2464,6 +2521,13 @@
               <a:noFill/>
             </a:ln>
           </p:spPr>
+          <p:txBody>
+            <a:bodyPr/>
+            <a:lstStyle/>
+            <a:p>
+              <a:endParaRPr lang="en-AU"/>
+            </a:p>
+          </p:txBody>
         </p:sp>
         <p:sp>
           <p:nvSpPr>
@@ -2514,6 +2578,13 @@
               <a:noFill/>
             </a:ln>
           </p:spPr>
+          <p:txBody>
+            <a:bodyPr/>
+            <a:lstStyle/>
+            <a:p>
+              <a:endParaRPr lang="en-AU"/>
+            </a:p>
+          </p:txBody>
         </p:sp>
         <p:sp>
           <p:nvSpPr>
@@ -2564,6 +2635,13 @@
               <a:noFill/>
             </a:ln>
           </p:spPr>
+          <p:txBody>
+            <a:bodyPr/>
+            <a:lstStyle/>
+            <a:p>
+              <a:endParaRPr lang="en-AU"/>
+            </a:p>
+          </p:txBody>
         </p:sp>
         <p:sp>
           <p:nvSpPr>
@@ -2642,6 +2720,13 @@
               <a:noFill/>
             </a:ln>
           </p:spPr>
+          <p:txBody>
+            <a:bodyPr/>
+            <a:lstStyle/>
+            <a:p>
+              <a:endParaRPr lang="en-AU"/>
+            </a:p>
+          </p:txBody>
         </p:sp>
         <p:sp>
           <p:nvSpPr>
@@ -2698,6 +2783,13 @@
               <a:noFill/>
             </a:ln>
           </p:spPr>
+          <p:txBody>
+            <a:bodyPr/>
+            <a:lstStyle/>
+            <a:p>
+              <a:endParaRPr lang="en-AU"/>
+            </a:p>
+          </p:txBody>
         </p:sp>
         <p:sp>
           <p:nvSpPr>
@@ -2748,6 +2840,13 @@
               <a:noFill/>
             </a:ln>
           </p:spPr>
+          <p:txBody>
+            <a:bodyPr/>
+            <a:lstStyle/>
+            <a:p>
+              <a:endParaRPr lang="en-AU"/>
+            </a:p>
+          </p:txBody>
         </p:sp>
         <p:sp>
           <p:nvSpPr>
@@ -2826,6 +2925,13 @@
               <a:noFill/>
             </a:ln>
           </p:spPr>
+          <p:txBody>
+            <a:bodyPr/>
+            <a:lstStyle/>
+            <a:p>
+              <a:endParaRPr lang="en-AU"/>
+            </a:p>
+          </p:txBody>
         </p:sp>
         <p:sp>
           <p:nvSpPr>
@@ -2876,6 +2982,13 @@
               <a:noFill/>
             </a:ln>
           </p:spPr>
+          <p:txBody>
+            <a:bodyPr/>
+            <a:lstStyle/>
+            <a:p>
+              <a:endParaRPr lang="en-AU"/>
+            </a:p>
+          </p:txBody>
         </p:sp>
         <p:sp>
           <p:nvSpPr>
@@ -2954,6 +3067,13 @@
               <a:noFill/>
             </a:ln>
           </p:spPr>
+          <p:txBody>
+            <a:bodyPr/>
+            <a:lstStyle/>
+            <a:p>
+              <a:endParaRPr lang="en-AU"/>
+            </a:p>
+          </p:txBody>
         </p:sp>
         <p:sp>
           <p:nvSpPr>
@@ -3004,6 +3124,13 @@
               <a:noFill/>
             </a:ln>
           </p:spPr>
+          <p:txBody>
+            <a:bodyPr/>
+            <a:lstStyle/>
+            <a:p>
+              <a:endParaRPr lang="en-AU"/>
+            </a:p>
+          </p:txBody>
         </p:sp>
         <p:sp>
           <p:nvSpPr>
@@ -3082,6 +3209,13 @@
               <a:noFill/>
             </a:ln>
           </p:spPr>
+          <p:txBody>
+            <a:bodyPr/>
+            <a:lstStyle/>
+            <a:p>
+              <a:endParaRPr lang="en-AU"/>
+            </a:p>
+          </p:txBody>
         </p:sp>
         <p:sp>
           <p:nvSpPr>
@@ -3104,6 +3238,13 @@
               <a:noFill/>
             </a:ln>
           </p:spPr>
+          <p:txBody>
+            <a:bodyPr/>
+            <a:lstStyle/>
+            <a:p>
+              <a:endParaRPr lang="en-AU"/>
+            </a:p>
+          </p:txBody>
         </p:sp>
         <p:sp>
           <p:nvSpPr>
@@ -3157,6 +3298,13 @@
               <a:noFill/>
             </a:ln>
           </p:spPr>
+          <p:txBody>
+            <a:bodyPr/>
+            <a:lstStyle/>
+            <a:p>
+              <a:endParaRPr lang="en-AU"/>
+            </a:p>
+          </p:txBody>
         </p:sp>
         <p:sp>
           <p:nvSpPr>
@@ -3235,6 +3383,13 @@
               <a:noFill/>
             </a:ln>
           </p:spPr>
+          <p:txBody>
+            <a:bodyPr/>
+            <a:lstStyle/>
+            <a:p>
+              <a:endParaRPr lang="en-AU"/>
+            </a:p>
+          </p:txBody>
         </p:sp>
         <p:sp>
           <p:nvSpPr>
@@ -3285,6 +3440,13 @@
               <a:noFill/>
             </a:ln>
           </p:spPr>
+          <p:txBody>
+            <a:bodyPr/>
+            <a:lstStyle/>
+            <a:p>
+              <a:endParaRPr lang="en-AU"/>
+            </a:p>
+          </p:txBody>
         </p:sp>
         <p:sp>
           <p:nvSpPr>
@@ -3363,6 +3525,13 @@
               <a:noFill/>
             </a:ln>
           </p:spPr>
+          <p:txBody>
+            <a:bodyPr/>
+            <a:lstStyle/>
+            <a:p>
+              <a:endParaRPr lang="en-AU"/>
+            </a:p>
+          </p:txBody>
         </p:sp>
         <p:sp>
           <p:nvSpPr>
@@ -3441,6 +3610,13 @@
               <a:noFill/>
             </a:ln>
           </p:spPr>
+          <p:txBody>
+            <a:bodyPr/>
+            <a:lstStyle/>
+            <a:p>
+              <a:endParaRPr lang="en-AU"/>
+            </a:p>
+          </p:txBody>
         </p:sp>
         <p:sp>
           <p:nvSpPr>
@@ -3494,6 +3670,13 @@
               <a:noFill/>
             </a:ln>
           </p:spPr>
+          <p:txBody>
+            <a:bodyPr/>
+            <a:lstStyle/>
+            <a:p>
+              <a:endParaRPr lang="en-AU"/>
+            </a:p>
+          </p:txBody>
         </p:sp>
         <p:sp>
           <p:nvSpPr>
@@ -3544,6 +3727,13 @@
               <a:noFill/>
             </a:ln>
           </p:spPr>
+          <p:txBody>
+            <a:bodyPr/>
+            <a:lstStyle/>
+            <a:p>
+              <a:endParaRPr lang="en-AU"/>
+            </a:p>
+          </p:txBody>
         </p:sp>
         <p:sp>
           <p:nvSpPr>
@@ -3622,6 +3812,13 @@
               <a:noFill/>
             </a:ln>
           </p:spPr>
+          <p:txBody>
+            <a:bodyPr/>
+            <a:lstStyle/>
+            <a:p>
+              <a:endParaRPr lang="en-AU"/>
+            </a:p>
+          </p:txBody>
         </p:sp>
         <p:sp>
           <p:nvSpPr>
@@ -3700,6 +3897,13 @@
               <a:noFill/>
             </a:ln>
           </p:spPr>
+          <p:txBody>
+            <a:bodyPr/>
+            <a:lstStyle/>
+            <a:p>
+              <a:endParaRPr lang="en-AU"/>
+            </a:p>
+          </p:txBody>
         </p:sp>
         <p:sp>
           <p:nvSpPr>
@@ -3750,6 +3954,13 @@
               <a:noFill/>
             </a:ln>
           </p:spPr>
+          <p:txBody>
+            <a:bodyPr/>
+            <a:lstStyle/>
+            <a:p>
+              <a:endParaRPr lang="en-AU"/>
+            </a:p>
+          </p:txBody>
         </p:sp>
         <p:sp>
           <p:nvSpPr>
@@ -3858,6 +4069,13 @@
               <a:noFill/>
             </a:ln>
           </p:spPr>
+          <p:txBody>
+            <a:bodyPr/>
+            <a:lstStyle/>
+            <a:p>
+              <a:endParaRPr lang="en-AU"/>
+            </a:p>
+          </p:txBody>
         </p:sp>
         <p:sp>
           <p:nvSpPr>
@@ -3914,6 +4132,13 @@
               <a:noFill/>
             </a:ln>
           </p:spPr>
+          <p:txBody>
+            <a:bodyPr/>
+            <a:lstStyle/>
+            <a:p>
+              <a:endParaRPr lang="en-AU"/>
+            </a:p>
+          </p:txBody>
         </p:sp>
         <p:sp>
           <p:nvSpPr>
@@ -3992,6 +4217,13 @@
               <a:noFill/>
             </a:ln>
           </p:spPr>
+          <p:txBody>
+            <a:bodyPr/>
+            <a:lstStyle/>
+            <a:p>
+              <a:endParaRPr lang="en-AU"/>
+            </a:p>
+          </p:txBody>
         </p:sp>
       </p:grpSp>
       <p:sp>
@@ -4124,7 +4356,7 @@
           <a:p>
             <a:fld id="{48A87A34-81AB-432B-8DAE-1953F412C126}" type="datetimeFigureOut">
               <a:rPr lang="en-US" dirty="0"/>
-              <a:t>9/18/2023</a:t>
+              <a:t>8/8/26</a:t>
             </a:fld>
             <a:endParaRPr lang="en-US" dirty="0"/>
           </a:p>
@@ -4400,7 +4632,7 @@
           <a:p>
             <a:fld id="{48A87A34-81AB-432B-8DAE-1953F412C126}" type="datetimeFigureOut">
               <a:rPr lang="en-US" dirty="0"/>
-              <a:t>9/18/2023</a:t>
+              <a:t>8/8/26</a:t>
             </a:fld>
             <a:endParaRPr lang="en-US" dirty="0"/>
           </a:p>
@@ -4615,7 +4847,7 @@
           <a:p>
             <a:fld id="{48A87A34-81AB-432B-8DAE-1953F412C126}" type="datetimeFigureOut">
               <a:rPr lang="en-US" dirty="0"/>
-              <a:t>9/18/2023</a:t>
+              <a:t>8/8/26</a:t>
             </a:fld>
             <a:endParaRPr lang="en-US" dirty="0"/>
           </a:p>
@@ -4897,7 +5129,7 @@
           <a:p>
             <a:fld id="{48A87A34-81AB-432B-8DAE-1953F412C126}" type="datetimeFigureOut">
               <a:rPr lang="en-US" dirty="0"/>
-              <a:t>9/18/2023</a:t>
+              <a:t>8/8/26</a:t>
             </a:fld>
             <a:endParaRPr lang="en-US" dirty="0"/>
           </a:p>
@@ -5350,7 +5582,7 @@
           <a:p>
             <a:fld id="{48A87A34-81AB-432B-8DAE-1953F412C126}" type="datetimeFigureOut">
               <a:rPr lang="en-US" dirty="0"/>
-              <a:t>9/18/2023</a:t>
+              <a:t>8/8/26</a:t>
             </a:fld>
             <a:endParaRPr lang="en-US" dirty="0"/>
           </a:p>
@@ -5915,7 +6147,7 @@
           <a:p>
             <a:fld id="{48A87A34-81AB-432B-8DAE-1953F412C126}" type="datetimeFigureOut">
               <a:rPr lang="en-US" dirty="0"/>
-              <a:t>9/18/2023</a:t>
+              <a:t>8/8/26</a:t>
             </a:fld>
             <a:endParaRPr lang="en-US" dirty="0"/>
           </a:p>
@@ -6654,7 +6886,7 @@
           <a:p>
             <a:fld id="{48A87A34-81AB-432B-8DAE-1953F412C126}" type="datetimeFigureOut">
               <a:rPr lang="en-US" dirty="0"/>
-              <a:t>9/18/2023</a:t>
+              <a:t>8/8/26</a:t>
             </a:fld>
             <a:endParaRPr lang="en-US" dirty="0"/>
           </a:p>
@@ -6843,7 +7075,7 @@
           <a:p>
             <a:fld id="{48A87A34-81AB-432B-8DAE-1953F412C126}" type="datetimeFigureOut">
               <a:rPr lang="en-US" dirty="0"/>
-              <a:t>9/18/2023</a:t>
+              <a:t>8/8/26</a:t>
             </a:fld>
             <a:endParaRPr lang="en-US" dirty="0"/>
           </a:p>
@@ -7042,7 +7274,7 @@
           <a:p>
             <a:fld id="{48A87A34-81AB-432B-8DAE-1953F412C126}" type="datetimeFigureOut">
               <a:rPr lang="en-US" dirty="0"/>
-              <a:t>9/18/2023</a:t>
+              <a:t>8/8/26</a:t>
             </a:fld>
             <a:endParaRPr lang="en-US" dirty="0"/>
           </a:p>
@@ -7231,7 +7463,7 @@
           <a:p>
             <a:fld id="{48A87A34-81AB-432B-8DAE-1953F412C126}" type="datetimeFigureOut">
               <a:rPr lang="en-US" dirty="0"/>
-              <a:t>9/18/2023</a:t>
+              <a:t>8/8/26</a:t>
             </a:fld>
             <a:endParaRPr lang="en-US" dirty="0"/>
           </a:p>
@@ -7500,7 +7732,7 @@
           <a:p>
             <a:fld id="{48A87A34-81AB-432B-8DAE-1953F412C126}" type="datetimeFigureOut">
               <a:rPr lang="en-US" dirty="0"/>
-              <a:t>9/18/2023</a:t>
+              <a:t>8/8/26</a:t>
             </a:fld>
             <a:endParaRPr lang="en-US" dirty="0"/>
           </a:p>
@@ -7751,7 +7983,7 @@
           <a:p>
             <a:fld id="{48A87A34-81AB-432B-8DAE-1953F412C126}" type="datetimeFigureOut">
               <a:rPr lang="en-US" dirty="0"/>
-              <a:t>9/18/2023</a:t>
+              <a:t>8/8/26</a:t>
             </a:fld>
             <a:endParaRPr lang="en-US" dirty="0"/>
           </a:p>
@@ -8151,7 +8383,7 @@
           <a:p>
             <a:fld id="{48A87A34-81AB-432B-8DAE-1953F412C126}" type="datetimeFigureOut">
               <a:rPr lang="en-US" dirty="0"/>
-              <a:t>9/18/2023</a:t>
+              <a:t>8/8/26</a:t>
             </a:fld>
             <a:endParaRPr lang="en-US" dirty="0"/>
           </a:p>
@@ -8288,7 +8520,7 @@
           <a:p>
             <a:fld id="{48A87A34-81AB-432B-8DAE-1953F412C126}" type="datetimeFigureOut">
               <a:rPr lang="en-US" dirty="0"/>
-              <a:t>9/18/2023</a:t>
+              <a:t>8/8/26</a:t>
             </a:fld>
             <a:endParaRPr lang="en-US" dirty="0"/>
           </a:p>
@@ -8402,7 +8634,7 @@
           <a:p>
             <a:fld id="{48A87A34-81AB-432B-8DAE-1953F412C126}" type="datetimeFigureOut">
               <a:rPr lang="en-US" dirty="0"/>
-              <a:t>9/18/2023</a:t>
+              <a:t>8/8/26</a:t>
             </a:fld>
             <a:endParaRPr lang="en-US" dirty="0"/>
           </a:p>
@@ -8670,7 +8902,7 @@
           <a:p>
             <a:fld id="{48A87A34-81AB-432B-8DAE-1953F412C126}" type="datetimeFigureOut">
               <a:rPr lang="en-US" dirty="0"/>
-              <a:t>9/18/2023</a:t>
+              <a:t>8/8/26</a:t>
             </a:fld>
             <a:endParaRPr lang="en-US" dirty="0"/>
           </a:p>
@@ -8969,7 +9201,7 @@
           <a:p>
             <a:fld id="{48A87A34-81AB-432B-8DAE-1953F412C126}" type="datetimeFigureOut">
               <a:rPr lang="en-US" dirty="0"/>
-              <a:t>9/18/2023</a:t>
+              <a:t>8/8/26</a:t>
             </a:fld>
             <a:endParaRPr lang="en-US" dirty="0"/>
           </a:p>
@@ -12044,8 +12276,8 @@
         </p:nvSpPr>
         <p:spPr>
           <a:xfrm>
-            <a:off x="6160899" y="1486111"/>
-            <a:ext cx="5030732" cy="4484754"/>
+            <a:off x="6712527" y="1486111"/>
+            <a:ext cx="4479104" cy="3750129"/>
           </a:xfrm>
           <a:prstGeom prst="rect">
             <a:avLst/>
@@ -12073,7 +12305,7 @@
                 <a:solidFill>
                   <a:schemeClr val="bg1"/>
                 </a:solidFill>
-                <a:latin typeface="Consolas" panose="020B0609020204030204" pitchFamily="49" charset="0"/>
+                <a:latin typeface="Aptos Display" panose="020B0004020202020204" pitchFamily="34" charset="0"/>
                 <a:ea typeface="微软雅黑" panose="020B0503020204020204" pitchFamily="34" charset="-122"/>
                 <a:cs typeface="Consolas" panose="020B0609020204030204" pitchFamily="49" charset="0"/>
               </a:rPr>
@@ -12092,11 +12324,11 @@
               <a:buAutoNum type="arabicPeriod"/>
             </a:pPr>
             <a:r>
-              <a:rPr lang="en" altLang="zh-CN" sz="1600" b="1" dirty="0">
+              <a:rPr lang="en" altLang="zh-CN" sz="1600" dirty="0">
                 <a:solidFill>
                   <a:srgbClr val="006699"/>
                 </a:solidFill>
-                <a:latin typeface="Consolas" panose="020B0609020204030204" pitchFamily="49" charset="0"/>
+                <a:latin typeface="Aptos Display" panose="020B0004020202020204" pitchFamily="34" charset="0"/>
                 <a:ea typeface="微软雅黑" panose="020B0503020204020204" pitchFamily="34" charset="-122"/>
                 <a:cs typeface="Consolas" panose="020B0609020204030204" pitchFamily="49" charset="0"/>
                 <a:sym typeface="+mn-ea"/>
@@ -12108,7 +12340,7 @@
                 <a:solidFill>
                   <a:schemeClr val="bg1"/>
                 </a:solidFill>
-                <a:latin typeface="Consolas" panose="020B0609020204030204" pitchFamily="49" charset="0"/>
+                <a:latin typeface="Aptos Display" panose="020B0004020202020204" pitchFamily="34" charset="0"/>
                 <a:ea typeface="微软雅黑" panose="020B0503020204020204" pitchFamily="34" charset="-122"/>
                 <a:cs typeface="Consolas" panose="020B0609020204030204" pitchFamily="49" charset="0"/>
               </a:rPr>
@@ -12131,18 +12363,18 @@
                 <a:solidFill>
                   <a:schemeClr val="bg1"/>
                 </a:solidFill>
-                <a:latin typeface="Consolas" panose="020B0609020204030204" pitchFamily="49" charset="0"/>
+                <a:latin typeface="Aptos Display" panose="020B0004020202020204" pitchFamily="34" charset="0"/>
                 <a:ea typeface="微软雅黑" panose="020B0503020204020204" pitchFamily="34" charset="-122"/>
                 <a:cs typeface="Consolas" panose="020B0609020204030204" pitchFamily="49" charset="0"/>
               </a:rPr>
               <a:t>An </a:t>
             </a:r>
             <a:r>
-              <a:rPr lang="en" altLang="zh-CN" sz="1600" b="1" dirty="0">
+              <a:rPr lang="en" altLang="zh-CN" sz="1600" dirty="0">
                 <a:solidFill>
                   <a:srgbClr val="006699"/>
                 </a:solidFill>
-                <a:latin typeface="Consolas" panose="020B0609020204030204" pitchFamily="49" charset="0"/>
+                <a:latin typeface="Aptos Display" panose="020B0004020202020204" pitchFamily="34" charset="0"/>
                 <a:ea typeface="微软雅黑" panose="020B0503020204020204" pitchFamily="34" charset="-122"/>
                 <a:cs typeface="Consolas" panose="020B0609020204030204" pitchFamily="49" charset="0"/>
                 <a:sym typeface="+mn-ea"/>
@@ -12154,18 +12386,18 @@
                 <a:solidFill>
                   <a:schemeClr val="bg1"/>
                 </a:solidFill>
-                <a:latin typeface="Consolas" panose="020B0609020204030204" pitchFamily="49" charset="0"/>
+                <a:latin typeface="Aptos Display" panose="020B0004020202020204" pitchFamily="34" charset="0"/>
                 <a:ea typeface="微软雅黑" panose="020B0503020204020204" pitchFamily="34" charset="-122"/>
                 <a:cs typeface="Consolas" panose="020B0609020204030204" pitchFamily="49" charset="0"/>
               </a:rPr>
               <a:t>can only pair with one </a:t>
             </a:r>
             <a:r>
-              <a:rPr lang="en" altLang="zh-CN" sz="1600" b="1" dirty="0">
+              <a:rPr lang="en" altLang="zh-CN" sz="1600" dirty="0">
                 <a:solidFill>
                   <a:srgbClr val="006699"/>
                 </a:solidFill>
-                <a:latin typeface="Consolas" panose="020B0609020204030204" pitchFamily="49" charset="0"/>
+                <a:latin typeface="Aptos Display" panose="020B0004020202020204" pitchFamily="34" charset="0"/>
                 <a:ea typeface="微软雅黑" panose="020B0503020204020204" pitchFamily="34" charset="-122"/>
                 <a:cs typeface="Consolas" panose="020B0609020204030204" pitchFamily="49" charset="0"/>
                 <a:sym typeface="+mn-ea"/>
@@ -12177,7 +12409,7 @@
                 <a:solidFill>
                   <a:schemeClr val="bg1"/>
                 </a:solidFill>
-                <a:latin typeface="Consolas" panose="020B0609020204030204" pitchFamily="49" charset="0"/>
+                <a:latin typeface="Aptos Display" panose="020B0004020202020204" pitchFamily="34" charset="0"/>
                 <a:ea typeface="微软雅黑" panose="020B0503020204020204" pitchFamily="34" charset="-122"/>
                 <a:cs typeface="Consolas" panose="020B0609020204030204" pitchFamily="49" charset="0"/>
               </a:rPr>
@@ -12187,7 +12419,7 @@
               <a:solidFill>
                 <a:schemeClr val="bg1"/>
               </a:solidFill>
-              <a:latin typeface="Consolas" panose="020B0609020204030204" pitchFamily="49" charset="0"/>
+              <a:latin typeface="Aptos Display" panose="020B0004020202020204" pitchFamily="34" charset="0"/>
               <a:ea typeface="微软雅黑" panose="020B0503020204020204" pitchFamily="34" charset="-122"/>
               <a:cs typeface="Consolas" panose="020B0609020204030204" pitchFamily="49" charset="0"/>
             </a:endParaRPr>
@@ -12204,11 +12436,11 @@
               <a:buAutoNum type="arabicPeriod"/>
             </a:pPr>
             <a:r>
-              <a:rPr lang="en" altLang="zh-CN" sz="1600" b="1" dirty="0">
+              <a:rPr lang="en" altLang="zh-CN" sz="1600" dirty="0">
                 <a:solidFill>
                   <a:srgbClr val="006699"/>
                 </a:solidFill>
-                <a:latin typeface="Consolas" panose="020B0609020204030204" pitchFamily="49" charset="0"/>
+                <a:latin typeface="Aptos Display" panose="020B0004020202020204" pitchFamily="34" charset="0"/>
                 <a:ea typeface="微软雅黑" panose="020B0503020204020204" pitchFamily="34" charset="-122"/>
                 <a:cs typeface="Consolas" panose="020B0609020204030204" pitchFamily="49" charset="0"/>
                 <a:sym typeface="+mn-ea"/>
@@ -12220,7 +12452,7 @@
                 <a:solidFill>
                   <a:schemeClr val="bg1"/>
                 </a:solidFill>
-                <a:latin typeface="Consolas" panose="020B0609020204030204" pitchFamily="49" charset="0"/>
+                <a:latin typeface="Aptos Display" panose="020B0004020202020204" pitchFamily="34" charset="0"/>
                 <a:ea typeface="微软雅黑" panose="020B0503020204020204" pitchFamily="34" charset="-122"/>
                 <a:cs typeface="Consolas" panose="020B0609020204030204" pitchFamily="49" charset="0"/>
               </a:rPr>
@@ -12230,7 +12462,7 @@
               <a:solidFill>
                 <a:schemeClr val="bg1"/>
               </a:solidFill>
-              <a:latin typeface="Consolas" panose="020B0609020204030204" pitchFamily="49" charset="0"/>
+              <a:latin typeface="Aptos Display" panose="020B0004020202020204" pitchFamily="34" charset="0"/>
               <a:ea typeface="微软雅黑" panose="020B0503020204020204" pitchFamily="34" charset="-122"/>
               <a:cs typeface="Consolas" panose="020B0609020204030204" pitchFamily="49" charset="0"/>
             </a:endParaRPr>
@@ -12251,40 +12483,29 @@
                 <a:solidFill>
                   <a:schemeClr val="bg1"/>
                 </a:solidFill>
-                <a:latin typeface="Consolas" panose="020B0609020204030204" pitchFamily="49" charset="0"/>
+                <a:latin typeface="Aptos Display" panose="020B0004020202020204" pitchFamily="34" charset="0"/>
                 <a:ea typeface="微软雅黑" panose="020B0503020204020204" pitchFamily="34" charset="-122"/>
                 <a:cs typeface="Consolas" panose="020B0609020204030204" pitchFamily="49" charset="0"/>
               </a:rPr>
               <a:t>You cannot write </a:t>
             </a:r>
             <a:r>
-              <a:rPr lang="en" altLang="zh-CN" sz="1600" b="1" kern="100" dirty="0">
+              <a:rPr lang="en" altLang="zh-CN" sz="1600" kern="100" dirty="0">
                 <a:solidFill>
                   <a:schemeClr val="bg1"/>
                 </a:solidFill>
-                <a:latin typeface="Consolas" panose="020B0609020204030204" pitchFamily="49" charset="0"/>
-                <a:ea typeface="微软雅黑" panose="020B0503020204020204" pitchFamily="34" charset="-122"/>
-                <a:cs typeface="Consolas" panose="020B0609020204030204" pitchFamily="49" charset="0"/>
-              </a:rPr>
-              <a:t>(expression)</a:t>
-            </a:r>
-            <a:r>
-              <a:rPr lang="en" altLang="zh-CN" sz="1600" kern="100" dirty="0">
-                <a:solidFill>
-                  <a:schemeClr val="bg1"/>
-                </a:solidFill>
-                <a:latin typeface="Consolas" panose="020B0609020204030204" pitchFamily="49" charset="0"/>
-                <a:ea typeface="微软雅黑" panose="020B0503020204020204" pitchFamily="34" charset="-122"/>
-                <a:cs typeface="Consolas" panose="020B0609020204030204" pitchFamily="49" charset="0"/>
-              </a:rPr>
-              <a:t> after </a:t>
-            </a:r>
-            <a:r>
-              <a:rPr lang="en" altLang="zh-CN" sz="1600" b="1" dirty="0">
+                <a:latin typeface="Aptos Display" panose="020B0004020202020204" pitchFamily="34" charset="0"/>
+                <a:ea typeface="微软雅黑" panose="020B0503020204020204" pitchFamily="34" charset="-122"/>
+                <a:cs typeface="Consolas" panose="020B0609020204030204" pitchFamily="49" charset="0"/>
+              </a:rPr>
+              <a:t>(expression) after </a:t>
+            </a:r>
+            <a:r>
+              <a:rPr lang="en" altLang="zh-CN" sz="1600" dirty="0">
                 <a:solidFill>
                   <a:srgbClr val="006699"/>
                 </a:solidFill>
-                <a:latin typeface="Consolas" panose="020B0609020204030204" pitchFamily="49" charset="0"/>
+                <a:latin typeface="Aptos Display" panose="020B0004020202020204" pitchFamily="34" charset="0"/>
                 <a:ea typeface="微软雅黑" panose="020B0503020204020204" pitchFamily="34" charset="-122"/>
                 <a:cs typeface="Consolas" panose="020B0609020204030204" pitchFamily="49" charset="0"/>
                 <a:sym typeface="+mn-ea"/>
@@ -12295,7 +12516,7 @@
               <a:solidFill>
                 <a:schemeClr val="bg1"/>
               </a:solidFill>
-              <a:latin typeface="Consolas" panose="020B0609020204030204" pitchFamily="49" charset="0"/>
+              <a:latin typeface="Aptos Display" panose="020B0004020202020204" pitchFamily="34" charset="0"/>
               <a:ea typeface="微软雅黑" panose="020B0503020204020204" pitchFamily="34" charset="-122"/>
               <a:cs typeface="Consolas" panose="020B0609020204030204" pitchFamily="49" charset="0"/>
             </a:endParaRPr>
@@ -12316,52 +12537,30 @@
                 <a:solidFill>
                   <a:schemeClr val="bg1"/>
                 </a:solidFill>
-                <a:latin typeface="Consolas" panose="020B0609020204030204" pitchFamily="49" charset="0"/>
-                <a:ea typeface="微软雅黑" panose="020B0503020204020204" pitchFamily="34" charset="-122"/>
-                <a:cs typeface="Consolas" panose="020B0609020204030204" pitchFamily="49" charset="0"/>
-              </a:rPr>
-              <a:t>Never add semicolon after if</a:t>
-            </a:r>
-            <a:r>
-              <a:rPr lang="en" altLang="zh-CN" sz="1600" b="1" kern="100" dirty="0">
+                <a:latin typeface="Aptos Display" panose="020B0004020202020204" pitchFamily="34" charset="0"/>
+                <a:ea typeface="微软雅黑" panose="020B0503020204020204" pitchFamily="34" charset="-122"/>
+                <a:cs typeface="Consolas" panose="020B0609020204030204" pitchFamily="49" charset="0"/>
+              </a:rPr>
+              <a:t>Never add semicolon after if(expression) or </a:t>
+            </a:r>
+            <a:r>
+              <a:rPr lang="en" altLang="zh-CN" sz="1600" dirty="0">
+                <a:solidFill>
+                  <a:srgbClr val="006699"/>
+                </a:solidFill>
+                <a:latin typeface="Aptos Display" panose="020B0004020202020204" pitchFamily="34" charset="0"/>
+                <a:ea typeface="微软雅黑" panose="020B0503020204020204" pitchFamily="34" charset="-122"/>
+                <a:cs typeface="Consolas" panose="020B0609020204030204" pitchFamily="49" charset="0"/>
+                <a:sym typeface="+mn-ea"/>
+              </a:rPr>
+              <a:t>else</a:t>
+            </a:r>
+            <a:r>
+              <a:rPr lang="en" altLang="zh-CN" sz="1600" kern="100" dirty="0">
                 <a:solidFill>
                   <a:schemeClr val="bg1"/>
                 </a:solidFill>
-                <a:latin typeface="Consolas" panose="020B0609020204030204" pitchFamily="49" charset="0"/>
-                <a:ea typeface="微软雅黑" panose="020B0503020204020204" pitchFamily="34" charset="-122"/>
-                <a:cs typeface="Consolas" panose="020B0609020204030204" pitchFamily="49" charset="0"/>
-              </a:rPr>
-              <a:t>(expression)</a:t>
-            </a:r>
-            <a:r>
-              <a:rPr lang="en" altLang="zh-CN" sz="1600" kern="100" dirty="0">
-                <a:solidFill>
-                  <a:schemeClr val="bg1"/>
-                </a:solidFill>
-                <a:latin typeface="Consolas" panose="020B0609020204030204" pitchFamily="49" charset="0"/>
-                <a:ea typeface="微软雅黑" panose="020B0503020204020204" pitchFamily="34" charset="-122"/>
-                <a:cs typeface="Consolas" panose="020B0609020204030204" pitchFamily="49" charset="0"/>
-              </a:rPr>
-              <a:t> or </a:t>
-            </a:r>
-            <a:r>
-              <a:rPr lang="en" altLang="zh-CN" sz="1600" b="1" dirty="0">
-                <a:solidFill>
-                  <a:srgbClr val="006699"/>
-                </a:solidFill>
-                <a:latin typeface="Consolas" panose="020B0609020204030204" pitchFamily="49" charset="0"/>
-                <a:ea typeface="微软雅黑" panose="020B0503020204020204" pitchFamily="34" charset="-122"/>
-                <a:cs typeface="Consolas" panose="020B0609020204030204" pitchFamily="49" charset="0"/>
-                <a:sym typeface="+mn-ea"/>
-              </a:rPr>
-              <a:t>else</a:t>
-            </a:r>
-            <a:r>
-              <a:rPr lang="en" altLang="zh-CN" sz="1600" b="1" kern="100" dirty="0">
-                <a:solidFill>
-                  <a:schemeClr val="bg1"/>
-                </a:solidFill>
-                <a:latin typeface="Consolas" panose="020B0609020204030204" pitchFamily="49" charset="0"/>
+                <a:latin typeface="Aptos Display" panose="020B0004020202020204" pitchFamily="34" charset="0"/>
                 <a:ea typeface="微软雅黑" panose="020B0503020204020204" pitchFamily="34" charset="-122"/>
                 <a:cs typeface="Consolas" panose="020B0609020204030204" pitchFamily="49" charset="0"/>
               </a:rPr>
@@ -12371,7 +12570,7 @@
               <a:solidFill>
                 <a:schemeClr val="bg1"/>
               </a:solidFill>
-              <a:latin typeface="Consolas" panose="020B0609020204030204" pitchFamily="49" charset="0"/>
+              <a:latin typeface="Aptos Display" panose="020B0004020202020204" pitchFamily="34" charset="0"/>
               <a:ea typeface="微软雅黑" panose="020B0503020204020204" pitchFamily="34" charset="-122"/>
               <a:cs typeface="Consolas" panose="020B0609020204030204" pitchFamily="49" charset="0"/>
             </a:endParaRPr>
@@ -12392,7 +12591,7 @@
                 <a:solidFill>
                   <a:schemeClr val="bg1"/>
                 </a:solidFill>
-                <a:latin typeface="Consolas" panose="020B0609020204030204" pitchFamily="49" charset="0"/>
+                <a:latin typeface="Aptos Display" panose="020B0004020202020204" pitchFamily="34" charset="0"/>
                 <a:ea typeface="微软雅黑" panose="020B0503020204020204" pitchFamily="34" charset="-122"/>
                 <a:cs typeface="Consolas" panose="020B0609020204030204" pitchFamily="49" charset="0"/>
               </a:rPr>
@@ -12402,7 +12601,7 @@
               <a:solidFill>
                 <a:schemeClr val="bg1"/>
               </a:solidFill>
-              <a:latin typeface="Consolas" panose="020B0609020204030204" pitchFamily="49" charset="0"/>
+              <a:latin typeface="Aptos Display" panose="020B0004020202020204" pitchFamily="34" charset="0"/>
               <a:ea typeface="微软雅黑" panose="020B0503020204020204" pitchFamily="34" charset="-122"/>
               <a:cs typeface="Consolas" panose="020B0609020204030204" pitchFamily="49" charset="0"/>
             </a:endParaRPr>
@@ -12417,7 +12616,7 @@
         </p:nvSpPr>
         <p:spPr>
           <a:xfrm>
-            <a:off x="509753" y="1736796"/>
+            <a:off x="379956" y="1784787"/>
             <a:ext cx="2793124" cy="2277251"/>
           </a:xfrm>
           <a:prstGeom prst="rect">
@@ -12769,7 +12968,7 @@
         </p:nvSpPr>
         <p:spPr>
           <a:xfrm>
-            <a:off x="3302876" y="1736794"/>
+            <a:off x="3453634" y="1784787"/>
             <a:ext cx="2858023" cy="3288429"/>
           </a:xfrm>
           <a:prstGeom prst="rect">
@@ -12985,7 +13184,7 @@
         </p:nvSpPr>
         <p:spPr>
           <a:xfrm>
-            <a:off x="477304" y="4392186"/>
+            <a:off x="347507" y="4440177"/>
             <a:ext cx="2793124" cy="2277251"/>
           </a:xfrm>
           <a:prstGeom prst="rect">
@@ -13176,7 +13375,7 @@
                 <a:solidFill>
                   <a:schemeClr val="bg1"/>
                 </a:solidFill>
-                <a:latin typeface="Consolas" panose="020B0609020204030204" pitchFamily="49" charset="0"/>
+                <a:latin typeface="Aptos Display" panose="020B0004020202020204" pitchFamily="34" charset="0"/>
                 <a:ea typeface="微软雅黑" panose="020B0503020204020204" pitchFamily="34" charset="-122"/>
                 <a:cs typeface="Consolas" panose="020B0609020204030204" pitchFamily="49" charset="0"/>
               </a:rPr>
@@ -13187,7 +13386,7 @@
                 <a:solidFill>
                   <a:schemeClr val="bg1"/>
                 </a:solidFill>
-                <a:latin typeface="Consolas" panose="020B0609020204030204" pitchFamily="49" charset="0"/>
+                <a:latin typeface="Aptos Display" panose="020B0004020202020204" pitchFamily="34" charset="0"/>
                 <a:ea typeface="微软雅黑" panose="020B0503020204020204" pitchFamily="34" charset="-122"/>
                 <a:cs typeface="Consolas" panose="020B0609020204030204" pitchFamily="49" charset="0"/>
               </a:rPr>
@@ -13198,12 +13397,31 @@
                 <a:solidFill>
                   <a:schemeClr val="bg1"/>
                 </a:solidFill>
-                <a:latin typeface="Consolas" panose="020B0609020204030204" pitchFamily="49" charset="0"/>
-                <a:ea typeface="微软雅黑" panose="020B0503020204020204" pitchFamily="34" charset="-122"/>
-                <a:cs typeface="Consolas" panose="020B0609020204030204" pitchFamily="49" charset="0"/>
-              </a:rPr>
-              <a:t>Buying Magnum</a:t>
-            </a:r>
+                <a:latin typeface="Aptos Display" panose="020B0004020202020204" pitchFamily="34" charset="0"/>
+                <a:ea typeface="微软雅黑" panose="020B0503020204020204" pitchFamily="34" charset="-122"/>
+                <a:cs typeface="Consolas" panose="020B0609020204030204" pitchFamily="49" charset="0"/>
+              </a:rPr>
+              <a:t>Buying Ice</a:t>
+            </a:r>
+            <a:r>
+              <a:rPr lang="en-US" altLang="zh-CN" sz="4000" dirty="0">
+                <a:solidFill>
+                  <a:schemeClr val="bg1"/>
+                </a:solidFill>
+                <a:latin typeface="Aptos Display" panose="020B0004020202020204" pitchFamily="34" charset="0"/>
+                <a:ea typeface="微软雅黑" panose="020B0503020204020204" pitchFamily="34" charset="-122"/>
+                <a:cs typeface="Consolas" panose="020B0609020204030204" pitchFamily="49" charset="0"/>
+              </a:rPr>
+              <a:t>cream</a:t>
+            </a:r>
+            <a:endParaRPr lang="en" altLang="en-US" sz="4000" dirty="0">
+              <a:solidFill>
+                <a:schemeClr val="bg1"/>
+              </a:solidFill>
+              <a:latin typeface="Aptos Display" panose="020B0004020202020204" pitchFamily="34" charset="0"/>
+              <a:ea typeface="微软雅黑" panose="020B0503020204020204" pitchFamily="34" charset="-122"/>
+              <a:cs typeface="Consolas" panose="020B0609020204030204" pitchFamily="49" charset="0"/>
+            </a:endParaRPr>
           </a:p>
         </p:txBody>
       </p:sp>
@@ -13456,8 +13674,8 @@
         </p:nvSpPr>
         <p:spPr>
           <a:xfrm>
-            <a:off x="2208637" y="1742149"/>
-            <a:ext cx="1539240" cy="4351338"/>
+            <a:off x="2208637" y="1743744"/>
+            <a:ext cx="1791863" cy="4351338"/>
           </a:xfrm>
           <a:prstGeom prst="rect">
             <a:avLst/>
@@ -13573,31 +13791,32 @@
           </a:lstStyle>
           <a:p>
             <a:r>
-              <a:rPr lang="en" altLang="zh-CN" sz="1600" b="1" dirty="0">
+              <a:rPr lang="en" altLang="zh-CN" sz="1400" dirty="0">
                 <a:solidFill>
                   <a:srgbClr val="006699"/>
                 </a:solidFill>
                 <a:latin typeface="Consolas" panose="020B0609020204030204" pitchFamily="49" charset="0"/>
                 <a:ea typeface="+mn-ea"/>
+                <a:cs typeface="Consolas" panose="020B0609020204030204" pitchFamily="49" charset="0"/>
               </a:rPr>
               <a:t>if </a:t>
             </a:r>
             <a:r>
-              <a:rPr lang="en" altLang="zh-CN" sz="1600" dirty="0">
+              <a:rPr lang="en" altLang="zh-CN" sz="1400" dirty="0">
                 <a:latin typeface="Consolas" panose="020B0609020204030204" pitchFamily="49" charset="0"/>
                 <a:cs typeface="Consolas" panose="020B0609020204030204" pitchFamily="49" charset="0"/>
               </a:rPr>
               <a:t>(</a:t>
             </a:r>
             <a:r>
-              <a:rPr lang="en" altLang="en-US" sz="1600" dirty="0">
+              <a:rPr lang="en" altLang="en-US" sz="1400" dirty="0">
                 <a:latin typeface="Consolas" panose="020B0609020204030204" pitchFamily="49" charset="0"/>
                 <a:cs typeface="Consolas" panose="020B0609020204030204" pitchFamily="49" charset="0"/>
               </a:rPr>
               <a:t>expression</a:t>
             </a:r>
             <a:r>
-              <a:rPr lang="en" altLang="zh-CN" sz="1600" dirty="0">
+              <a:rPr lang="en" altLang="zh-CN" sz="1400" dirty="0">
                 <a:latin typeface="Consolas" panose="020B0609020204030204" pitchFamily="49" charset="0"/>
                 <a:cs typeface="Consolas" panose="020B0609020204030204" pitchFamily="49" charset="0"/>
               </a:rPr>
@@ -13606,14 +13825,21 @@
           </a:p>
           <a:p>
             <a:r>
-              <a:rPr lang="en" altLang="en-US" sz="1600" dirty="0">
+              <a:rPr lang="zh-CN" altLang="en-US" sz="1400" dirty="0">
+                <a:latin typeface="Consolas" panose="020B0609020204030204" pitchFamily="49" charset="0"/>
+                <a:cs typeface="Consolas" panose="020B0609020204030204" pitchFamily="49" charset="0"/>
+              </a:rPr>
+              <a:t>    </a:t>
+            </a:r>
+            <a:r>
+              <a:rPr lang="en" altLang="en-US" sz="1400" dirty="0">
                 <a:latin typeface="Consolas" panose="020B0609020204030204" pitchFamily="49" charset="0"/>
                 <a:cs typeface="Consolas" panose="020B0609020204030204" pitchFamily="49" charset="0"/>
               </a:rPr>
               <a:t>statement</a:t>
             </a:r>
             <a:r>
-              <a:rPr lang="en" altLang="zh-CN" sz="1600" dirty="0">
+              <a:rPr lang="en" altLang="zh-CN" sz="1400" dirty="0">
                 <a:latin typeface="Consolas" panose="020B0609020204030204" pitchFamily="49" charset="0"/>
                 <a:cs typeface="Consolas" panose="020B0609020204030204" pitchFamily="49" charset="0"/>
               </a:rPr>
@@ -13622,26 +13848,34 @@
           </a:p>
           <a:p>
             <a:r>
-              <a:rPr lang="en" altLang="zh-CN" sz="1600" b="1" dirty="0">
+              <a:rPr lang="en" altLang="zh-CN" sz="1400" dirty="0">
                 <a:solidFill>
                   <a:srgbClr val="006699"/>
                 </a:solidFill>
                 <a:latin typeface="Consolas" panose="020B0609020204030204" pitchFamily="49" charset="0"/>
                 <a:ea typeface="+mn-ea"/>
+                <a:cs typeface="Consolas" panose="020B0609020204030204" pitchFamily="49" charset="0"/>
               </a:rPr>
               <a:t>else</a:t>
             </a:r>
           </a:p>
           <a:p>
             <a:r>
-              <a:rPr lang="en" altLang="en-US" sz="1600" dirty="0">
+              <a:rPr lang="zh-CN" altLang="en-US" sz="1400" dirty="0">
+                <a:latin typeface="Consolas" panose="020B0609020204030204" pitchFamily="49" charset="0"/>
+                <a:cs typeface="Consolas" panose="020B0609020204030204" pitchFamily="49" charset="0"/>
+              </a:rPr>
+              <a:t>    </a:t>
+            </a:r>
+            <a:r>
+              <a:rPr lang="en" altLang="en-US" sz="1400" dirty="0">
                 <a:latin typeface="Consolas" panose="020B0609020204030204" pitchFamily="49" charset="0"/>
                 <a:cs typeface="Consolas" panose="020B0609020204030204" pitchFamily="49" charset="0"/>
               </a:rPr>
               <a:t>statement</a:t>
             </a:r>
             <a:r>
-              <a:rPr lang="en" altLang="zh-CN" sz="1600" dirty="0">
+              <a:rPr lang="en" altLang="zh-CN" sz="1400" dirty="0">
                 <a:latin typeface="Consolas" panose="020B0609020204030204" pitchFamily="49" charset="0"/>
                 <a:cs typeface="Consolas" panose="020B0609020204030204" pitchFamily="49" charset="0"/>
               </a:rPr>
@@ -13659,7 +13893,7 @@
         <p:spPr>
           <a:xfrm>
             <a:off x="605789" y="1743744"/>
-            <a:ext cx="1539240" cy="4351338"/>
+            <a:ext cx="1602848" cy="4351338"/>
           </a:xfrm>
           <a:prstGeom prst="rect">
             <a:avLst/>
@@ -13839,16 +14073,17 @@
               <a:buNone/>
             </a:pPr>
             <a:r>
-              <a:rPr lang="en" altLang="zh-CN" sz="1600" b="1" dirty="0">
+              <a:rPr lang="en" altLang="zh-CN" sz="1400" dirty="0">
                 <a:solidFill>
                   <a:srgbClr val="006699"/>
                 </a:solidFill>
                 <a:latin typeface="Consolas" panose="020B0609020204030204" pitchFamily="49" charset="0"/>
+                <a:cs typeface="Consolas" panose="020B0609020204030204" pitchFamily="49" charset="0"/>
               </a:rPr>
               <a:t>if </a:t>
             </a:r>
             <a:r>
-              <a:rPr lang="en" altLang="zh-CN" sz="1600" dirty="0">
+              <a:rPr lang="en" altLang="zh-CN" sz="1400" dirty="0">
                 <a:solidFill>
                   <a:schemeClr val="bg1"/>
                 </a:solidFill>
@@ -13859,7 +14094,7 @@
               <a:t>(e</a:t>
             </a:r>
             <a:r>
-              <a:rPr lang="en" altLang="en-US" sz="1600" dirty="0">
+              <a:rPr lang="en" altLang="en-US" sz="1400" dirty="0">
                 <a:solidFill>
                   <a:schemeClr val="bg1"/>
                 </a:solidFill>
@@ -13870,7 +14105,7 @@
               <a:t>xpression</a:t>
             </a:r>
             <a:r>
-              <a:rPr lang="en" altLang="zh-CN" sz="1600" dirty="0">
+              <a:rPr lang="en" altLang="zh-CN" sz="1400" dirty="0">
                 <a:solidFill>
                   <a:schemeClr val="bg1"/>
                 </a:solidFill>
@@ -13887,7 +14122,7 @@
               <a:buNone/>
             </a:pPr>
             <a:r>
-              <a:rPr lang="en" altLang="en-US" sz="1600" dirty="0">
+              <a:rPr lang="zh-CN" altLang="en-US" sz="1400" dirty="0">
                 <a:solidFill>
                   <a:schemeClr val="bg1"/>
                 </a:solidFill>
@@ -13895,10 +14130,21 @@
                 <a:ea typeface="微软雅黑" panose="020B0503020204020204" pitchFamily="34" charset="-122"/>
                 <a:cs typeface="Consolas" panose="020B0609020204030204" pitchFamily="49" charset="0"/>
               </a:rPr>
+              <a:t>    </a:t>
+            </a:r>
+            <a:r>
+              <a:rPr lang="en" altLang="en-US" sz="1400" dirty="0">
+                <a:solidFill>
+                  <a:schemeClr val="bg1"/>
+                </a:solidFill>
+                <a:latin typeface="Consolas" panose="020B0609020204030204" pitchFamily="49" charset="0"/>
+                <a:ea typeface="微软雅黑" panose="020B0503020204020204" pitchFamily="34" charset="-122"/>
+                <a:cs typeface="Consolas" panose="020B0609020204030204" pitchFamily="49" charset="0"/>
+              </a:rPr>
               <a:t>statement</a:t>
             </a:r>
             <a:r>
-              <a:rPr lang="en" altLang="zh-CN" sz="1600" dirty="0">
+              <a:rPr lang="en" altLang="zh-CN" sz="1400" dirty="0">
                 <a:solidFill>
                   <a:schemeClr val="bg1"/>
                 </a:solidFill>
@@ -13934,16 +14180,24 @@
           <a:lstStyle/>
           <a:p>
             <a:r>
-              <a:rPr lang="en" altLang="en-US" sz="4000" dirty="0">
+              <a:rPr lang="en-US" altLang="zh-CN" sz="4000" dirty="0">
                 <a:solidFill>
                   <a:schemeClr val="bg1"/>
                 </a:solidFill>
-                <a:latin typeface="Consolas" panose="020B0609020204030204" pitchFamily="49" charset="0"/>
-                <a:ea typeface="微软雅黑" panose="020B0503020204020204" pitchFamily="34" charset="-122"/>
-                <a:cs typeface="Consolas" panose="020B0609020204030204" pitchFamily="49" charset="0"/>
-              </a:rPr>
-              <a:t>Grammar</a:t>
-            </a:r>
+                <a:latin typeface="Aptos Display" panose="020B0004020202020204" pitchFamily="34" charset="0"/>
+                <a:ea typeface="微软雅黑" panose="020B0503020204020204" pitchFamily="34" charset="-122"/>
+                <a:cs typeface="Consolas" panose="020B0609020204030204" pitchFamily="49" charset="0"/>
+              </a:rPr>
+              <a:t>Syntax</a:t>
+            </a:r>
+            <a:endParaRPr lang="en" altLang="en-US" sz="4000" dirty="0">
+              <a:solidFill>
+                <a:schemeClr val="bg1"/>
+              </a:solidFill>
+              <a:latin typeface="Aptos Display" panose="020B0004020202020204" pitchFamily="34" charset="0"/>
+              <a:ea typeface="微软雅黑" panose="020B0503020204020204" pitchFamily="34" charset="-122"/>
+              <a:cs typeface="Consolas" panose="020B0609020204030204" pitchFamily="49" charset="0"/>
+            </a:endParaRPr>
           </a:p>
         </p:txBody>
       </p:sp>
@@ -13955,8 +14209,8 @@
         </p:nvSpPr>
         <p:spPr>
           <a:xfrm>
-            <a:off x="3747877" y="1748027"/>
-            <a:ext cx="1539240" cy="3611245"/>
+            <a:off x="4000499" y="1743744"/>
+            <a:ext cx="1891145" cy="2863348"/>
           </a:xfrm>
           <a:prstGeom prst="rect">
             <a:avLst/>
@@ -13978,16 +14232,17 @@
               <a:buSzPct val="125000"/>
             </a:pPr>
             <a:r>
-              <a:rPr lang="en" altLang="zh-CN" sz="1600" b="1" dirty="0">
+              <a:rPr lang="en" altLang="zh-CN" sz="1400" dirty="0">
                 <a:solidFill>
                   <a:srgbClr val="006699"/>
                 </a:solidFill>
                 <a:latin typeface="Consolas" panose="020B0609020204030204" pitchFamily="49" charset="0"/>
+                <a:cs typeface="Consolas" panose="020B0609020204030204" pitchFamily="49" charset="0"/>
               </a:rPr>
               <a:t>if </a:t>
             </a:r>
             <a:r>
-              <a:rPr lang="en" altLang="zh-CN" sz="1600" dirty="0">
+              <a:rPr lang="en" altLang="zh-CN" sz="1400" dirty="0">
                 <a:solidFill>
                   <a:prstClr val="black"/>
                 </a:solidFill>
@@ -13998,7 +14253,7 @@
               <a:t>(</a:t>
             </a:r>
             <a:r>
-              <a:rPr lang="en" altLang="en-US" sz="1600" dirty="0">
+              <a:rPr lang="en" altLang="en-US" sz="1400" dirty="0">
                 <a:solidFill>
                   <a:prstClr val="black"/>
                 </a:solidFill>
@@ -14009,7 +14264,7 @@
               <a:t>expression</a:t>
             </a:r>
             <a:r>
-              <a:rPr lang="en" altLang="zh-CN" sz="1600" dirty="0">
+              <a:rPr lang="en" altLang="zh-CN" sz="1400" dirty="0">
                 <a:solidFill>
                   <a:prstClr val="black"/>
                 </a:solidFill>
@@ -14031,7 +14286,7 @@
               <a:buSzPct val="125000"/>
             </a:pPr>
             <a:r>
-              <a:rPr lang="en" altLang="en-US" sz="1600" dirty="0">
+              <a:rPr lang="zh-CN" altLang="en-US" sz="1400" dirty="0">
                 <a:solidFill>
                   <a:prstClr val="black"/>
                 </a:solidFill>
@@ -14039,10 +14294,21 @@
                 <a:ea typeface="微软雅黑" panose="020B0503020204020204" pitchFamily="34" charset="-122"/>
                 <a:cs typeface="Consolas" panose="020B0609020204030204" pitchFamily="49" charset="0"/>
               </a:rPr>
+              <a:t>    </a:t>
+            </a:r>
+            <a:r>
+              <a:rPr lang="en" altLang="en-US" sz="1400" dirty="0">
+                <a:solidFill>
+                  <a:prstClr val="black"/>
+                </a:solidFill>
+                <a:latin typeface="Consolas" panose="020B0609020204030204" pitchFamily="49" charset="0"/>
+                <a:ea typeface="微软雅黑" panose="020B0503020204020204" pitchFamily="34" charset="-122"/>
+                <a:cs typeface="Consolas" panose="020B0609020204030204" pitchFamily="49" charset="0"/>
+              </a:rPr>
               <a:t>statement</a:t>
             </a:r>
             <a:r>
-              <a:rPr lang="en" altLang="zh-CN" sz="1600" dirty="0">
+              <a:rPr lang="en" altLang="zh-CN" sz="1400" dirty="0">
                 <a:solidFill>
                   <a:prstClr val="black"/>
                 </a:solidFill>
@@ -14064,7 +14330,7 @@
               <a:buSzPct val="125000"/>
             </a:pPr>
             <a:r>
-              <a:rPr lang="en" altLang="en-US" sz="1600" dirty="0">
+              <a:rPr lang="zh-CN" altLang="en-US" sz="1400" dirty="0">
                 <a:solidFill>
                   <a:prstClr val="black"/>
                 </a:solidFill>
@@ -14072,10 +14338,21 @@
                 <a:ea typeface="微软雅黑" panose="020B0503020204020204" pitchFamily="34" charset="-122"/>
                 <a:cs typeface="Consolas" panose="020B0609020204030204" pitchFamily="49" charset="0"/>
               </a:rPr>
+              <a:t>    </a:t>
+            </a:r>
+            <a:r>
+              <a:rPr lang="en" altLang="en-US" sz="1400" dirty="0">
+                <a:solidFill>
+                  <a:prstClr val="black"/>
+                </a:solidFill>
+                <a:latin typeface="Consolas" panose="020B0609020204030204" pitchFamily="49" charset="0"/>
+                <a:ea typeface="微软雅黑" panose="020B0503020204020204" pitchFamily="34" charset="-122"/>
+                <a:cs typeface="Consolas" panose="020B0609020204030204" pitchFamily="49" charset="0"/>
+              </a:rPr>
               <a:t>statement</a:t>
             </a:r>
             <a:r>
-              <a:rPr lang="en" altLang="zh-CN" sz="1600" dirty="0">
+              <a:rPr lang="en" altLang="zh-CN" sz="1400" dirty="0">
                 <a:solidFill>
                   <a:prstClr val="black"/>
                 </a:solidFill>
@@ -14097,7 +14374,7 @@
               <a:buSzPct val="125000"/>
             </a:pPr>
             <a:r>
-              <a:rPr lang="en" altLang="en-US" sz="1600" dirty="0">
+              <a:rPr lang="en" altLang="en-US" sz="1400" dirty="0">
                 <a:solidFill>
                   <a:prstClr val="black"/>
                 </a:solidFill>
@@ -14108,7 +14385,7 @@
               <a:t>    </a:t>
             </a:r>
             <a:r>
-              <a:rPr lang="en" altLang="zh-CN" sz="1600" dirty="0">
+              <a:rPr lang="en" altLang="zh-CN" sz="1400" dirty="0">
                 <a:solidFill>
                   <a:prstClr val="black"/>
                 </a:solidFill>
@@ -14130,7 +14407,7 @@
               <a:buSzPct val="125000"/>
             </a:pPr>
             <a:r>
-              <a:rPr lang="en" altLang="zh-CN" sz="1600" dirty="0">
+              <a:rPr lang="en" altLang="zh-CN" sz="1400" dirty="0">
                 <a:solidFill>
                   <a:prstClr val="black"/>
                 </a:solidFill>
@@ -14141,16 +14418,17 @@
               <a:t>}</a:t>
             </a:r>
             <a:r>
-              <a:rPr lang="en" altLang="zh-CN" sz="1600" b="1" dirty="0">
+              <a:rPr lang="en" altLang="zh-CN" sz="1400" dirty="0">
                 <a:solidFill>
                   <a:srgbClr val="006699"/>
                 </a:solidFill>
                 <a:latin typeface="Consolas" panose="020B0609020204030204" pitchFamily="49" charset="0"/>
+                <a:cs typeface="Consolas" panose="020B0609020204030204" pitchFamily="49" charset="0"/>
               </a:rPr>
               <a:t>else</a:t>
             </a:r>
             <a:r>
-              <a:rPr lang="en" altLang="zh-CN" sz="1600" dirty="0">
+              <a:rPr lang="en" altLang="zh-CN" sz="1400" dirty="0">
                 <a:solidFill>
                   <a:prstClr val="black"/>
                 </a:solidFill>
@@ -14172,7 +14450,7 @@
               <a:buSzPct val="125000"/>
             </a:pPr>
             <a:r>
-              <a:rPr lang="en" altLang="en-US" sz="1600" dirty="0">
+              <a:rPr lang="zh-CN" altLang="en-US" sz="1400" dirty="0">
                 <a:solidFill>
                   <a:prstClr val="black"/>
                 </a:solidFill>
@@ -14180,10 +14458,21 @@
                 <a:ea typeface="微软雅黑" panose="020B0503020204020204" pitchFamily="34" charset="-122"/>
                 <a:cs typeface="Consolas" panose="020B0609020204030204" pitchFamily="49" charset="0"/>
               </a:rPr>
+              <a:t>    </a:t>
+            </a:r>
+            <a:r>
+              <a:rPr lang="en" altLang="en-US" sz="1400" dirty="0">
+                <a:solidFill>
+                  <a:prstClr val="black"/>
+                </a:solidFill>
+                <a:latin typeface="Consolas" panose="020B0609020204030204" pitchFamily="49" charset="0"/>
+                <a:ea typeface="微软雅黑" panose="020B0503020204020204" pitchFamily="34" charset="-122"/>
+                <a:cs typeface="Consolas" panose="020B0609020204030204" pitchFamily="49" charset="0"/>
+              </a:rPr>
               <a:t>statement</a:t>
             </a:r>
             <a:r>
-              <a:rPr lang="en" altLang="zh-CN" sz="1600" dirty="0">
+              <a:rPr lang="en" altLang="zh-CN" sz="1400" dirty="0">
                 <a:solidFill>
                   <a:prstClr val="black"/>
                 </a:solidFill>
@@ -14205,7 +14494,7 @@
               <a:buSzPct val="125000"/>
             </a:pPr>
             <a:r>
-              <a:rPr lang="en" altLang="en-US" sz="1600" dirty="0">
+              <a:rPr lang="zh-CN" altLang="en-US" sz="1400" dirty="0">
                 <a:solidFill>
                   <a:prstClr val="black"/>
                 </a:solidFill>
@@ -14213,10 +14502,21 @@
                 <a:ea typeface="微软雅黑" panose="020B0503020204020204" pitchFamily="34" charset="-122"/>
                 <a:cs typeface="Consolas" panose="020B0609020204030204" pitchFamily="49" charset="0"/>
               </a:rPr>
+              <a:t>    </a:t>
+            </a:r>
+            <a:r>
+              <a:rPr lang="en" altLang="en-US" sz="1400" dirty="0">
+                <a:solidFill>
+                  <a:prstClr val="black"/>
+                </a:solidFill>
+                <a:latin typeface="Consolas" panose="020B0609020204030204" pitchFamily="49" charset="0"/>
+                <a:ea typeface="微软雅黑" panose="020B0503020204020204" pitchFamily="34" charset="-122"/>
+                <a:cs typeface="Consolas" panose="020B0609020204030204" pitchFamily="49" charset="0"/>
+              </a:rPr>
               <a:t>statement</a:t>
             </a:r>
             <a:r>
-              <a:rPr lang="en" altLang="zh-CN" sz="1600" dirty="0">
+              <a:rPr lang="en" altLang="zh-CN" sz="1400" dirty="0">
                 <a:solidFill>
                   <a:prstClr val="black"/>
                 </a:solidFill>
@@ -14238,7 +14538,18 @@
               <a:buSzPct val="125000"/>
             </a:pPr>
             <a:r>
-              <a:rPr lang="en" altLang="zh-CN" sz="1600" dirty="0">
+              <a:rPr lang="zh-CN" altLang="en-US" sz="1400" dirty="0">
+                <a:solidFill>
+                  <a:prstClr val="black"/>
+                </a:solidFill>
+                <a:latin typeface="Consolas" panose="020B0609020204030204" pitchFamily="49" charset="0"/>
+                <a:ea typeface="微软雅黑" panose="020B0503020204020204" pitchFamily="34" charset="-122"/>
+                <a:cs typeface="Consolas" panose="020B0609020204030204" pitchFamily="49" charset="0"/>
+              </a:rPr>
+              <a:t>    </a:t>
+            </a:r>
+            <a:r>
+              <a:rPr lang="en" altLang="zh-CN" sz="1400" dirty="0">
                 <a:solidFill>
                   <a:prstClr val="black"/>
                 </a:solidFill>
@@ -14260,7 +14571,7 @@
               <a:buSzPct val="125000"/>
             </a:pPr>
             <a:r>
-              <a:rPr lang="en" altLang="zh-CN" sz="1600" dirty="0">
+              <a:rPr lang="en" altLang="zh-CN" sz="1400" dirty="0">
                 <a:solidFill>
                   <a:prstClr val="black"/>
                 </a:solidFill>
@@ -14270,7 +14581,7 @@
               </a:rPr>
               <a:t>}</a:t>
             </a:r>
-            <a:endParaRPr lang="zh-CN" altLang="en-US" sz="1600" dirty="0">
+            <a:endParaRPr lang="zh-CN" altLang="en-US" sz="1400" dirty="0">
               <a:solidFill>
                 <a:prstClr val="black"/>
               </a:solidFill>
@@ -14296,7 +14607,7 @@
         <p:spPr>
           <a:xfrm>
             <a:off x="6160899" y="1486111"/>
-            <a:ext cx="5030732" cy="4484754"/>
+            <a:ext cx="5030732" cy="3011465"/>
           </a:xfrm>
           <a:prstGeom prst="rect">
             <a:avLst/>
@@ -14324,7 +14635,7 @@
                 <a:solidFill>
                   <a:schemeClr val="bg1"/>
                 </a:solidFill>
-                <a:latin typeface="Consolas" panose="020B0609020204030204" pitchFamily="49" charset="0"/>
+                <a:latin typeface="Aptos Display" panose="020B0004020202020204" pitchFamily="34" charset="0"/>
                 <a:ea typeface="微软雅黑" panose="020B0503020204020204" pitchFamily="34" charset="-122"/>
                 <a:cs typeface="Consolas" panose="020B0609020204030204" pitchFamily="49" charset="0"/>
               </a:rPr>
@@ -14343,11 +14654,11 @@
               <a:buAutoNum type="arabicPeriod"/>
             </a:pPr>
             <a:r>
-              <a:rPr lang="en" altLang="zh-CN" sz="1600" b="1" dirty="0">
+              <a:rPr lang="en" altLang="zh-CN" sz="1600" dirty="0">
                 <a:solidFill>
                   <a:srgbClr val="006699"/>
                 </a:solidFill>
-                <a:latin typeface="Consolas" panose="020B0609020204030204" pitchFamily="49" charset="0"/>
+                <a:latin typeface="Aptos Display" panose="020B0004020202020204" pitchFamily="34" charset="0"/>
                 <a:ea typeface="微软雅黑" panose="020B0503020204020204" pitchFamily="34" charset="-122"/>
                 <a:cs typeface="Consolas" panose="020B0609020204030204" pitchFamily="49" charset="0"/>
                 <a:sym typeface="+mn-ea"/>
@@ -14359,7 +14670,7 @@
                 <a:solidFill>
                   <a:schemeClr val="bg1"/>
                 </a:solidFill>
-                <a:latin typeface="Consolas" panose="020B0609020204030204" pitchFamily="49" charset="0"/>
+                <a:latin typeface="Aptos Display" panose="020B0004020202020204" pitchFamily="34" charset="0"/>
                 <a:ea typeface="微软雅黑" panose="020B0503020204020204" pitchFamily="34" charset="-122"/>
                 <a:cs typeface="Consolas" panose="020B0609020204030204" pitchFamily="49" charset="0"/>
               </a:rPr>
@@ -14382,18 +14693,18 @@
                 <a:solidFill>
                   <a:schemeClr val="bg1"/>
                 </a:solidFill>
-                <a:latin typeface="Consolas" panose="020B0609020204030204" pitchFamily="49" charset="0"/>
+                <a:latin typeface="Aptos Display" panose="020B0004020202020204" pitchFamily="34" charset="0"/>
                 <a:ea typeface="微软雅黑" panose="020B0503020204020204" pitchFamily="34" charset="-122"/>
                 <a:cs typeface="Consolas" panose="020B0609020204030204" pitchFamily="49" charset="0"/>
               </a:rPr>
               <a:t>An </a:t>
             </a:r>
             <a:r>
-              <a:rPr lang="en" altLang="zh-CN" sz="1600" b="1" dirty="0">
+              <a:rPr lang="en" altLang="zh-CN" sz="1600" dirty="0">
                 <a:solidFill>
                   <a:srgbClr val="006699"/>
                 </a:solidFill>
-                <a:latin typeface="Consolas" panose="020B0609020204030204" pitchFamily="49" charset="0"/>
+                <a:latin typeface="Aptos Display" panose="020B0004020202020204" pitchFamily="34" charset="0"/>
                 <a:ea typeface="微软雅黑" panose="020B0503020204020204" pitchFamily="34" charset="-122"/>
                 <a:cs typeface="Consolas" panose="020B0609020204030204" pitchFamily="49" charset="0"/>
                 <a:sym typeface="+mn-ea"/>
@@ -14405,18 +14716,18 @@
                 <a:solidFill>
                   <a:schemeClr val="bg1"/>
                 </a:solidFill>
-                <a:latin typeface="Consolas" panose="020B0609020204030204" pitchFamily="49" charset="0"/>
+                <a:latin typeface="Aptos Display" panose="020B0004020202020204" pitchFamily="34" charset="0"/>
                 <a:ea typeface="微软雅黑" panose="020B0503020204020204" pitchFamily="34" charset="-122"/>
                 <a:cs typeface="Consolas" panose="020B0609020204030204" pitchFamily="49" charset="0"/>
               </a:rPr>
               <a:t>can only pair with one </a:t>
             </a:r>
             <a:r>
-              <a:rPr lang="en" altLang="zh-CN" sz="1600" b="1" dirty="0">
+              <a:rPr lang="en" altLang="zh-CN" sz="1600" dirty="0">
                 <a:solidFill>
                   <a:srgbClr val="006699"/>
                 </a:solidFill>
-                <a:latin typeface="Consolas" panose="020B0609020204030204" pitchFamily="49" charset="0"/>
+                <a:latin typeface="Aptos Display" panose="020B0004020202020204" pitchFamily="34" charset="0"/>
                 <a:ea typeface="微软雅黑" panose="020B0503020204020204" pitchFamily="34" charset="-122"/>
                 <a:cs typeface="Consolas" panose="020B0609020204030204" pitchFamily="49" charset="0"/>
                 <a:sym typeface="+mn-ea"/>
@@ -14428,7 +14739,7 @@
                 <a:solidFill>
                   <a:schemeClr val="bg1"/>
                 </a:solidFill>
-                <a:latin typeface="Consolas" panose="020B0609020204030204" pitchFamily="49" charset="0"/>
+                <a:latin typeface="Aptos Display" panose="020B0004020202020204" pitchFamily="34" charset="0"/>
                 <a:ea typeface="微软雅黑" panose="020B0503020204020204" pitchFamily="34" charset="-122"/>
                 <a:cs typeface="Consolas" panose="020B0609020204030204" pitchFamily="49" charset="0"/>
               </a:rPr>
@@ -14438,7 +14749,7 @@
               <a:solidFill>
                 <a:schemeClr val="bg1"/>
               </a:solidFill>
-              <a:latin typeface="Consolas" panose="020B0609020204030204" pitchFamily="49" charset="0"/>
+              <a:latin typeface="Aptos Display" panose="020B0004020202020204" pitchFamily="34" charset="0"/>
               <a:ea typeface="微软雅黑" panose="020B0503020204020204" pitchFamily="34" charset="-122"/>
               <a:cs typeface="Consolas" panose="020B0609020204030204" pitchFamily="49" charset="0"/>
             </a:endParaRPr>
@@ -14455,11 +14766,11 @@
               <a:buAutoNum type="arabicPeriod"/>
             </a:pPr>
             <a:r>
-              <a:rPr lang="en" altLang="zh-CN" sz="1600" b="1" dirty="0">
+              <a:rPr lang="en" altLang="zh-CN" sz="1600" dirty="0">
                 <a:solidFill>
                   <a:srgbClr val="006699"/>
                 </a:solidFill>
-                <a:latin typeface="Consolas" panose="020B0609020204030204" pitchFamily="49" charset="0"/>
+                <a:latin typeface="Aptos Display" panose="020B0004020202020204" pitchFamily="34" charset="0"/>
                 <a:ea typeface="微软雅黑" panose="020B0503020204020204" pitchFamily="34" charset="-122"/>
                 <a:cs typeface="Consolas" panose="020B0609020204030204" pitchFamily="49" charset="0"/>
                 <a:sym typeface="+mn-ea"/>
@@ -14471,7 +14782,7 @@
                 <a:solidFill>
                   <a:schemeClr val="bg1"/>
                 </a:solidFill>
-                <a:latin typeface="Consolas" panose="020B0609020204030204" pitchFamily="49" charset="0"/>
+                <a:latin typeface="Aptos Display" panose="020B0004020202020204" pitchFamily="34" charset="0"/>
                 <a:ea typeface="微软雅黑" panose="020B0503020204020204" pitchFamily="34" charset="-122"/>
                 <a:cs typeface="Consolas" panose="020B0609020204030204" pitchFamily="49" charset="0"/>
               </a:rPr>
@@ -14481,7 +14792,7 @@
               <a:solidFill>
                 <a:schemeClr val="bg1"/>
               </a:solidFill>
-              <a:latin typeface="Consolas" panose="020B0609020204030204" pitchFamily="49" charset="0"/>
+              <a:latin typeface="Aptos Display" panose="020B0004020202020204" pitchFamily="34" charset="0"/>
               <a:ea typeface="微软雅黑" panose="020B0503020204020204" pitchFamily="34" charset="-122"/>
               <a:cs typeface="Consolas" panose="020B0609020204030204" pitchFamily="49" charset="0"/>
             </a:endParaRPr>
@@ -14502,40 +14813,29 @@
                 <a:solidFill>
                   <a:schemeClr val="bg1"/>
                 </a:solidFill>
-                <a:latin typeface="Consolas" panose="020B0609020204030204" pitchFamily="49" charset="0"/>
+                <a:latin typeface="Aptos Display" panose="020B0004020202020204" pitchFamily="34" charset="0"/>
                 <a:ea typeface="微软雅黑" panose="020B0503020204020204" pitchFamily="34" charset="-122"/>
                 <a:cs typeface="Consolas" panose="020B0609020204030204" pitchFamily="49" charset="0"/>
               </a:rPr>
               <a:t>You cannot write </a:t>
             </a:r>
             <a:r>
-              <a:rPr lang="en" altLang="zh-CN" sz="1600" b="1" kern="100" dirty="0">
+              <a:rPr lang="en" altLang="zh-CN" sz="1600" kern="100" dirty="0">
                 <a:solidFill>
                   <a:schemeClr val="bg1"/>
                 </a:solidFill>
-                <a:latin typeface="Consolas" panose="020B0609020204030204" pitchFamily="49" charset="0"/>
-                <a:ea typeface="微软雅黑" panose="020B0503020204020204" pitchFamily="34" charset="-122"/>
-                <a:cs typeface="Consolas" panose="020B0609020204030204" pitchFamily="49" charset="0"/>
-              </a:rPr>
-              <a:t>(expression)</a:t>
-            </a:r>
-            <a:r>
-              <a:rPr lang="en" altLang="zh-CN" sz="1600" kern="100" dirty="0">
-                <a:solidFill>
-                  <a:schemeClr val="bg1"/>
-                </a:solidFill>
-                <a:latin typeface="Consolas" panose="020B0609020204030204" pitchFamily="49" charset="0"/>
-                <a:ea typeface="微软雅黑" panose="020B0503020204020204" pitchFamily="34" charset="-122"/>
-                <a:cs typeface="Consolas" panose="020B0609020204030204" pitchFamily="49" charset="0"/>
-              </a:rPr>
-              <a:t> after </a:t>
-            </a:r>
-            <a:r>
-              <a:rPr lang="en" altLang="zh-CN" sz="1600" b="1" dirty="0">
+                <a:latin typeface="Aptos Display" panose="020B0004020202020204" pitchFamily="34" charset="0"/>
+                <a:ea typeface="微软雅黑" panose="020B0503020204020204" pitchFamily="34" charset="-122"/>
+                <a:cs typeface="Consolas" panose="020B0609020204030204" pitchFamily="49" charset="0"/>
+              </a:rPr>
+              <a:t>(expression) after </a:t>
+            </a:r>
+            <a:r>
+              <a:rPr lang="en" altLang="zh-CN" sz="1600" dirty="0">
                 <a:solidFill>
                   <a:srgbClr val="006699"/>
                 </a:solidFill>
-                <a:latin typeface="Consolas" panose="020B0609020204030204" pitchFamily="49" charset="0"/>
+                <a:latin typeface="Aptos Display" panose="020B0004020202020204" pitchFamily="34" charset="0"/>
                 <a:ea typeface="微软雅黑" panose="020B0503020204020204" pitchFamily="34" charset="-122"/>
                 <a:cs typeface="Consolas" panose="020B0609020204030204" pitchFamily="49" charset="0"/>
                 <a:sym typeface="+mn-ea"/>
@@ -14546,7 +14846,7 @@
               <a:solidFill>
                 <a:schemeClr val="bg1"/>
               </a:solidFill>
-              <a:latin typeface="Consolas" panose="020B0609020204030204" pitchFamily="49" charset="0"/>
+              <a:latin typeface="Aptos Display" panose="020B0004020202020204" pitchFamily="34" charset="0"/>
               <a:ea typeface="微软雅黑" panose="020B0503020204020204" pitchFamily="34" charset="-122"/>
               <a:cs typeface="Consolas" panose="020B0609020204030204" pitchFamily="49" charset="0"/>
             </a:endParaRPr>
@@ -14567,52 +14867,30 @@
                 <a:solidFill>
                   <a:schemeClr val="bg1"/>
                 </a:solidFill>
-                <a:latin typeface="Consolas" panose="020B0609020204030204" pitchFamily="49" charset="0"/>
-                <a:ea typeface="微软雅黑" panose="020B0503020204020204" pitchFamily="34" charset="-122"/>
-                <a:cs typeface="Consolas" panose="020B0609020204030204" pitchFamily="49" charset="0"/>
-              </a:rPr>
-              <a:t>Never add semicolon after if</a:t>
-            </a:r>
-            <a:r>
-              <a:rPr lang="en" altLang="zh-CN" sz="1600" b="1" kern="100" dirty="0">
+                <a:latin typeface="Aptos Display" panose="020B0004020202020204" pitchFamily="34" charset="0"/>
+                <a:ea typeface="微软雅黑" panose="020B0503020204020204" pitchFamily="34" charset="-122"/>
+                <a:cs typeface="Consolas" panose="020B0609020204030204" pitchFamily="49" charset="0"/>
+              </a:rPr>
+              <a:t>Never add semicolon after if(expression) or </a:t>
+            </a:r>
+            <a:r>
+              <a:rPr lang="en" altLang="zh-CN" sz="1600" dirty="0">
+                <a:solidFill>
+                  <a:srgbClr val="006699"/>
+                </a:solidFill>
+                <a:latin typeface="Aptos Display" panose="020B0004020202020204" pitchFamily="34" charset="0"/>
+                <a:ea typeface="微软雅黑" panose="020B0503020204020204" pitchFamily="34" charset="-122"/>
+                <a:cs typeface="Consolas" panose="020B0609020204030204" pitchFamily="49" charset="0"/>
+                <a:sym typeface="+mn-ea"/>
+              </a:rPr>
+              <a:t>else</a:t>
+            </a:r>
+            <a:r>
+              <a:rPr lang="en" altLang="zh-CN" sz="1600" kern="100" dirty="0">
                 <a:solidFill>
                   <a:schemeClr val="bg1"/>
                 </a:solidFill>
-                <a:latin typeface="Consolas" panose="020B0609020204030204" pitchFamily="49" charset="0"/>
-                <a:ea typeface="微软雅黑" panose="020B0503020204020204" pitchFamily="34" charset="-122"/>
-                <a:cs typeface="Consolas" panose="020B0609020204030204" pitchFamily="49" charset="0"/>
-              </a:rPr>
-              <a:t>(expression)</a:t>
-            </a:r>
-            <a:r>
-              <a:rPr lang="en" altLang="zh-CN" sz="1600" kern="100" dirty="0">
-                <a:solidFill>
-                  <a:schemeClr val="bg1"/>
-                </a:solidFill>
-                <a:latin typeface="Consolas" panose="020B0609020204030204" pitchFamily="49" charset="0"/>
-                <a:ea typeface="微软雅黑" panose="020B0503020204020204" pitchFamily="34" charset="-122"/>
-                <a:cs typeface="Consolas" panose="020B0609020204030204" pitchFamily="49" charset="0"/>
-              </a:rPr>
-              <a:t> or </a:t>
-            </a:r>
-            <a:r>
-              <a:rPr lang="en" altLang="zh-CN" sz="1600" b="1" dirty="0">
-                <a:solidFill>
-                  <a:srgbClr val="006699"/>
-                </a:solidFill>
-                <a:latin typeface="Consolas" panose="020B0609020204030204" pitchFamily="49" charset="0"/>
-                <a:ea typeface="微软雅黑" panose="020B0503020204020204" pitchFamily="34" charset="-122"/>
-                <a:cs typeface="Consolas" panose="020B0609020204030204" pitchFamily="49" charset="0"/>
-                <a:sym typeface="+mn-ea"/>
-              </a:rPr>
-              <a:t>else</a:t>
-            </a:r>
-            <a:r>
-              <a:rPr lang="en" altLang="zh-CN" sz="1600" b="1" kern="100" dirty="0">
-                <a:solidFill>
-                  <a:schemeClr val="bg1"/>
-                </a:solidFill>
-                <a:latin typeface="Consolas" panose="020B0609020204030204" pitchFamily="49" charset="0"/>
+                <a:latin typeface="Aptos Display" panose="020B0004020202020204" pitchFamily="34" charset="0"/>
                 <a:ea typeface="微软雅黑" panose="020B0503020204020204" pitchFamily="34" charset="-122"/>
                 <a:cs typeface="Consolas" panose="020B0609020204030204" pitchFamily="49" charset="0"/>
               </a:rPr>
@@ -14622,7 +14900,7 @@
               <a:solidFill>
                 <a:schemeClr val="bg1"/>
               </a:solidFill>
-              <a:latin typeface="Consolas" panose="020B0609020204030204" pitchFamily="49" charset="0"/>
+              <a:latin typeface="Aptos Display" panose="020B0004020202020204" pitchFamily="34" charset="0"/>
               <a:ea typeface="微软雅黑" panose="020B0503020204020204" pitchFamily="34" charset="-122"/>
               <a:cs typeface="Consolas" panose="020B0609020204030204" pitchFamily="49" charset="0"/>
             </a:endParaRPr>
@@ -14643,7 +14921,7 @@
                 <a:solidFill>
                   <a:schemeClr val="bg1"/>
                 </a:solidFill>
-                <a:latin typeface="Consolas" panose="020B0609020204030204" pitchFamily="49" charset="0"/>
+                <a:latin typeface="Aptos Display" panose="020B0004020202020204" pitchFamily="34" charset="0"/>
                 <a:ea typeface="微软雅黑" panose="020B0503020204020204" pitchFamily="34" charset="-122"/>
                 <a:cs typeface="Consolas" panose="020B0609020204030204" pitchFamily="49" charset="0"/>
               </a:rPr>
@@ -14653,7 +14931,7 @@
               <a:solidFill>
                 <a:schemeClr val="bg1"/>
               </a:solidFill>
-              <a:latin typeface="Consolas" panose="020B0609020204030204" pitchFamily="49" charset="0"/>
+              <a:latin typeface="Aptos Display" panose="020B0004020202020204" pitchFamily="34" charset="0"/>
               <a:ea typeface="微软雅黑" panose="020B0503020204020204" pitchFamily="34" charset="-122"/>
               <a:cs typeface="Consolas" panose="020B0609020204030204" pitchFamily="49" charset="0"/>
             </a:endParaRPr>
@@ -14995,8 +15273,7 @@
                 <a:solidFill>
                   <a:schemeClr val="bg1"/>
                 </a:solidFill>
-                <a:latin typeface="Consolas" panose="020B0609020204030204" pitchFamily="49" charset="0"/>
-                <a:ea typeface="微软雅黑" panose="020B0503020204020204" pitchFamily="34" charset="-122"/>
+                <a:latin typeface="Aptos Display" panose="020B0004020202020204" pitchFamily="34" charset="0"/>
                 <a:cs typeface="Consolas" panose="020B0609020204030204" pitchFamily="49" charset="0"/>
               </a:rPr>
               <a:t>An expression can always evaluate to a value:</a:t>
@@ -15021,7 +15298,7 @@
                 <a:solidFill>
                   <a:schemeClr val="bg1"/>
                 </a:solidFill>
-                <a:latin typeface="Consolas" panose="020B0609020204030204" pitchFamily="49" charset="0"/>
+                <a:latin typeface="Aptos Display" panose="020B0004020202020204" pitchFamily="34" charset="0"/>
                 <a:ea typeface="微软雅黑" panose="020B0503020204020204" pitchFamily="34" charset="-122"/>
                 <a:cs typeface="Consolas" panose="020B0609020204030204" pitchFamily="49" charset="0"/>
               </a:rPr>
@@ -15032,7 +15309,7 @@
                 <a:solidFill>
                   <a:schemeClr val="bg1"/>
                 </a:solidFill>
-                <a:latin typeface="Consolas" panose="020B0609020204030204" pitchFamily="49" charset="0"/>
+                <a:latin typeface="Aptos Display" panose="020B0004020202020204" pitchFamily="34" charset="0"/>
                 <a:ea typeface="微软雅黑" panose="020B0503020204020204" pitchFamily="34" charset="-122"/>
                 <a:cs typeface="Consolas" panose="020B0609020204030204" pitchFamily="49" charset="0"/>
               </a:rPr>
@@ -15043,7 +15320,7 @@
                 <a:solidFill>
                   <a:schemeClr val="bg1"/>
                 </a:solidFill>
-                <a:latin typeface="Consolas" panose="020B0609020204030204" pitchFamily="49" charset="0"/>
+                <a:latin typeface="Aptos Display" panose="020B0004020202020204" pitchFamily="34" charset="0"/>
                 <a:ea typeface="微软雅黑" panose="020B0503020204020204" pitchFamily="34" charset="-122"/>
                 <a:cs typeface="Consolas" panose="020B0609020204030204" pitchFamily="49" charset="0"/>
               </a:rPr>
@@ -15054,7 +15331,7 @@
                 <a:solidFill>
                   <a:schemeClr val="bg1"/>
                 </a:solidFill>
-                <a:latin typeface="Consolas" panose="020B0609020204030204" pitchFamily="49" charset="0"/>
+                <a:latin typeface="Aptos Display" panose="020B0004020202020204" pitchFamily="34" charset="0"/>
                 <a:ea typeface="微软雅黑" panose="020B0503020204020204" pitchFamily="34" charset="-122"/>
                 <a:cs typeface="Consolas" panose="020B0609020204030204" pitchFamily="49" charset="0"/>
               </a:rPr>
@@ -15065,7 +15342,7 @@
                 <a:solidFill>
                   <a:schemeClr val="bg1"/>
                 </a:solidFill>
-                <a:latin typeface="Consolas" panose="020B0609020204030204" pitchFamily="49" charset="0"/>
+                <a:latin typeface="Aptos Display" panose="020B0004020202020204" pitchFamily="34" charset="0"/>
                 <a:ea typeface="微软雅黑" panose="020B0503020204020204" pitchFamily="34" charset="-122"/>
                 <a:cs typeface="Consolas" panose="020B0609020204030204" pitchFamily="49" charset="0"/>
               </a:rPr>
@@ -15091,7 +15368,7 @@
                 <a:solidFill>
                   <a:schemeClr val="bg1"/>
                 </a:solidFill>
-                <a:latin typeface="Consolas" panose="020B0609020204030204" pitchFamily="49" charset="0"/>
+                <a:latin typeface="Aptos Display" panose="020B0004020202020204" pitchFamily="34" charset="0"/>
                 <a:ea typeface="微软雅黑" panose="020B0503020204020204" pitchFamily="34" charset="-122"/>
                 <a:cs typeface="Consolas" panose="020B0609020204030204" pitchFamily="49" charset="0"/>
               </a:rPr>
@@ -15102,7 +15379,7 @@
                 <a:solidFill>
                   <a:schemeClr val="bg1"/>
                 </a:solidFill>
-                <a:latin typeface="Consolas" panose="020B0609020204030204" pitchFamily="49" charset="0"/>
+                <a:latin typeface="Aptos Display" panose="020B0004020202020204" pitchFamily="34" charset="0"/>
                 <a:ea typeface="微软雅黑" panose="020B0503020204020204" pitchFamily="34" charset="-122"/>
                 <a:cs typeface="Consolas" panose="020B0609020204030204" pitchFamily="49" charset="0"/>
               </a:rPr>
@@ -15112,7 +15389,7 @@
               <a:solidFill>
                 <a:schemeClr val="bg1"/>
               </a:solidFill>
-              <a:latin typeface="Consolas" panose="020B0609020204030204" pitchFamily="49" charset="0"/>
+              <a:latin typeface="Aptos Display" panose="020B0004020202020204" pitchFamily="34" charset="0"/>
               <a:ea typeface="微软雅黑" panose="020B0503020204020204" pitchFamily="34" charset="-122"/>
               <a:cs typeface="Consolas" panose="020B0609020204030204" pitchFamily="49" charset="0"/>
             </a:endParaRPr>
@@ -15146,7 +15423,7 @@
                 <a:solidFill>
                   <a:schemeClr val="bg1"/>
                 </a:solidFill>
-                <a:latin typeface="Consolas" panose="020B0609020204030204" pitchFamily="49" charset="0"/>
+                <a:latin typeface="Aptos Display" panose="020B0004020202020204" pitchFamily="34" charset="0"/>
                 <a:ea typeface="微软雅黑" panose="020B0503020204020204" pitchFamily="34" charset="-122"/>
                 <a:cs typeface="Consolas" panose="020B0609020204030204" pitchFamily="49" charset="0"/>
               </a:rPr>
@@ -15156,7 +15433,7 @@
               <a:solidFill>
                 <a:schemeClr val="bg1"/>
               </a:solidFill>
-              <a:latin typeface="Consolas" panose="020B0609020204030204" pitchFamily="49" charset="0"/>
+              <a:latin typeface="Aptos Display" panose="020B0004020202020204" pitchFamily="34" charset="0"/>
               <a:ea typeface="微软雅黑" panose="020B0503020204020204" pitchFamily="34" charset="-122"/>
               <a:cs typeface="Consolas" panose="020B0609020204030204" pitchFamily="49" charset="0"/>
             </a:endParaRPr>
@@ -15605,7 +15882,7 @@
         </p:nvSpPr>
         <p:spPr>
           <a:xfrm>
-            <a:off x="684323" y="2863263"/>
+            <a:off x="684323" y="2724961"/>
             <a:ext cx="4762999" cy="704039"/>
           </a:xfrm>
           <a:prstGeom prst="rect">
@@ -15645,7 +15922,7 @@
                 <a:solidFill>
                   <a:srgbClr val="008200"/>
                 </a:solidFill>
-                <a:latin typeface="Consolas" panose="020B0609020204030204" pitchFamily="49" charset="0"/>
+                <a:latin typeface="Aptos Display" panose="020B0004020202020204" pitchFamily="34" charset="0"/>
                 <a:cs typeface="+mn-cs"/>
               </a:rPr>
               <a:t>// </a:t>
@@ -15655,7 +15932,7 @@
                 <a:solidFill>
                   <a:srgbClr val="008200"/>
                 </a:solidFill>
-                <a:latin typeface="Consolas" panose="020B0609020204030204" pitchFamily="49" charset="0"/>
+                <a:latin typeface="Aptos Display" panose="020B0004020202020204" pitchFamily="34" charset="0"/>
                 <a:cs typeface="+mn-cs"/>
               </a:rPr>
               <a:t>First, define three variables:</a:t>
@@ -15664,7 +15941,7 @@
               <a:solidFill>
                 <a:srgbClr val="008200"/>
               </a:solidFill>
-              <a:latin typeface="Consolas" panose="020B0609020204030204" pitchFamily="49" charset="0"/>
+              <a:latin typeface="Aptos Display" panose="020B0004020202020204" pitchFamily="34" charset="0"/>
               <a:cs typeface="+mn-cs"/>
             </a:endParaRPr>
           </a:p>
@@ -15673,7 +15950,7 @@
               <a:buNone/>
             </a:pPr>
             <a:r>
-              <a:rPr lang="en" altLang="zh-CN" b="1" kern="1200" dirty="0">
+              <a:rPr lang="en" altLang="zh-CN" kern="1200" dirty="0">
                 <a:solidFill>
                   <a:srgbClr val="808080"/>
                 </a:solidFill>
@@ -15713,7 +15990,7 @@
         <p:spPr>
           <a:xfrm>
             <a:off x="6412448" y="1722925"/>
-            <a:ext cx="1789519" cy="1170641"/>
+            <a:ext cx="2034133" cy="1170641"/>
           </a:xfrm>
           <a:prstGeom prst="rect">
             <a:avLst/>
@@ -15749,12 +16026,12 @@
               <a:buNone/>
             </a:pPr>
             <a:r>
-              <a:rPr lang="en" altLang="zh-CN" sz="1200" b="1" kern="1200" dirty="0">
+              <a:rPr lang="en" altLang="zh-CN" sz="1200" kern="1200" dirty="0">
                 <a:solidFill>
                   <a:srgbClr val="006699"/>
                 </a:solidFill>
                 <a:latin typeface="Consolas" panose="020B0609020204030204" pitchFamily="49" charset="0"/>
-                <a:cs typeface="+mn-cs"/>
+                <a:cs typeface="Consolas" panose="020B0609020204030204" pitchFamily="49" charset="0"/>
               </a:rPr>
               <a:t>if </a:t>
             </a:r>
@@ -15798,6 +16075,17 @@
               <a:buNone/>
             </a:pPr>
             <a:r>
+              <a:rPr lang="zh-CN" altLang="en-US" sz="1200" dirty="0">
+                <a:solidFill>
+                  <a:schemeClr val="bg1"/>
+                </a:solidFill>
+                <a:latin typeface="Consolas" panose="020B0609020204030204" pitchFamily="49" charset="0"/>
+                <a:ea typeface="微软雅黑" panose="020B0503020204020204" charset="-122"/>
+                <a:cs typeface="Consolas" panose="020B0609020204030204" pitchFamily="49" charset="0"/>
+              </a:rPr>
+              <a:t>    </a:t>
+            </a:r>
+            <a:r>
               <a:rPr lang="en" altLang="zh-CN" sz="1200" dirty="0">
                 <a:solidFill>
                   <a:schemeClr val="bg1"/>
@@ -15806,7 +16094,7 @@
                 <a:ea typeface="微软雅黑" panose="020B0503020204020204" charset="-122"/>
                 <a:cs typeface="Consolas" panose="020B0609020204030204" pitchFamily="49" charset="0"/>
               </a:rPr>
-              <a:t>// do </a:t>
+              <a:t>//do </a:t>
             </a:r>
             <a:r>
               <a:rPr lang="en" altLang="zh-CN" sz="1200" dirty="0" err="1">
@@ -15817,7 +16105,7 @@
                 <a:ea typeface="微软雅黑" panose="020B0503020204020204" charset="-122"/>
                 <a:cs typeface="Consolas" panose="020B0609020204030204" pitchFamily="49" charset="0"/>
               </a:rPr>
-              <a:t>sth </a:t>
+              <a:t>sth</a:t>
             </a:r>
             <a:r>
               <a:rPr lang="en" altLang="zh-CN" sz="1200" dirty="0">
@@ -15873,7 +16161,7 @@
                 <a:ea typeface="微软雅黑" panose="020B0503020204020204" charset="-122"/>
                 <a:cs typeface="Consolas" panose="020B0609020204030204" pitchFamily="49" charset="0"/>
               </a:rPr>
-              <a:t>sth </a:t>
+              <a:t>sth</a:t>
             </a:r>
             <a:r>
               <a:rPr lang="en" altLang="zh-CN" sz="1200" dirty="0">
@@ -15884,7 +16172,7 @@
                 <a:ea typeface="微软雅黑" panose="020B0503020204020204" charset="-122"/>
                 <a:cs typeface="Consolas" panose="020B0609020204030204" pitchFamily="49" charset="0"/>
               </a:rPr>
-              <a:t>.after if</a:t>
+              <a:t> .after if</a:t>
             </a:r>
             <a:endParaRPr lang="en-US" altLang="zh-CN" sz="1200" dirty="0">
               <a:latin typeface="Consolas" panose="020B0609020204030204" pitchFamily="49" charset="0"/>
@@ -15909,9 +16197,9 @@
         <p:grpSpPr>
           <a:xfrm>
             <a:off x="8183006" y="1722925"/>
-            <a:ext cx="3292559" cy="821902"/>
+            <a:ext cx="3292559" cy="853850"/>
             <a:chOff x="5410787" y="1465739"/>
-            <a:chExt cx="5220576" cy="821902"/>
+            <a:chExt cx="5220576" cy="853850"/>
           </a:xfrm>
         </p:grpSpPr>
         <p:sp>
@@ -15929,7 +16217,7 @@
           <p:spPr>
             <a:xfrm>
               <a:off x="5410787" y="1699868"/>
-              <a:ext cx="1507071" cy="339004"/>
+              <a:ext cx="1507071" cy="619721"/>
             </a:xfrm>
             <a:prstGeom prst="rect">
               <a:avLst/>
@@ -15969,14 +16257,14 @@
                   <a:solidFill>
                     <a:schemeClr val="bg1"/>
                   </a:solidFill>
-                  <a:latin typeface="Consolas" panose="020B0609020204030204" pitchFamily="49" charset="0"/>
+                  <a:latin typeface="Aptos Display" panose="020B0004020202020204" pitchFamily="34" charset="0"/>
                   <a:ea typeface="微软雅黑" panose="020B0503020204020204" charset="-122"/>
                   <a:cs typeface="Consolas" panose="020B0609020204030204" pitchFamily="49" charset="0"/>
                 </a:rPr>
                 <a:t>value of expression</a:t>
               </a:r>
               <a:endParaRPr lang="en-US" altLang="zh-CN" sz="1200" dirty="0">
-                <a:latin typeface="Consolas" panose="020B0609020204030204" pitchFamily="49" charset="0"/>
+                <a:latin typeface="Aptos Display" panose="020B0004020202020204" pitchFamily="34" charset="0"/>
                 <a:ea typeface="微软雅黑" panose="020B0503020204020204" charset="-122"/>
                 <a:cs typeface="Consolas" panose="020B0609020204030204" pitchFamily="49" charset="0"/>
               </a:endParaRPr>
@@ -16024,7 +16312,7 @@
             <a:p>
               <a:pPr algn="ctr"/>
               <a:endParaRPr lang="zh-CN" altLang="en-US" sz="1050">
-                <a:latin typeface="Consolas" panose="020B0609020204030204" pitchFamily="49" charset="0"/>
+                <a:latin typeface="Aptos Display" panose="020B0004020202020204" pitchFamily="34" charset="0"/>
               </a:endParaRPr>
             </a:p>
           </p:txBody>
@@ -16044,7 +16332,7 @@
           <p:spPr>
             <a:xfrm>
               <a:off x="7101583" y="1465739"/>
-              <a:ext cx="3529780" cy="339004"/>
+              <a:ext cx="3529780" cy="342723"/>
             </a:xfrm>
             <a:prstGeom prst="rect">
               <a:avLst/>
@@ -16084,14 +16372,14 @@
                   <a:solidFill>
                     <a:schemeClr val="bg1"/>
                   </a:solidFill>
-                  <a:latin typeface="Consolas" panose="020B0609020204030204" pitchFamily="49" charset="0"/>
+                  <a:latin typeface="Aptos Display" panose="020B0004020202020204" pitchFamily="34" charset="0"/>
                   <a:ea typeface="微软雅黑" panose="020B0503020204020204" charset="-122"/>
                   <a:cs typeface="Consolas" panose="020B0609020204030204" pitchFamily="49" charset="0"/>
                 </a:rPr>
                 <a:t>True: Execute the logic within </a:t>
               </a:r>
               <a:endParaRPr lang="en-US" altLang="zh-CN" sz="1200" dirty="0">
-                <a:latin typeface="Consolas" panose="020B0609020204030204" pitchFamily="49" charset="0"/>
+                <a:latin typeface="Aptos Display" panose="020B0004020202020204" pitchFamily="34" charset="0"/>
                 <a:ea typeface="微软雅黑" panose="020B0503020204020204" charset="-122"/>
                 <a:cs typeface="Consolas" panose="020B0609020204030204" pitchFamily="49" charset="0"/>
               </a:endParaRPr>
@@ -16113,7 +16401,7 @@
           <p:spPr>
             <a:xfrm>
               <a:off x="7101583" y="1948637"/>
-              <a:ext cx="3529777" cy="339004"/>
+              <a:ext cx="3529777" cy="342723"/>
             </a:xfrm>
             <a:prstGeom prst="rect">
               <a:avLst/>
@@ -16153,14 +16441,14 @@
                   <a:solidFill>
                     <a:schemeClr val="bg1"/>
                   </a:solidFill>
-                  <a:latin typeface="Consolas" panose="020B0609020204030204" pitchFamily="49" charset="0"/>
+                  <a:latin typeface="Aptos Display" panose="020B0004020202020204" pitchFamily="34" charset="0"/>
                   <a:ea typeface="微软雅黑" panose="020B0503020204020204" charset="-122"/>
                   <a:cs typeface="Consolas" panose="020B0609020204030204" pitchFamily="49" charset="0"/>
                 </a:rPr>
                 <a:t>False: execute the logic after </a:t>
               </a:r>
               <a:endParaRPr lang="en-US" altLang="zh-CN" sz="1200" dirty="0">
-                <a:latin typeface="Consolas" panose="020B0609020204030204" pitchFamily="49" charset="0"/>
+                <a:latin typeface="Aptos Display" panose="020B0004020202020204" pitchFamily="34" charset="0"/>
                 <a:ea typeface="微软雅黑" panose="020B0503020204020204" charset="-122"/>
                 <a:cs typeface="Consolas" panose="020B0609020204030204" pitchFamily="49" charset="0"/>
               </a:endParaRPr>
@@ -16218,12 +16506,12 @@
               <a:buNone/>
             </a:pPr>
             <a:r>
-              <a:rPr lang="en" altLang="zh-CN" sz="1200" b="1" kern="1200" dirty="0">
+              <a:rPr lang="en" altLang="zh-CN" sz="1200" kern="1200" dirty="0">
                 <a:solidFill>
                   <a:srgbClr val="006699"/>
                 </a:solidFill>
                 <a:latin typeface="Consolas" panose="020B0609020204030204" pitchFamily="49" charset="0"/>
-                <a:cs typeface="+mn-cs"/>
+                <a:cs typeface="Consolas" panose="020B0609020204030204" pitchFamily="49" charset="0"/>
               </a:rPr>
               <a:t>if </a:t>
             </a:r>
@@ -16266,6 +16554,17 @@
               <a:buNone/>
             </a:pPr>
             <a:r>
+              <a:rPr lang="zh-CN" altLang="en-US" sz="1200" dirty="0">
+                <a:solidFill>
+                  <a:schemeClr val="bg1"/>
+                </a:solidFill>
+                <a:latin typeface="Consolas" panose="020B0609020204030204" pitchFamily="49" charset="0"/>
+                <a:ea typeface="微软雅黑" panose="020B0503020204020204" charset="-122"/>
+                <a:cs typeface="Consolas" panose="020B0609020204030204" pitchFamily="49" charset="0"/>
+              </a:rPr>
+              <a:t>    </a:t>
+            </a:r>
+            <a:r>
               <a:rPr lang="en" altLang="zh-CN" sz="1200" dirty="0">
                 <a:solidFill>
                   <a:schemeClr val="bg1"/>
@@ -16274,7 +16573,7 @@
                 <a:ea typeface="微软雅黑" panose="020B0503020204020204" charset="-122"/>
                 <a:cs typeface="Consolas" panose="020B0609020204030204" pitchFamily="49" charset="0"/>
               </a:rPr>
-              <a:t>// do </a:t>
+              <a:t>//do </a:t>
             </a:r>
             <a:r>
               <a:rPr lang="en" altLang="zh-CN" sz="1200" dirty="0" err="1">
@@ -16285,7 +16584,7 @@
                 <a:ea typeface="微软雅黑" panose="020B0503020204020204" charset="-122"/>
                 <a:cs typeface="Consolas" panose="020B0609020204030204" pitchFamily="49" charset="0"/>
               </a:rPr>
-              <a:t>sth </a:t>
+              <a:t>sth</a:t>
             </a:r>
             <a:r>
               <a:rPr lang="en" altLang="zh-CN" sz="1200" dirty="0">
@@ -16312,17 +16611,17 @@
                 <a:ea typeface="微软雅黑" panose="020B0503020204020204" charset="-122"/>
                 <a:cs typeface="Consolas" panose="020B0609020204030204" pitchFamily="49" charset="0"/>
               </a:rPr>
-              <a:t>} </a:t>
-            </a:r>
-            <a:r>
-              <a:rPr lang="en" altLang="zh-CN" sz="1200" b="1" kern="1200" dirty="0">
+              <a:t>}</a:t>
+            </a:r>
+            <a:r>
+              <a:rPr lang="en" altLang="zh-CN" sz="1200" kern="1200" dirty="0">
                 <a:solidFill>
                   <a:srgbClr val="006699"/>
                 </a:solidFill>
                 <a:latin typeface="Consolas" panose="020B0609020204030204" pitchFamily="49" charset="0"/>
-                <a:cs typeface="+mn-cs"/>
-              </a:rPr>
-              <a:t>else </a:t>
+                <a:cs typeface="Consolas" panose="020B0609020204030204" pitchFamily="49" charset="0"/>
+              </a:rPr>
+              <a:t>else</a:t>
             </a:r>
             <a:r>
               <a:rPr lang="en" altLang="zh-CN" sz="1200" dirty="0">
@@ -16341,6 +16640,17 @@
               <a:buNone/>
             </a:pPr>
             <a:r>
+              <a:rPr lang="zh-CN" altLang="en-US" sz="1200" dirty="0">
+                <a:solidFill>
+                  <a:schemeClr val="bg1"/>
+                </a:solidFill>
+                <a:latin typeface="Consolas" panose="020B0609020204030204" pitchFamily="49" charset="0"/>
+                <a:ea typeface="微软雅黑" panose="020B0503020204020204" charset="-122"/>
+                <a:cs typeface="Consolas" panose="020B0609020204030204" pitchFamily="49" charset="0"/>
+              </a:rPr>
+              <a:t>    </a:t>
+            </a:r>
+            <a:r>
               <a:rPr lang="en" altLang="zh-CN" sz="1200" dirty="0">
                 <a:solidFill>
                   <a:schemeClr val="bg1"/>
@@ -16349,7 +16659,7 @@
                 <a:ea typeface="微软雅黑" panose="020B0503020204020204" charset="-122"/>
                 <a:cs typeface="Consolas" panose="020B0609020204030204" pitchFamily="49" charset="0"/>
               </a:rPr>
-              <a:t>// do </a:t>
+              <a:t>//do </a:t>
             </a:r>
             <a:r>
               <a:rPr lang="en" altLang="zh-CN" sz="1200" dirty="0" err="1">
@@ -16360,7 +16670,7 @@
                 <a:ea typeface="微软雅黑" panose="020B0503020204020204" charset="-122"/>
                 <a:cs typeface="Consolas" panose="020B0609020204030204" pitchFamily="49" charset="0"/>
               </a:rPr>
-              <a:t>sth </a:t>
+              <a:t>sth</a:t>
             </a:r>
             <a:r>
               <a:rPr lang="en" altLang="zh-CN" sz="1200" dirty="0">
@@ -16407,9 +16717,9 @@
         <p:grpSpPr>
           <a:xfrm>
             <a:off x="8179129" y="3238354"/>
-            <a:ext cx="3422685" cy="821902"/>
+            <a:ext cx="3422685" cy="862441"/>
             <a:chOff x="5404642" y="1465739"/>
-            <a:chExt cx="5426900" cy="821902"/>
+            <a:chExt cx="5426900" cy="862441"/>
           </a:xfrm>
         </p:grpSpPr>
         <p:sp>
@@ -16427,7 +16737,7 @@
           <p:spPr>
             <a:xfrm>
               <a:off x="5404642" y="1708459"/>
-              <a:ext cx="1507071" cy="339004"/>
+              <a:ext cx="1507071" cy="619721"/>
             </a:xfrm>
             <a:prstGeom prst="rect">
               <a:avLst/>
@@ -16467,14 +16777,14 @@
                   <a:solidFill>
                     <a:schemeClr val="bg1"/>
                   </a:solidFill>
-                  <a:latin typeface="Consolas" panose="020B0609020204030204" pitchFamily="49" charset="0"/>
+                  <a:latin typeface="Aptos Display" panose="020B0004020202020204" pitchFamily="34" charset="0"/>
                   <a:ea typeface="微软雅黑" panose="020B0503020204020204" charset="-122"/>
                   <a:cs typeface="Consolas" panose="020B0609020204030204" pitchFamily="49" charset="0"/>
                 </a:rPr>
                 <a:t>value of expression</a:t>
               </a:r>
               <a:endParaRPr lang="en-US" altLang="zh-CN" sz="1200" dirty="0">
-                <a:latin typeface="Consolas" panose="020B0609020204030204" pitchFamily="49" charset="0"/>
+                <a:latin typeface="Aptos Display" panose="020B0004020202020204" pitchFamily="34" charset="0"/>
                 <a:ea typeface="微软雅黑" panose="020B0503020204020204" charset="-122"/>
                 <a:cs typeface="Consolas" panose="020B0609020204030204" pitchFamily="49" charset="0"/>
               </a:endParaRPr>
@@ -16522,7 +16832,7 @@
             <a:p>
               <a:pPr algn="ctr"/>
               <a:endParaRPr lang="zh-CN" altLang="en-US" sz="1050">
-                <a:latin typeface="Consolas" panose="020B0609020204030204" pitchFamily="49" charset="0"/>
+                <a:latin typeface="Aptos Display" panose="020B0004020202020204" pitchFamily="34" charset="0"/>
               </a:endParaRPr>
             </a:p>
           </p:txBody>
@@ -16542,7 +16852,7 @@
           <p:spPr>
             <a:xfrm>
               <a:off x="7101582" y="1465739"/>
-              <a:ext cx="3529781" cy="339004"/>
+              <a:ext cx="3529781" cy="342723"/>
             </a:xfrm>
             <a:prstGeom prst="rect">
               <a:avLst/>
@@ -16582,14 +16892,14 @@
                   <a:solidFill>
                     <a:schemeClr val="bg1"/>
                   </a:solidFill>
-                  <a:latin typeface="Consolas" panose="020B0609020204030204" pitchFamily="49" charset="0"/>
+                  <a:latin typeface="Aptos Display" panose="020B0004020202020204" pitchFamily="34" charset="0"/>
                   <a:ea typeface="微软雅黑" panose="020B0503020204020204" charset="-122"/>
                   <a:cs typeface="Consolas" panose="020B0609020204030204" pitchFamily="49" charset="0"/>
                 </a:rPr>
                 <a:t>True: Execute the logic within </a:t>
               </a:r>
               <a:endParaRPr lang="en-US" altLang="zh-CN" sz="1200" dirty="0">
-                <a:latin typeface="Consolas" panose="020B0609020204030204" pitchFamily="49" charset="0"/>
+                <a:latin typeface="Aptos Display" panose="020B0004020202020204" pitchFamily="34" charset="0"/>
                 <a:ea typeface="微软雅黑" panose="020B0503020204020204" charset="-122"/>
                 <a:cs typeface="Consolas" panose="020B0609020204030204" pitchFamily="49" charset="0"/>
               </a:endParaRPr>
@@ -16611,7 +16921,7 @@
           <p:spPr>
             <a:xfrm>
               <a:off x="7101582" y="1948637"/>
-              <a:ext cx="3729960" cy="339004"/>
+              <a:ext cx="3729960" cy="342723"/>
             </a:xfrm>
             <a:prstGeom prst="rect">
               <a:avLst/>
@@ -16651,14 +16961,14 @@
                   <a:solidFill>
                     <a:schemeClr val="bg1"/>
                   </a:solidFill>
-                  <a:latin typeface="Consolas" panose="020B0609020204030204" pitchFamily="49" charset="0"/>
+                  <a:latin typeface="Aptos Display" panose="020B0004020202020204" pitchFamily="34" charset="0"/>
                   <a:ea typeface="微软雅黑" panose="020B0503020204020204" charset="-122"/>
                   <a:cs typeface="Consolas" panose="020B0609020204030204" pitchFamily="49" charset="0"/>
                 </a:rPr>
                 <a:t>False: execute the logic within the </a:t>
               </a:r>
               <a:endParaRPr lang="en-US" altLang="zh-CN" sz="1200" dirty="0">
-                <a:latin typeface="Consolas" panose="020B0609020204030204" pitchFamily="49" charset="0"/>
+                <a:latin typeface="Aptos Display" panose="020B0004020202020204" pitchFamily="34" charset="0"/>
                 <a:ea typeface="微软雅黑" panose="020B0503020204020204" charset="-122"/>
                 <a:cs typeface="Consolas" panose="020B0609020204030204" pitchFamily="49" charset="0"/>
               </a:endParaRPr>
@@ -16793,8 +17103,8 @@
         </p:nvSpPr>
         <p:spPr>
           <a:xfrm>
-            <a:off x="7268308" y="1419167"/>
-            <a:ext cx="4758939" cy="5051126"/>
+            <a:off x="7460673" y="1419167"/>
+            <a:ext cx="4052454" cy="4038221"/>
           </a:xfrm>
           <a:prstGeom prst="rect">
             <a:avLst/>
@@ -16821,7 +17131,7 @@
                     <a:lumMod val="75000"/>
                   </a:schemeClr>
                 </a:solidFill>
-                <a:latin typeface="Consolas" panose="020B0609020204030204" pitchFamily="49" charset="0"/>
+                <a:latin typeface="Aptos Display" panose="020B0004020202020204" pitchFamily="34" charset="0"/>
                 <a:ea typeface="微软雅黑" panose="020B0503020204020204" pitchFamily="34" charset="-122"/>
                 <a:cs typeface="Consolas" panose="020B0609020204030204" pitchFamily="49" charset="0"/>
                 <a:sym typeface="+mn-ea"/>
@@ -16833,7 +17143,7 @@
                 <a:solidFill>
                   <a:prstClr val="black"/>
                 </a:solidFill>
-                <a:latin typeface="Consolas" panose="020B0609020204030204" pitchFamily="49" charset="0"/>
+                <a:latin typeface="Aptos Display" panose="020B0004020202020204" pitchFamily="34" charset="0"/>
                 <a:ea typeface="微软雅黑" panose="020B0503020204020204" pitchFamily="34" charset="-122"/>
                 <a:cs typeface="Consolas" panose="020B0609020204030204" pitchFamily="49" charset="0"/>
                 <a:sym typeface="+mn-ea"/>
@@ -16847,7 +17157,7 @@
                     <a:lumMod val="75000"/>
                   </a:schemeClr>
                 </a:solidFill>
-                <a:latin typeface="Consolas" panose="020B0609020204030204" pitchFamily="49" charset="0"/>
+                <a:latin typeface="Aptos Display" panose="020B0004020202020204" pitchFamily="34" charset="0"/>
                 <a:ea typeface="微软雅黑" panose="020B0503020204020204" pitchFamily="34" charset="-122"/>
                 <a:cs typeface="Consolas" panose="020B0609020204030204" pitchFamily="49" charset="0"/>
                 <a:sym typeface="+mn-ea"/>
@@ -16859,7 +17169,7 @@
                 <a:solidFill>
                   <a:prstClr val="black"/>
                 </a:solidFill>
-                <a:latin typeface="Consolas" panose="020B0609020204030204" pitchFamily="49" charset="0"/>
+                <a:latin typeface="Aptos Display" panose="020B0004020202020204" pitchFamily="34" charset="0"/>
                 <a:ea typeface="微软雅黑" panose="020B0503020204020204" pitchFamily="34" charset="-122"/>
                 <a:cs typeface="Consolas" panose="020B0609020204030204" pitchFamily="49" charset="0"/>
                 <a:sym typeface="+mn-ea"/>
@@ -16873,7 +17183,7 @@
                     <a:lumMod val="75000"/>
                   </a:schemeClr>
                 </a:solidFill>
-                <a:latin typeface="Consolas" panose="020B0609020204030204" pitchFamily="49" charset="0"/>
+                <a:latin typeface="Aptos Display" panose="020B0004020202020204" pitchFamily="34" charset="0"/>
                 <a:ea typeface="微软雅黑" panose="020B0503020204020204" pitchFamily="34" charset="-122"/>
                 <a:cs typeface="Consolas" panose="020B0609020204030204" pitchFamily="49" charset="0"/>
                 <a:sym typeface="+mn-ea"/>
@@ -16885,7 +17195,7 @@
                 <a:solidFill>
                   <a:prstClr val="black"/>
                 </a:solidFill>
-                <a:latin typeface="Consolas" panose="020B0609020204030204" pitchFamily="49" charset="0"/>
+                <a:latin typeface="Aptos Display" panose="020B0004020202020204" pitchFamily="34" charset="0"/>
                 <a:ea typeface="微软雅黑" panose="020B0503020204020204" pitchFamily="34" charset="-122"/>
                 <a:cs typeface="Consolas" panose="020B0609020204030204" pitchFamily="49" charset="0"/>
                 <a:sym typeface="+mn-ea"/>
@@ -16899,7 +17209,7 @@
                     <a:lumMod val="75000"/>
                   </a:schemeClr>
                 </a:solidFill>
-                <a:latin typeface="Consolas" panose="020B0609020204030204" pitchFamily="49" charset="0"/>
+                <a:latin typeface="Aptos Display" panose="020B0004020202020204" pitchFamily="34" charset="0"/>
                 <a:ea typeface="微软雅黑" panose="020B0503020204020204" pitchFamily="34" charset="-122"/>
                 <a:cs typeface="Consolas" panose="020B0609020204030204" pitchFamily="49" charset="0"/>
                 <a:sym typeface="+mn-ea"/>
@@ -16911,7 +17221,7 @@
                 <a:solidFill>
                   <a:prstClr val="black"/>
                 </a:solidFill>
-                <a:latin typeface="Consolas" panose="020B0609020204030204" pitchFamily="49" charset="0"/>
+                <a:latin typeface="Aptos Display" panose="020B0004020202020204" pitchFamily="34" charset="0"/>
                 <a:ea typeface="微软雅黑" panose="020B0503020204020204" pitchFamily="34" charset="-122"/>
                 <a:cs typeface="Consolas" panose="020B0609020204030204" pitchFamily="49" charset="0"/>
                 <a:sym typeface="+mn-ea"/>
@@ -16925,7 +17235,7 @@
                     <a:lumMod val="75000"/>
                   </a:schemeClr>
                 </a:solidFill>
-                <a:latin typeface="Consolas" panose="020B0609020204030204" pitchFamily="49" charset="0"/>
+                <a:latin typeface="Aptos Display" panose="020B0004020202020204" pitchFamily="34" charset="0"/>
                 <a:ea typeface="微软雅黑" panose="020B0503020204020204" pitchFamily="34" charset="-122"/>
                 <a:cs typeface="Consolas" panose="020B0609020204030204" pitchFamily="49" charset="0"/>
                 <a:sym typeface="+mn-ea"/>
@@ -16937,7 +17247,7 @@
                 <a:solidFill>
                   <a:prstClr val="black"/>
                 </a:solidFill>
-                <a:latin typeface="Consolas" panose="020B0609020204030204" pitchFamily="49" charset="0"/>
+                <a:latin typeface="Aptos Display" panose="020B0004020202020204" pitchFamily="34" charset="0"/>
                 <a:ea typeface="微软雅黑" panose="020B0503020204020204" pitchFamily="34" charset="-122"/>
                 <a:cs typeface="Consolas" panose="020B0609020204030204" pitchFamily="49" charset="0"/>
                 <a:sym typeface="+mn-ea"/>
@@ -16951,7 +17261,7 @@
                     <a:lumMod val="75000"/>
                   </a:schemeClr>
                 </a:solidFill>
-                <a:latin typeface="Consolas" panose="020B0609020204030204" pitchFamily="49" charset="0"/>
+                <a:latin typeface="Aptos Display" panose="020B0004020202020204" pitchFamily="34" charset="0"/>
                 <a:ea typeface="微软雅黑" panose="020B0503020204020204" pitchFamily="34" charset="-122"/>
                 <a:cs typeface="Consolas" panose="020B0609020204030204" pitchFamily="49" charset="0"/>
                 <a:sym typeface="+mn-ea"/>
@@ -16963,7 +17273,7 @@
                 <a:solidFill>
                   <a:prstClr val="black"/>
                 </a:solidFill>
-                <a:latin typeface="Consolas" panose="020B0609020204030204" pitchFamily="49" charset="0"/>
+                <a:latin typeface="Aptos Display" panose="020B0004020202020204" pitchFamily="34" charset="0"/>
                 <a:ea typeface="微软雅黑" panose="020B0503020204020204" pitchFamily="34" charset="-122"/>
                 <a:cs typeface="Consolas" panose="020B0609020204030204" pitchFamily="49" charset="0"/>
                 <a:sym typeface="+mn-ea"/>
@@ -16977,7 +17287,7 @@
                     <a:lumMod val="75000"/>
                   </a:schemeClr>
                 </a:solidFill>
-                <a:latin typeface="Consolas" panose="020B0609020204030204" pitchFamily="49" charset="0"/>
+                <a:latin typeface="Aptos Display" panose="020B0004020202020204" pitchFamily="34" charset="0"/>
                 <a:ea typeface="微软雅黑" panose="020B0503020204020204" pitchFamily="34" charset="-122"/>
                 <a:cs typeface="Consolas" panose="020B0609020204030204" pitchFamily="49" charset="0"/>
                 <a:sym typeface="+mn-ea"/>
@@ -16988,7 +17298,7 @@
               <a:solidFill>
                 <a:prstClr val="black"/>
               </a:solidFill>
-              <a:latin typeface="Consolas" panose="020B0609020204030204" pitchFamily="49" charset="0"/>
+              <a:latin typeface="Aptos Display" panose="020B0004020202020204" pitchFamily="34" charset="0"/>
               <a:ea typeface="微软雅黑" panose="020B0503020204020204" pitchFamily="34" charset="-122"/>
               <a:cs typeface="Consolas" panose="020B0609020204030204" pitchFamily="49" charset="0"/>
             </a:endParaRPr>
@@ -17006,7 +17316,7 @@
                 <a:solidFill>
                   <a:prstClr val="black"/>
                 </a:solidFill>
-                <a:latin typeface="Consolas" panose="020B0609020204030204" pitchFamily="49" charset="0"/>
+                <a:latin typeface="Aptos Display" panose="020B0004020202020204" pitchFamily="34" charset="0"/>
                 <a:ea typeface="微软雅黑" panose="020B0503020204020204" pitchFamily="34" charset="-122"/>
                 <a:cs typeface="Consolas" panose="020B0609020204030204" pitchFamily="49" charset="0"/>
               </a:rPr>
@@ -17017,7 +17327,7 @@
                 <a:solidFill>
                   <a:prstClr val="black"/>
                 </a:solidFill>
-                <a:latin typeface="Consolas" panose="020B0609020204030204" pitchFamily="49" charset="0"/>
+                <a:latin typeface="Aptos Display" panose="020B0004020202020204" pitchFamily="34" charset="0"/>
                 <a:ea typeface="微软雅黑" panose="020B0503020204020204" pitchFamily="34" charset="-122"/>
                 <a:cs typeface="Consolas" panose="020B0609020204030204" pitchFamily="49" charset="0"/>
                 <a:sym typeface="+mn-ea"/>
@@ -17031,7 +17341,7 @@
                     <a:lumMod val="75000"/>
                   </a:schemeClr>
                 </a:solidFill>
-                <a:latin typeface="Consolas" panose="020B0609020204030204" pitchFamily="49" charset="0"/>
+                <a:latin typeface="Aptos Display" panose="020B0004020202020204" pitchFamily="34" charset="0"/>
                 <a:ea typeface="微软雅黑" panose="020B0503020204020204" pitchFamily="34" charset="-122"/>
                 <a:cs typeface="Consolas" panose="020B0609020204030204" pitchFamily="49" charset="0"/>
                 <a:sym typeface="+mn-ea"/>
@@ -17043,7 +17353,7 @@
                 <a:solidFill>
                   <a:prstClr val="black"/>
                 </a:solidFill>
-                <a:latin typeface="Consolas" panose="020B0609020204030204" pitchFamily="49" charset="0"/>
+                <a:latin typeface="Aptos Display" panose="020B0004020202020204" pitchFamily="34" charset="0"/>
                 <a:ea typeface="微软雅黑" panose="020B0503020204020204" pitchFamily="34" charset="-122"/>
                 <a:cs typeface="Consolas" panose="020B0609020204030204" pitchFamily="49" charset="0"/>
               </a:rPr>
@@ -17053,7 +17363,7 @@
               <a:solidFill>
                 <a:prstClr val="black"/>
               </a:solidFill>
-              <a:latin typeface="Consolas" panose="020B0609020204030204" pitchFamily="49" charset="0"/>
+              <a:latin typeface="Aptos Display" panose="020B0004020202020204" pitchFamily="34" charset="0"/>
               <a:ea typeface="微软雅黑" panose="020B0503020204020204" pitchFamily="34" charset="-122"/>
               <a:cs typeface="Consolas" panose="020B0609020204030204" pitchFamily="49" charset="0"/>
             </a:endParaRPr>
@@ -17071,7 +17381,7 @@
                 <a:solidFill>
                   <a:prstClr val="black"/>
                 </a:solidFill>
-                <a:latin typeface="Consolas" panose="020B0609020204030204" pitchFamily="49" charset="0"/>
+                <a:latin typeface="Aptos Display" panose="020B0004020202020204" pitchFamily="34" charset="0"/>
                 <a:ea typeface="微软雅黑" panose="020B0503020204020204" pitchFamily="34" charset="-122"/>
                 <a:cs typeface="Consolas" panose="020B0609020204030204" pitchFamily="49" charset="0"/>
               </a:rPr>
@@ -17084,7 +17394,7 @@
                     <a:lumMod val="75000"/>
                   </a:schemeClr>
                 </a:solidFill>
-                <a:latin typeface="Consolas" panose="020B0609020204030204" pitchFamily="49" charset="0"/>
+                <a:latin typeface="Aptos Display" panose="020B0004020202020204" pitchFamily="34" charset="0"/>
                 <a:ea typeface="微软雅黑" panose="020B0503020204020204" pitchFamily="34" charset="-122"/>
                 <a:cs typeface="Consolas" panose="020B0609020204030204" pitchFamily="49" charset="0"/>
               </a:rPr>
@@ -17095,7 +17405,7 @@
                 <a:solidFill>
                   <a:prstClr val="black"/>
                 </a:solidFill>
-                <a:latin typeface="Consolas" panose="020B0609020204030204" pitchFamily="49" charset="0"/>
+                <a:latin typeface="Aptos Display" panose="020B0004020202020204" pitchFamily="34" charset="0"/>
                 <a:ea typeface="微软雅黑" panose="020B0503020204020204" pitchFamily="34" charset="-122"/>
                 <a:cs typeface="Consolas" panose="020B0609020204030204" pitchFamily="49" charset="0"/>
               </a:rPr>
@@ -17108,7 +17418,7 @@
                     <a:lumMod val="75000"/>
                   </a:schemeClr>
                 </a:solidFill>
-                <a:latin typeface="Consolas" panose="020B0609020204030204" pitchFamily="49" charset="0"/>
+                <a:latin typeface="Aptos Display" panose="020B0004020202020204" pitchFamily="34" charset="0"/>
                 <a:ea typeface="微软雅黑" panose="020B0503020204020204" pitchFamily="34" charset="-122"/>
                 <a:cs typeface="Consolas" panose="020B0609020204030204" pitchFamily="49" charset="0"/>
               </a:rPr>
@@ -17119,7 +17429,7 @@
                 <a:solidFill>
                   <a:prstClr val="black"/>
                 </a:solidFill>
-                <a:latin typeface="Consolas" panose="020B0609020204030204" pitchFamily="49" charset="0"/>
+                <a:latin typeface="Aptos Display" panose="020B0004020202020204" pitchFamily="34" charset="0"/>
                 <a:ea typeface="微软雅黑" panose="020B0503020204020204" pitchFamily="34" charset="-122"/>
                 <a:cs typeface="Consolas" panose="020B0609020204030204" pitchFamily="49" charset="0"/>
               </a:rPr>
@@ -17132,7 +17442,7 @@
                     <a:lumMod val="75000"/>
                   </a:schemeClr>
                 </a:solidFill>
-                <a:latin typeface="Consolas" panose="020B0609020204030204" pitchFamily="49" charset="0"/>
+                <a:latin typeface="Aptos Display" panose="020B0004020202020204" pitchFamily="34" charset="0"/>
                 <a:ea typeface="微软雅黑" panose="020B0503020204020204" pitchFamily="34" charset="-122"/>
                 <a:cs typeface="Consolas" panose="020B0609020204030204" pitchFamily="49" charset="0"/>
               </a:rPr>
@@ -17143,7 +17453,7 @@
                 <a:solidFill>
                   <a:prstClr val="black"/>
                 </a:solidFill>
-                <a:latin typeface="Consolas" panose="020B0609020204030204" pitchFamily="49" charset="0"/>
+                <a:latin typeface="Aptos Display" panose="020B0004020202020204" pitchFamily="34" charset="0"/>
                 <a:ea typeface="微软雅黑" panose="020B0503020204020204" pitchFamily="34" charset="-122"/>
                 <a:cs typeface="Consolas" panose="020B0609020204030204" pitchFamily="49" charset="0"/>
               </a:rPr>
@@ -17156,7 +17466,7 @@
                     <a:lumMod val="75000"/>
                   </a:schemeClr>
                 </a:solidFill>
-                <a:latin typeface="Consolas" panose="020B0609020204030204" pitchFamily="49" charset="0"/>
+                <a:latin typeface="Aptos Display" panose="020B0004020202020204" pitchFamily="34" charset="0"/>
                 <a:ea typeface="微软雅黑" panose="020B0503020204020204" pitchFamily="34" charset="-122"/>
                 <a:cs typeface="Consolas" panose="020B0609020204030204" pitchFamily="49" charset="0"/>
               </a:rPr>
@@ -17167,7 +17477,7 @@
                 <a:solidFill>
                   <a:prstClr val="black"/>
                 </a:solidFill>
-                <a:latin typeface="Consolas" panose="020B0609020204030204" pitchFamily="49" charset="0"/>
+                <a:latin typeface="Aptos Display" panose="020B0004020202020204" pitchFamily="34" charset="0"/>
                 <a:ea typeface="微软雅黑" panose="020B0503020204020204" pitchFamily="34" charset="-122"/>
                 <a:cs typeface="Consolas" panose="020B0609020204030204" pitchFamily="49" charset="0"/>
               </a:rPr>
@@ -17180,7 +17490,7 @@
                     <a:lumMod val="75000"/>
                   </a:schemeClr>
                 </a:solidFill>
-                <a:latin typeface="Consolas" panose="020B0609020204030204" pitchFamily="49" charset="0"/>
+                <a:latin typeface="Aptos Display" panose="020B0004020202020204" pitchFamily="34" charset="0"/>
                 <a:ea typeface="微软雅黑" panose="020B0503020204020204" pitchFamily="34" charset="-122"/>
                 <a:cs typeface="Consolas" panose="020B0609020204030204" pitchFamily="49" charset="0"/>
               </a:rPr>
@@ -17191,7 +17501,7 @@
                 <a:solidFill>
                   <a:prstClr val="black"/>
                 </a:solidFill>
-                <a:latin typeface="Consolas" panose="020B0609020204030204" pitchFamily="49" charset="0"/>
+                <a:latin typeface="Aptos Display" panose="020B0004020202020204" pitchFamily="34" charset="0"/>
                 <a:ea typeface="微软雅黑" panose="020B0503020204020204" pitchFamily="34" charset="-122"/>
                 <a:cs typeface="Consolas" panose="020B0609020204030204" pitchFamily="49" charset="0"/>
               </a:rPr>
@@ -17204,7 +17514,7 @@
                     <a:lumMod val="75000"/>
                   </a:schemeClr>
                 </a:solidFill>
-                <a:latin typeface="Consolas" panose="020B0609020204030204" pitchFamily="49" charset="0"/>
+                <a:latin typeface="Aptos Display" panose="020B0004020202020204" pitchFamily="34" charset="0"/>
                 <a:ea typeface="微软雅黑" panose="020B0503020204020204" pitchFamily="34" charset="-122"/>
                 <a:cs typeface="Consolas" panose="020B0609020204030204" pitchFamily="49" charset="0"/>
               </a:rPr>
@@ -17215,7 +17525,7 @@
                 <a:solidFill>
                   <a:prstClr val="black"/>
                 </a:solidFill>
-                <a:latin typeface="Consolas" panose="020B0609020204030204" pitchFamily="49" charset="0"/>
+                <a:latin typeface="Aptos Display" panose="020B0004020202020204" pitchFamily="34" charset="0"/>
                 <a:ea typeface="微软雅黑" panose="020B0503020204020204" pitchFamily="34" charset="-122"/>
                 <a:cs typeface="Consolas" panose="020B0609020204030204" pitchFamily="49" charset="0"/>
               </a:rPr>
@@ -17228,7 +17538,7 @@
                     <a:lumMod val="75000"/>
                   </a:schemeClr>
                 </a:solidFill>
-                <a:latin typeface="Consolas" panose="020B0609020204030204" pitchFamily="49" charset="0"/>
+                <a:latin typeface="Aptos Display" panose="020B0004020202020204" pitchFamily="34" charset="0"/>
                 <a:ea typeface="微软雅黑" panose="020B0503020204020204" pitchFamily="34" charset="-122"/>
                 <a:cs typeface="Consolas" panose="020B0609020204030204" pitchFamily="49" charset="0"/>
               </a:rPr>
@@ -17239,7 +17549,7 @@
                 <a:solidFill>
                   <a:prstClr val="black"/>
                 </a:solidFill>
-                <a:latin typeface="Consolas" panose="020B0609020204030204" pitchFamily="49" charset="0"/>
+                <a:latin typeface="Aptos Display" panose="020B0004020202020204" pitchFamily="34" charset="0"/>
                 <a:ea typeface="微软雅黑" panose="020B0503020204020204" pitchFamily="34" charset="-122"/>
                 <a:cs typeface="Consolas" panose="020B0609020204030204" pitchFamily="49" charset="0"/>
               </a:rPr>
@@ -17252,7 +17562,7 @@
                     <a:lumMod val="75000"/>
                   </a:schemeClr>
                 </a:solidFill>
-                <a:latin typeface="Consolas" panose="020B0609020204030204" pitchFamily="49" charset="0"/>
+                <a:latin typeface="Aptos Display" panose="020B0004020202020204" pitchFamily="34" charset="0"/>
                 <a:ea typeface="微软雅黑" panose="020B0503020204020204" pitchFamily="34" charset="-122"/>
                 <a:cs typeface="Consolas" panose="020B0609020204030204" pitchFamily="49" charset="0"/>
               </a:rPr>
@@ -17263,7 +17573,7 @@
                 <a:solidFill>
                   <a:prstClr val="black"/>
                 </a:solidFill>
-                <a:latin typeface="Consolas" panose="020B0609020204030204" pitchFamily="49" charset="0"/>
+                <a:latin typeface="Aptos Display" panose="020B0004020202020204" pitchFamily="34" charset="0"/>
                 <a:ea typeface="微软雅黑" panose="020B0503020204020204" pitchFamily="34" charset="-122"/>
                 <a:cs typeface="Consolas" panose="020B0609020204030204" pitchFamily="49" charset="0"/>
               </a:rPr>
@@ -17283,7 +17593,7 @@
                 <a:solidFill>
                   <a:srgbClr val="FF0000"/>
                 </a:solidFill>
-                <a:latin typeface="Consolas" panose="020B0609020204030204" pitchFamily="49" charset="0"/>
+                <a:latin typeface="Aptos Display" panose="020B0004020202020204" pitchFamily="34" charset="0"/>
                 <a:ea typeface="微软雅黑" panose="020B0503020204020204" pitchFamily="34" charset="-122"/>
                 <a:cs typeface="Consolas" panose="020B0609020204030204" pitchFamily="49" charset="0"/>
               </a:rPr>
@@ -17296,7 +17606,7 @@
                     <a:lumMod val="75000"/>
                   </a:schemeClr>
                 </a:solidFill>
-                <a:latin typeface="Consolas" panose="020B0609020204030204" pitchFamily="49" charset="0"/>
+                <a:latin typeface="Aptos Display" panose="020B0004020202020204" pitchFamily="34" charset="0"/>
                 <a:ea typeface="微软雅黑" panose="020B0503020204020204" pitchFamily="34" charset="-122"/>
                 <a:cs typeface="Consolas" panose="020B0609020204030204" pitchFamily="49" charset="0"/>
               </a:rPr>
@@ -17307,7 +17617,7 @@
                 <a:solidFill>
                   <a:srgbClr val="FF0000"/>
                 </a:solidFill>
-                <a:latin typeface="Consolas" panose="020B0609020204030204" pitchFamily="49" charset="0"/>
+                <a:latin typeface="Aptos Display" panose="020B0004020202020204" pitchFamily="34" charset="0"/>
                 <a:ea typeface="微软雅黑" panose="020B0503020204020204" pitchFamily="34" charset="-122"/>
                 <a:cs typeface="Consolas" panose="020B0609020204030204" pitchFamily="49" charset="0"/>
               </a:rPr>
@@ -17320,7 +17630,7 @@
                     <a:lumMod val="75000"/>
                   </a:schemeClr>
                 </a:solidFill>
-                <a:latin typeface="Consolas" panose="020B0609020204030204" pitchFamily="49" charset="0"/>
+                <a:latin typeface="Aptos Display" panose="020B0004020202020204" pitchFamily="34" charset="0"/>
                 <a:ea typeface="微软雅黑" panose="020B0503020204020204" pitchFamily="34" charset="-122"/>
                 <a:cs typeface="Consolas" panose="020B0609020204030204" pitchFamily="49" charset="0"/>
               </a:rPr>
@@ -17331,7 +17641,7 @@
                 <a:solidFill>
                   <a:srgbClr val="FF0000"/>
                 </a:solidFill>
-                <a:latin typeface="Consolas" panose="020B0609020204030204" pitchFamily="49" charset="0"/>
+                <a:latin typeface="Aptos Display" panose="020B0004020202020204" pitchFamily="34" charset="0"/>
                 <a:ea typeface="微软雅黑" panose="020B0503020204020204" pitchFamily="34" charset="-122"/>
                 <a:cs typeface="Consolas" panose="020B0609020204030204" pitchFamily="49" charset="0"/>
               </a:rPr>
@@ -17341,7 +17651,7 @@
               <a:solidFill>
                 <a:prstClr val="black"/>
               </a:solidFill>
-              <a:latin typeface="Consolas" panose="020B0609020204030204" pitchFamily="49" charset="0"/>
+              <a:latin typeface="Aptos Display" panose="020B0004020202020204" pitchFamily="34" charset="0"/>
               <a:ea typeface="微软雅黑" panose="020B0503020204020204" pitchFamily="34" charset="-122"/>
               <a:cs typeface="Consolas" panose="020B0609020204030204" pitchFamily="49" charset="0"/>
             </a:endParaRPr>
@@ -17359,7 +17669,7 @@
                 <a:solidFill>
                   <a:prstClr val="black"/>
                 </a:solidFill>
-                <a:latin typeface="Consolas" panose="020B0609020204030204" pitchFamily="49" charset="0"/>
+                <a:latin typeface="Aptos Display" panose="020B0004020202020204" pitchFamily="34" charset="0"/>
                 <a:ea typeface="微软雅黑" panose="020B0503020204020204" pitchFamily="34" charset="-122"/>
                 <a:cs typeface="Consolas" panose="020B0609020204030204" pitchFamily="49" charset="0"/>
               </a:rPr>
@@ -17372,7 +17682,7 @@
                     <a:lumMod val="75000"/>
                   </a:schemeClr>
                 </a:solidFill>
-                <a:latin typeface="Consolas" panose="020B0609020204030204" pitchFamily="49" charset="0"/>
+                <a:latin typeface="Aptos Display" panose="020B0004020202020204" pitchFamily="34" charset="0"/>
                 <a:ea typeface="微软雅黑" panose="020B0503020204020204" pitchFamily="34" charset="-122"/>
                 <a:cs typeface="Consolas" panose="020B0609020204030204" pitchFamily="49" charset="0"/>
               </a:rPr>
@@ -17383,7 +17693,7 @@
                 <a:solidFill>
                   <a:prstClr val="black"/>
                 </a:solidFill>
-                <a:latin typeface="Consolas" panose="020B0609020204030204" pitchFamily="49" charset="0"/>
+                <a:latin typeface="Aptos Display" panose="020B0004020202020204" pitchFamily="34" charset="0"/>
                 <a:ea typeface="微软雅黑" panose="020B0503020204020204" pitchFamily="34" charset="-122"/>
                 <a:cs typeface="Consolas" panose="020B0609020204030204" pitchFamily="49" charset="0"/>
               </a:rPr>
@@ -17394,7 +17704,7 @@
                 <a:solidFill>
                   <a:prstClr val="black"/>
                 </a:solidFill>
-                <a:latin typeface="Consolas" panose="020B0609020204030204" pitchFamily="49" charset="0"/>
+                <a:latin typeface="Aptos Display" panose="020B0004020202020204" pitchFamily="34" charset="0"/>
                 <a:ea typeface="微软雅黑" panose="020B0503020204020204" pitchFamily="34" charset="-122"/>
                 <a:cs typeface="Consolas" panose="020B0609020204030204" pitchFamily="49" charset="0"/>
               </a:rPr>
@@ -17414,7 +17724,7 @@
                 <a:solidFill>
                   <a:prstClr val="black"/>
                 </a:solidFill>
-                <a:latin typeface="Consolas" panose="020B0609020204030204" pitchFamily="49" charset="0"/>
+                <a:latin typeface="Aptos Display" panose="020B0004020202020204" pitchFamily="34" charset="0"/>
                 <a:ea typeface="微软雅黑" panose="020B0503020204020204" pitchFamily="34" charset="-122"/>
                 <a:cs typeface="Consolas" panose="020B0609020204030204" pitchFamily="49" charset="0"/>
               </a:rPr>
@@ -17425,7 +17735,7 @@
                 <a:solidFill>
                   <a:prstClr val="black"/>
                 </a:solidFill>
-                <a:latin typeface="Consolas" panose="020B0609020204030204" pitchFamily="49" charset="0"/>
+                <a:latin typeface="Aptos Display" panose="020B0004020202020204" pitchFamily="34" charset="0"/>
                 <a:ea typeface="微软雅黑" panose="020B0503020204020204" pitchFamily="34" charset="-122"/>
                 <a:cs typeface="Consolas" panose="020B0609020204030204" pitchFamily="49" charset="0"/>
                 <a:sym typeface="+mn-ea"/>
@@ -17437,7 +17747,7 @@
                 <a:solidFill>
                   <a:prstClr val="black"/>
                 </a:solidFill>
-                <a:latin typeface="Consolas" panose="020B0609020204030204" pitchFamily="49" charset="0"/>
+                <a:latin typeface="Aptos Display" panose="020B0004020202020204" pitchFamily="34" charset="0"/>
                 <a:ea typeface="微软雅黑" panose="020B0503020204020204" pitchFamily="34" charset="-122"/>
                 <a:cs typeface="Consolas" panose="020B0609020204030204" pitchFamily="49" charset="0"/>
                 <a:sym typeface="+mn-ea"/>
@@ -17449,7 +17759,7 @@
                 <a:solidFill>
                   <a:prstClr val="black"/>
                 </a:solidFill>
-                <a:latin typeface="Consolas" panose="020B0609020204030204" pitchFamily="49" charset="0"/>
+                <a:latin typeface="Aptos Display" panose="020B0004020202020204" pitchFamily="34" charset="0"/>
                 <a:ea typeface="微软雅黑" panose="020B0503020204020204" pitchFamily="34" charset="-122"/>
                 <a:cs typeface="Consolas" panose="020B0609020204030204" pitchFamily="49" charset="0"/>
                 <a:sym typeface="+mn-ea"/>
@@ -17460,7 +17770,7 @@
               <a:solidFill>
                 <a:prstClr val="black"/>
               </a:solidFill>
-              <a:latin typeface="Consolas" panose="020B0609020204030204" pitchFamily="49" charset="0"/>
+              <a:latin typeface="Aptos Display" panose="020B0004020202020204" pitchFamily="34" charset="0"/>
               <a:ea typeface="微软雅黑" panose="020B0503020204020204" pitchFamily="34" charset="-122"/>
               <a:cs typeface="Consolas" panose="020B0609020204030204" pitchFamily="49" charset="0"/>
             </a:endParaRPr>
@@ -17480,7 +17790,7 @@
                     <a:lumMod val="75000"/>
                   </a:schemeClr>
                 </a:solidFill>
-                <a:latin typeface="Consolas" panose="020B0609020204030204" pitchFamily="49" charset="0"/>
+                <a:latin typeface="Aptos Display" panose="020B0004020202020204" pitchFamily="34" charset="0"/>
                 <a:ea typeface="微软雅黑" panose="020B0503020204020204" pitchFamily="34" charset="-122"/>
                 <a:cs typeface="Consolas" panose="020B0609020204030204" pitchFamily="49" charset="0"/>
               </a:rPr>
@@ -17491,7 +17801,7 @@
                 <a:solidFill>
                   <a:prstClr val="black"/>
                 </a:solidFill>
-                <a:latin typeface="Consolas" panose="020B0609020204030204" pitchFamily="49" charset="0"/>
+                <a:latin typeface="Aptos Display" panose="020B0004020202020204" pitchFamily="34" charset="0"/>
                 <a:ea typeface="微软雅黑" panose="020B0503020204020204" pitchFamily="34" charset="-122"/>
                 <a:cs typeface="Consolas" panose="020B0609020204030204" pitchFamily="49" charset="0"/>
               </a:rPr>
@@ -17501,7 +17811,7 @@
               <a:solidFill>
                 <a:prstClr val="black"/>
               </a:solidFill>
-              <a:latin typeface="Consolas" panose="020B0609020204030204" pitchFamily="49" charset="0"/>
+              <a:latin typeface="Aptos Display" panose="020B0004020202020204" pitchFamily="34" charset="0"/>
               <a:ea typeface="微软雅黑" panose="020B0503020204020204" pitchFamily="34" charset="-122"/>
               <a:cs typeface="Consolas" panose="020B0609020204030204" pitchFamily="49" charset="0"/>
             </a:endParaRPr>
@@ -17519,7 +17829,7 @@
                 <a:solidFill>
                   <a:prstClr val="black"/>
                 </a:solidFill>
-                <a:latin typeface="Consolas" panose="020B0609020204030204" pitchFamily="49" charset="0"/>
+                <a:latin typeface="Aptos Display" panose="020B0004020202020204" pitchFamily="34" charset="0"/>
                 <a:ea typeface="微软雅黑" panose="020B0503020204020204" pitchFamily="34" charset="-122"/>
                 <a:cs typeface="Consolas" panose="020B0609020204030204" pitchFamily="49" charset="0"/>
               </a:rPr>
@@ -17532,7 +17842,7 @@
                     <a:lumMod val="75000"/>
                   </a:schemeClr>
                 </a:solidFill>
-                <a:latin typeface="Consolas" panose="020B0609020204030204" pitchFamily="49" charset="0"/>
+                <a:latin typeface="Aptos Display" panose="020B0004020202020204" pitchFamily="34" charset="0"/>
                 <a:ea typeface="微软雅黑" panose="020B0503020204020204" pitchFamily="34" charset="-122"/>
                 <a:cs typeface="Consolas" panose="020B0609020204030204" pitchFamily="49" charset="0"/>
               </a:rPr>
@@ -17543,7 +17853,7 @@
                 <a:solidFill>
                   <a:prstClr val="black"/>
                 </a:solidFill>
-                <a:latin typeface="Consolas" panose="020B0609020204030204" pitchFamily="49" charset="0"/>
+                <a:latin typeface="Aptos Display" panose="020B0004020202020204" pitchFamily="34" charset="0"/>
                 <a:ea typeface="微软雅黑" panose="020B0503020204020204" pitchFamily="34" charset="-122"/>
                 <a:cs typeface="Consolas" panose="020B0609020204030204" pitchFamily="49" charset="0"/>
               </a:rPr>
@@ -17556,7 +17866,7 @@
                     <a:lumMod val="75000"/>
                   </a:schemeClr>
                 </a:solidFill>
-                <a:latin typeface="Consolas" panose="020B0609020204030204" pitchFamily="49" charset="0"/>
+                <a:latin typeface="Aptos Display" panose="020B0004020202020204" pitchFamily="34" charset="0"/>
                 <a:ea typeface="微软雅黑" panose="020B0503020204020204" pitchFamily="34" charset="-122"/>
                 <a:cs typeface="Consolas" panose="020B0609020204030204" pitchFamily="49" charset="0"/>
               </a:rPr>
@@ -17567,7 +17877,7 @@
                 <a:solidFill>
                   <a:prstClr val="black"/>
                 </a:solidFill>
-                <a:latin typeface="Consolas" panose="020B0609020204030204" pitchFamily="49" charset="0"/>
+                <a:latin typeface="Aptos Display" panose="020B0004020202020204" pitchFamily="34" charset="0"/>
                 <a:ea typeface="微软雅黑" panose="020B0503020204020204" pitchFamily="34" charset="-122"/>
                 <a:cs typeface="Consolas" panose="020B0609020204030204" pitchFamily="49" charset="0"/>
               </a:rPr>
@@ -17580,7 +17890,7 @@
                     <a:lumMod val="75000"/>
                   </a:schemeClr>
                 </a:solidFill>
-                <a:latin typeface="Consolas" panose="020B0609020204030204" pitchFamily="49" charset="0"/>
+                <a:latin typeface="Aptos Display" panose="020B0004020202020204" pitchFamily="34" charset="0"/>
                 <a:ea typeface="微软雅黑" panose="020B0503020204020204" pitchFamily="34" charset="-122"/>
                 <a:cs typeface="Consolas" panose="020B0609020204030204" pitchFamily="49" charset="0"/>
               </a:rPr>
@@ -17591,7 +17901,7 @@
                 <a:solidFill>
                   <a:prstClr val="black"/>
                 </a:solidFill>
-                <a:latin typeface="Consolas" panose="020B0609020204030204" pitchFamily="49" charset="0"/>
+                <a:latin typeface="Aptos Display" panose="020B0004020202020204" pitchFamily="34" charset="0"/>
                 <a:ea typeface="微软雅黑" panose="020B0503020204020204" pitchFamily="34" charset="-122"/>
                 <a:cs typeface="Consolas" panose="020B0609020204030204" pitchFamily="49" charset="0"/>
               </a:rPr>
@@ -17604,7 +17914,7 @@
                     <a:lumMod val="75000"/>
                   </a:schemeClr>
                 </a:solidFill>
-                <a:latin typeface="Consolas" panose="020B0609020204030204" pitchFamily="49" charset="0"/>
+                <a:latin typeface="Aptos Display" panose="020B0004020202020204" pitchFamily="34" charset="0"/>
                 <a:ea typeface="微软雅黑" panose="020B0503020204020204" pitchFamily="34" charset="-122"/>
                 <a:cs typeface="Consolas" panose="020B0609020204030204" pitchFamily="49" charset="0"/>
               </a:rPr>
@@ -17615,7 +17925,7 @@
                 <a:solidFill>
                   <a:schemeClr val="bg1"/>
                 </a:solidFill>
-                <a:latin typeface="Consolas" panose="020B0609020204030204" pitchFamily="49" charset="0"/>
+                <a:latin typeface="Aptos Display" panose="020B0004020202020204" pitchFamily="34" charset="0"/>
                 <a:ea typeface="微软雅黑" panose="020B0503020204020204" pitchFamily="34" charset="-122"/>
                 <a:cs typeface="Consolas" panose="020B0609020204030204" pitchFamily="49" charset="0"/>
               </a:rPr>
@@ -17628,7 +17938,7 @@
                     <a:lumMod val="75000"/>
                   </a:schemeClr>
                 </a:solidFill>
-                <a:latin typeface="Consolas" panose="020B0609020204030204" pitchFamily="49" charset="0"/>
+                <a:latin typeface="Aptos Display" panose="020B0004020202020204" pitchFamily="34" charset="0"/>
                 <a:ea typeface="微软雅黑" panose="020B0503020204020204" pitchFamily="34" charset="-122"/>
                 <a:cs typeface="Consolas" panose="020B0609020204030204" pitchFamily="49" charset="0"/>
               </a:rPr>
@@ -17639,7 +17949,7 @@
                 <a:solidFill>
                   <a:prstClr val="black"/>
                 </a:solidFill>
-                <a:latin typeface="Consolas" panose="020B0609020204030204" pitchFamily="49" charset="0"/>
+                <a:latin typeface="Aptos Display" panose="020B0004020202020204" pitchFamily="34" charset="0"/>
                 <a:ea typeface="微软雅黑" panose="020B0503020204020204" pitchFamily="34" charset="-122"/>
                 <a:cs typeface="Consolas" panose="020B0609020204030204" pitchFamily="49" charset="0"/>
               </a:rPr>
@@ -17652,7 +17962,7 @@
                     <a:lumMod val="75000"/>
                   </a:schemeClr>
                 </a:solidFill>
-                <a:latin typeface="Consolas" panose="020B0609020204030204" pitchFamily="49" charset="0"/>
+                <a:latin typeface="Aptos Display" panose="020B0004020202020204" pitchFamily="34" charset="0"/>
                 <a:ea typeface="微软雅黑" panose="020B0503020204020204" pitchFamily="34" charset="-122"/>
                 <a:cs typeface="Consolas" panose="020B0609020204030204" pitchFamily="49" charset="0"/>
               </a:rPr>
@@ -17663,7 +17973,7 @@
                 <a:solidFill>
                   <a:prstClr val="black"/>
                 </a:solidFill>
-                <a:latin typeface="Consolas" panose="020B0609020204030204" pitchFamily="49" charset="0"/>
+                <a:latin typeface="Aptos Display" panose="020B0004020202020204" pitchFamily="34" charset="0"/>
                 <a:ea typeface="微软雅黑" panose="020B0503020204020204" pitchFamily="34" charset="-122"/>
                 <a:cs typeface="Consolas" panose="020B0609020204030204" pitchFamily="49" charset="0"/>
               </a:rPr>
@@ -17674,7 +17984,7 @@
                 <a:solidFill>
                   <a:prstClr val="black"/>
                 </a:solidFill>
-                <a:latin typeface="Consolas" panose="020B0609020204030204" pitchFamily="49" charset="0"/>
+                <a:latin typeface="Aptos Display" panose="020B0004020202020204" pitchFamily="34" charset="0"/>
                 <a:ea typeface="微软雅黑" panose="020B0503020204020204" pitchFamily="34" charset="-122"/>
                 <a:cs typeface="Consolas" panose="020B0609020204030204" pitchFamily="49" charset="0"/>
               </a:rPr>
@@ -17684,7 +17994,7 @@
               <a:solidFill>
                 <a:prstClr val="black"/>
               </a:solidFill>
-              <a:latin typeface="Consolas" panose="020B0609020204030204" pitchFamily="49" charset="0"/>
+              <a:latin typeface="Aptos Display" panose="020B0004020202020204" pitchFamily="34" charset="0"/>
               <a:ea typeface="微软雅黑" panose="020B0503020204020204" pitchFamily="34" charset="-122"/>
               <a:cs typeface="Consolas" panose="020B0609020204030204" pitchFamily="49" charset="0"/>
             </a:endParaRPr>
@@ -17739,14 +18049,14 @@
             </p:custDataLst>
             <p:extLst>
               <p:ext uri="{D42A27DB-BD31-4B8C-83A1-F6EECF244321}">
-                <p14:modId xmlns:p14="http://schemas.microsoft.com/office/powerpoint/2010/main" val="3072682424"/>
+                <p14:modId xmlns:p14="http://schemas.microsoft.com/office/powerpoint/2010/main" val="3497266616"/>
               </p:ext>
             </p:extLst>
           </p:nvPr>
         </p:nvGraphicFramePr>
         <p:xfrm>
-          <a:off x="347597" y="1856197"/>
-          <a:ext cx="6920711" cy="5593080"/>
+          <a:off x="347597" y="1856198"/>
+          <a:ext cx="6920711" cy="4709160"/>
         </p:xfrm>
         <a:graphic>
           <a:graphicData uri="http://schemas.openxmlformats.org/drawingml/2006/table">
@@ -17755,14 +18065,14 @@
                 <a:tableStyleId>{5C22544A-7EE6-4342-B048-85BDC9FD1C3A}</a:tableStyleId>
               </a:tblPr>
               <a:tblGrid>
-                <a:gridCol w="1950126">
+                <a:gridCol w="2177394">
                   <a:extLst>
                     <a:ext uri="{9D8B030D-6E8A-4147-A177-3AD203B41FA5}">
                       <a16:colId xmlns:a16="http://schemas.microsoft.com/office/drawing/2014/main" val="20000"/>
                     </a:ext>
                   </a:extLst>
                 </a:gridCol>
-                <a:gridCol w="4970585">
+                <a:gridCol w="4743317">
                   <a:extLst>
                     <a:ext uri="{9D8B030D-6E8A-4147-A177-3AD203B41FA5}">
                       <a16:colId xmlns:a16="http://schemas.microsoft.com/office/drawing/2014/main" val="20001"/>
@@ -17770,7 +18080,7 @@
                   </a:extLst>
                 </a:gridCol>
               </a:tblGrid>
-              <a:tr h="370840">
+              <a:tr h="480554">
                 <a:tc>
                   <a:txBody>
                     <a:bodyPr/>
@@ -17811,7 +18121,7 @@
                   </a:ext>
                 </a:extLst>
               </a:tr>
-              <a:tr h="370840">
+              <a:tr h="236571">
                 <a:tc>
                   <a:txBody>
                     <a:bodyPr/>
@@ -17840,7 +18150,7 @@
                     <a:lstStyle/>
                     <a:p>
                       <a:r>
-                        <a:rPr lang="en" altLang="zh-CN" sz="1200" dirty="0">
+                        <a:rPr lang="en" altLang="zh-CN" sz="1100" dirty="0">
                           <a:latin typeface="Consolas" panose="020B0609020204030204" pitchFamily="49" charset="0"/>
                           <a:ea typeface="微软雅黑" panose="020B0503020204020204" pitchFamily="34" charset="-122"/>
                           <a:cs typeface="Consolas" panose="020B0609020204030204" pitchFamily="49" charset="0"/>
@@ -17848,7 +18158,7 @@
                         <a:t>0 // evaluate both sides </a:t>
                       </a:r>
                       <a:r>
-                        <a:rPr lang="en" altLang="en-US" sz="1200" dirty="0">
+                        <a:rPr lang="en" altLang="en-US" sz="1100" dirty="0">
                           <a:latin typeface="Consolas" panose="020B0609020204030204" pitchFamily="49" charset="0"/>
                           <a:ea typeface="微软雅黑" panose="020B0503020204020204" pitchFamily="34" charset="-122"/>
                           <a:cs typeface="Consolas" panose="020B0609020204030204" pitchFamily="49" charset="0"/>
@@ -17865,7 +18175,7 @@
                   </a:ext>
                 </a:extLst>
               </a:tr>
-              <a:tr h="370840">
+              <a:tr h="236571">
                 <a:tc>
                   <a:txBody>
                     <a:bodyPr/>
@@ -17894,7 +18204,7 @@
                     <a:lstStyle/>
                     <a:p>
                       <a:r>
-                        <a:rPr lang="en" altLang="zh-CN" sz="1200" dirty="0">
+                        <a:rPr lang="en" altLang="zh-CN" sz="1100" dirty="0">
                           <a:latin typeface="Consolas" panose="020B0609020204030204" pitchFamily="49" charset="0"/>
                           <a:ea typeface="微软雅黑" panose="020B0503020204020204" pitchFamily="34" charset="-122"/>
                           <a:cs typeface="Consolas" panose="020B0609020204030204" pitchFamily="49" charset="0"/>
@@ -17902,7 +18212,7 @@
                         <a:t>1 // </a:t>
                       </a:r>
                       <a:r>
-                        <a:rPr lang="en" altLang="en-US" sz="1200" dirty="0">
+                        <a:rPr lang="en" altLang="en-US" sz="1100" dirty="0">
                           <a:latin typeface="Consolas" panose="020B0609020204030204" pitchFamily="49" charset="0"/>
                           <a:ea typeface="微软雅黑" panose="020B0503020204020204" pitchFamily="34" charset="-122"/>
                           <a:cs typeface="Consolas" panose="020B0609020204030204" pitchFamily="49" charset="0"/>
@@ -17919,7 +18229,7 @@
                   </a:ext>
                 </a:extLst>
               </a:tr>
-              <a:tr h="370840">
+              <a:tr h="236571">
                 <a:tc>
                   <a:txBody>
                     <a:bodyPr/>
@@ -17948,14 +18258,14 @@
                     <a:lstStyle/>
                     <a:p>
                       <a:r>
-                        <a:rPr lang="en" altLang="zh-CN" sz="1200" dirty="0">
+                        <a:rPr lang="en" altLang="zh-CN" sz="1100" dirty="0">
                           <a:latin typeface="Consolas" panose="020B0609020204030204" pitchFamily="49" charset="0"/>
                           <a:ea typeface="微软雅黑" panose="020B0503020204020204" pitchFamily="34" charset="-122"/>
                           <a:cs typeface="Consolas" panose="020B0609020204030204" pitchFamily="49" charset="0"/>
                         </a:rPr>
                         <a:t>0</a:t>
                       </a:r>
-                      <a:endParaRPr lang="zh-CN" altLang="en-US" sz="1200" dirty="0">
+                      <a:endParaRPr lang="zh-CN" altLang="en-US" sz="1100" dirty="0">
                         <a:latin typeface="Consolas" panose="020B0609020204030204" pitchFamily="49" charset="0"/>
                         <a:ea typeface="微软雅黑" panose="020B0503020204020204" pitchFamily="34" charset="-122"/>
                         <a:cs typeface="Consolas" panose="020B0609020204030204" pitchFamily="49" charset="0"/>
@@ -17970,7 +18280,7 @@
                   </a:ext>
                 </a:extLst>
               </a:tr>
-              <a:tr h="370840">
+              <a:tr h="320370">
                 <a:tc>
                   <a:txBody>
                     <a:bodyPr/>
@@ -17999,7 +18309,7 @@
                     <a:lstStyle/>
                     <a:p>
                       <a:r>
-                        <a:rPr lang="en" altLang="zh-CN" sz="1200" dirty="0">
+                        <a:rPr lang="en" altLang="zh-CN" sz="1100" dirty="0">
                           <a:latin typeface="Consolas" panose="020B0609020204030204" pitchFamily="49" charset="0"/>
                           <a:ea typeface="微软雅黑" panose="020B0503020204020204" pitchFamily="34" charset="-122"/>
                           <a:cs typeface="Consolas" panose="020B0609020204030204" pitchFamily="49" charset="0"/>
@@ -18007,7 +18317,7 @@
                         <a:t>1 // evaluate</a:t>
                       </a:r>
                       <a:r>
-                        <a:rPr lang="en" altLang="en-US" sz="1200" dirty="0">
+                        <a:rPr lang="en" altLang="en-US" sz="1100" dirty="0">
                           <a:latin typeface="Consolas" panose="020B0609020204030204" pitchFamily="49" charset="0"/>
                           <a:ea typeface="微软雅黑" panose="020B0503020204020204" pitchFamily="34" charset="-122"/>
                           <a:cs typeface="Consolas" panose="020B0609020204030204" pitchFamily="49" charset="0"/>
@@ -18015,7 +18325,7 @@
                         <a:t> both sides of </a:t>
                       </a:r>
                       <a:r>
-                        <a:rPr lang="en" altLang="zh-CN" sz="1200" dirty="0">
+                        <a:rPr lang="en" altLang="zh-CN" sz="1100" dirty="0">
                           <a:latin typeface="Consolas" panose="020B0609020204030204" pitchFamily="49" charset="0"/>
                           <a:ea typeface="微软雅黑" panose="020B0503020204020204" pitchFamily="34" charset="-122"/>
                           <a:cs typeface="Consolas" panose="020B0609020204030204" pitchFamily="49" charset="0"/>
@@ -18023,7 +18333,7 @@
                         <a:t>!= separately</a:t>
                       </a:r>
                       <a:r>
-                        <a:rPr lang="en" altLang="en-US" sz="1200" dirty="0">
+                        <a:rPr lang="en" altLang="en-US" sz="1100" dirty="0">
                           <a:latin typeface="Consolas" panose="020B0609020204030204" pitchFamily="49" charset="0"/>
                           <a:ea typeface="微软雅黑" panose="020B0503020204020204" pitchFamily="34" charset="-122"/>
                           <a:cs typeface="Consolas" panose="020B0609020204030204" pitchFamily="49" charset="0"/>
@@ -18040,7 +18350,7 @@
                   </a:ext>
                 </a:extLst>
               </a:tr>
-              <a:tr h="370840">
+              <a:tr h="272218">
                 <a:tc>
                   <a:txBody>
                     <a:bodyPr/>
@@ -18085,7 +18395,7 @@
                     <a:lstStyle/>
                     <a:p>
                       <a:r>
-                        <a:rPr lang="en" altLang="zh-CN" sz="1200" dirty="0">
+                        <a:rPr lang="en" altLang="zh-CN" sz="1100" dirty="0">
                           <a:latin typeface="Consolas" panose="020B0609020204030204" pitchFamily="49" charset="0"/>
                           <a:ea typeface="微软雅黑" panose="020B0503020204020204" pitchFamily="34" charset="-122"/>
                           <a:cs typeface="Consolas" panose="020B0609020204030204" pitchFamily="49" charset="0"/>
@@ -18093,7 +18403,7 @@
                         <a:t>0 // evaluate </a:t>
                       </a:r>
                       <a:r>
-                        <a:rPr lang="en" altLang="en-US" sz="1200" dirty="0">
+                        <a:rPr lang="en" altLang="en-US" sz="1100" dirty="0">
                           <a:latin typeface="Consolas" panose="020B0609020204030204" pitchFamily="49" charset="0"/>
                           <a:ea typeface="微软雅黑" panose="020B0503020204020204" pitchFamily="34" charset="-122"/>
                           <a:cs typeface="Consolas" panose="020B0609020204030204" pitchFamily="49" charset="0"/>
@@ -18110,7 +18420,7 @@
                   </a:ext>
                 </a:extLst>
               </a:tr>
-              <a:tr h="370840">
+              <a:tr h="272218">
                 <a:tc>
                   <a:txBody>
                     <a:bodyPr/>
@@ -18139,7 +18449,7 @@
                     <a:lstStyle/>
                     <a:p>
                       <a:r>
-                        <a:rPr lang="en" altLang="zh-CN" sz="1200" dirty="0">
+                        <a:rPr lang="en" altLang="zh-CN" sz="1100" dirty="0">
                           <a:latin typeface="Consolas" panose="020B0609020204030204" pitchFamily="49" charset="0"/>
                           <a:ea typeface="微软雅黑" panose="020B0503020204020204" pitchFamily="34" charset="-122"/>
                           <a:cs typeface="Consolas" panose="020B0609020204030204" pitchFamily="49" charset="0"/>
@@ -18147,7 +18457,7 @@
                         <a:t>1 // </a:t>
                       </a:r>
                       <a:r>
-                        <a:rPr lang="en" altLang="en-US" sz="1200" dirty="0">
+                        <a:rPr lang="en" altLang="en-US" sz="1100" dirty="0">
                           <a:latin typeface="Consolas" panose="020B0609020204030204" pitchFamily="49" charset="0"/>
                           <a:ea typeface="微软雅黑" panose="020B0503020204020204" pitchFamily="34" charset="-122"/>
                           <a:cs typeface="Consolas" panose="020B0609020204030204" pitchFamily="49" charset="0"/>
@@ -18155,7 +18465,7 @@
                         <a:t>Character type is used for operations, using </a:t>
                       </a:r>
                       <a:r>
-                        <a:rPr lang="en" altLang="zh-CN" sz="1200" dirty="0">
+                        <a:rPr lang="en" altLang="zh-CN" sz="1100" dirty="0">
                           <a:latin typeface="Consolas" panose="020B0609020204030204" pitchFamily="49" charset="0"/>
                           <a:ea typeface="微软雅黑" panose="020B0503020204020204" pitchFamily="34" charset="-122"/>
                           <a:cs typeface="Consolas" panose="020B0609020204030204" pitchFamily="49" charset="0"/>
@@ -18163,7 +18473,7 @@
                         <a:t>ASCII </a:t>
                       </a:r>
                       <a:r>
-                        <a:rPr lang="en" altLang="en-US" sz="1200" dirty="0">
+                        <a:rPr lang="en" altLang="en-US" sz="1100" dirty="0">
                           <a:latin typeface="Consolas" panose="020B0609020204030204" pitchFamily="49" charset="0"/>
                           <a:ea typeface="微软雅黑" panose="020B0503020204020204" pitchFamily="34" charset="-122"/>
                           <a:cs typeface="Consolas" panose="020B0609020204030204" pitchFamily="49" charset="0"/>
@@ -18180,7 +18490,7 @@
                   </a:ext>
                 </a:extLst>
               </a:tr>
-              <a:tr h="370840">
+              <a:tr h="236571">
                 <a:tc>
                   <a:txBody>
                     <a:bodyPr/>
@@ -18209,7 +18519,7 @@
                     <a:lstStyle/>
                     <a:p>
                       <a:r>
-                        <a:rPr lang="en" altLang="zh-CN" sz="1200" dirty="0">
+                        <a:rPr lang="en" altLang="zh-CN" sz="1100" dirty="0">
                           <a:latin typeface="Consolas" panose="020B0609020204030204" pitchFamily="49" charset="0"/>
                           <a:ea typeface="微软雅黑" panose="020B0503020204020204" pitchFamily="34" charset="-122"/>
                           <a:cs typeface="Consolas" panose="020B0609020204030204" pitchFamily="49" charset="0"/>
@@ -18217,7 +18527,7 @@
                         <a:t>1 // evaluate</a:t>
                       </a:r>
                       <a:r>
-                        <a:rPr lang="en" altLang="en-US" sz="1200" dirty="0">
+                        <a:rPr lang="en" altLang="en-US" sz="1100" dirty="0">
                           <a:latin typeface="Consolas" panose="020B0609020204030204" pitchFamily="49" charset="0"/>
                           <a:ea typeface="微软雅黑" panose="020B0503020204020204" pitchFamily="34" charset="-122"/>
                           <a:cs typeface="Consolas" panose="020B0609020204030204" pitchFamily="49" charset="0"/>
@@ -18234,7 +18544,7 @@
                   </a:ext>
                 </a:extLst>
               </a:tr>
-              <a:tr h="370840">
+              <a:tr h="593046">
                 <a:tc>
                   <a:txBody>
                     <a:bodyPr/>
@@ -18283,7 +18593,7 @@
                         <a:buChar char="•"/>
                       </a:pPr>
                       <a:r>
-                        <a:rPr lang="en" altLang="en-US" sz="1200" dirty="0">
+                        <a:rPr lang="en" altLang="en-US" sz="1100" dirty="0">
                           <a:latin typeface="Consolas" panose="020B0609020204030204" pitchFamily="49" charset="0"/>
                           <a:ea typeface="微软雅黑" panose="020B0503020204020204" pitchFamily="34" charset="-122"/>
                           <a:cs typeface="Consolas" panose="020B0609020204030204" pitchFamily="49" charset="0"/>
@@ -18291,7 +18601,7 @@
                         <a:t>evaluate </a:t>
                       </a:r>
                       <a:r>
-                        <a:rPr lang="en" altLang="zh-CN" sz="1200" dirty="0">
+                        <a:rPr lang="en" altLang="zh-CN" sz="1100" dirty="0">
                           <a:latin typeface="Consolas" panose="020B0609020204030204" pitchFamily="49" charset="0"/>
                           <a:ea typeface="微软雅黑" panose="020B0503020204020204" pitchFamily="34" charset="-122"/>
                           <a:cs typeface="Consolas" panose="020B0609020204030204" pitchFamily="49" charset="0"/>
@@ -18299,14 +18609,14 @@
                         <a:t>0&lt;a first </a:t>
                       </a:r>
                       <a:r>
-                        <a:rPr lang="en" altLang="en-US" sz="1200" dirty="0">
+                        <a:rPr lang="en" altLang="en-US" sz="1100" dirty="0">
                           <a:latin typeface="Consolas" panose="020B0609020204030204" pitchFamily="49" charset="0"/>
                           <a:ea typeface="微软雅黑" panose="020B0503020204020204" pitchFamily="34" charset="-122"/>
                           <a:cs typeface="Consolas" panose="020B0609020204030204" pitchFamily="49" charset="0"/>
                         </a:rPr>
                         <a:t>and get an intermediate result of either 0 or 1</a:t>
                       </a:r>
-                      <a:endParaRPr lang="en-US" altLang="zh-CN" sz="1200" dirty="0">
+                      <a:endParaRPr lang="en-US" altLang="zh-CN" sz="1100" dirty="0">
                         <a:latin typeface="Consolas" panose="020B0609020204030204" pitchFamily="49" charset="0"/>
                         <a:ea typeface="微软雅黑" panose="020B0503020204020204" pitchFamily="34" charset="-122"/>
                         <a:cs typeface="Consolas" panose="020B0609020204030204" pitchFamily="49" charset="0"/>
@@ -18318,7 +18628,7 @@
                         <a:buChar char="•"/>
                       </a:pPr>
                       <a:r>
-                        <a:rPr lang="en" altLang="en-US" sz="1200" dirty="0">
+                        <a:rPr lang="en" altLang="en-US" sz="1100" dirty="0">
                           <a:latin typeface="Consolas" panose="020B0609020204030204" pitchFamily="49" charset="0"/>
                           <a:ea typeface="微软雅黑" panose="020B0503020204020204" pitchFamily="34" charset="-122"/>
                           <a:cs typeface="Consolas" panose="020B0609020204030204" pitchFamily="49" charset="0"/>
@@ -18326,7 +18636,7 @@
                         <a:t>Then evaluate the intermediate result </a:t>
                       </a:r>
                       <a:r>
-                        <a:rPr lang="en" altLang="zh-CN" sz="1200" dirty="0">
+                        <a:rPr lang="en" altLang="zh-CN" sz="1100" dirty="0">
                           <a:latin typeface="Consolas" panose="020B0609020204030204" pitchFamily="49" charset="0"/>
                           <a:ea typeface="微软雅黑" panose="020B0503020204020204" pitchFamily="34" charset="-122"/>
                           <a:cs typeface="Consolas" panose="020B0609020204030204" pitchFamily="49" charset="0"/>
@@ -18334,7 +18644,7 @@
                         <a:t>&lt;5</a:t>
                       </a:r>
                       <a:r>
-                        <a:rPr lang="en" altLang="en-US" sz="1200" dirty="0">
+                        <a:rPr lang="en" altLang="en-US" sz="1100" dirty="0">
                           <a:latin typeface="Consolas" panose="020B0609020204030204" pitchFamily="49" charset="0"/>
                           <a:ea typeface="微软雅黑" panose="020B0503020204020204" pitchFamily="34" charset="-122"/>
                           <a:cs typeface="Consolas" panose="020B0609020204030204" pitchFamily="49" charset="0"/>
@@ -18342,7 +18652,7 @@
                         <a:t>, no matter the intermediate result is </a:t>
                       </a:r>
                       <a:r>
-                        <a:rPr lang="en" altLang="zh-CN" sz="1200" dirty="0">
+                        <a:rPr lang="en" altLang="zh-CN" sz="1100" dirty="0">
                           <a:latin typeface="Consolas" panose="020B0609020204030204" pitchFamily="49" charset="0"/>
                           <a:ea typeface="微软雅黑" panose="020B0503020204020204" pitchFamily="34" charset="-122"/>
                           <a:cs typeface="Consolas" panose="020B0609020204030204" pitchFamily="49" charset="0"/>
@@ -18350,7 +18660,7 @@
                         <a:t>0 </a:t>
                       </a:r>
                       <a:r>
-                        <a:rPr lang="en" altLang="en-US" sz="1200" dirty="0">
+                        <a:rPr lang="en" altLang="en-US" sz="1100" dirty="0">
                           <a:latin typeface="Consolas" panose="020B0609020204030204" pitchFamily="49" charset="0"/>
                           <a:ea typeface="微软雅黑" panose="020B0503020204020204" pitchFamily="34" charset="-122"/>
                           <a:cs typeface="Consolas" panose="020B0609020204030204" pitchFamily="49" charset="0"/>
@@ -18358,7 +18668,7 @@
                         <a:t>or </a:t>
                       </a:r>
                       <a:r>
-                        <a:rPr lang="en" altLang="zh-CN" sz="1200" dirty="0">
+                        <a:rPr lang="en" altLang="zh-CN" sz="1100" dirty="0">
                           <a:latin typeface="Consolas" panose="020B0609020204030204" pitchFamily="49" charset="0"/>
                           <a:ea typeface="微软雅黑" panose="020B0503020204020204" pitchFamily="34" charset="-122"/>
                           <a:cs typeface="Consolas" panose="020B0609020204030204" pitchFamily="49" charset="0"/>
@@ -18366,7 +18676,7 @@
                         <a:t>1</a:t>
                       </a:r>
                       <a:r>
-                        <a:rPr lang="en" altLang="en-US" sz="1200" dirty="0">
+                        <a:rPr lang="en" altLang="en-US" sz="1100" dirty="0">
                           <a:latin typeface="Consolas" panose="020B0609020204030204" pitchFamily="49" charset="0"/>
                           <a:ea typeface="微软雅黑" panose="020B0503020204020204" pitchFamily="34" charset="-122"/>
                           <a:cs typeface="Consolas" panose="020B0609020204030204" pitchFamily="49" charset="0"/>
@@ -18374,14 +18684,14 @@
                         <a:t>, the final result must be </a:t>
                       </a:r>
                       <a:r>
-                        <a:rPr lang="en" altLang="zh-CN" sz="1200" dirty="0">
+                        <a:rPr lang="en" altLang="zh-CN" sz="1100" dirty="0">
                           <a:latin typeface="Consolas" panose="020B0609020204030204" pitchFamily="49" charset="0"/>
                           <a:ea typeface="微软雅黑" panose="020B0503020204020204" pitchFamily="34" charset="-122"/>
                           <a:cs typeface="Consolas" panose="020B0609020204030204" pitchFamily="49" charset="0"/>
                         </a:rPr>
                         <a:t>1</a:t>
                       </a:r>
-                      <a:endParaRPr lang="zh-CN" altLang="en-US" sz="1200" dirty="0">
+                      <a:endParaRPr lang="zh-CN" altLang="en-US" sz="1100" dirty="0">
                         <a:latin typeface="Consolas" panose="020B0609020204030204" pitchFamily="49" charset="0"/>
                         <a:ea typeface="微软雅黑" panose="020B0503020204020204" pitchFamily="34" charset="-122"/>
                         <a:cs typeface="Consolas" panose="020B0609020204030204" pitchFamily="49" charset="0"/>
@@ -18396,7 +18706,7 @@
                   </a:ext>
                 </a:extLst>
               </a:tr>
-              <a:tr h="370840">
+              <a:tr h="697948">
                 <a:tc>
                   <a:txBody>
                     <a:bodyPr/>
@@ -18441,7 +18751,7 @@
                     <a:lstStyle/>
                     <a:p>
                       <a:r>
-                        <a:rPr lang="en" altLang="zh-CN" sz="1200" dirty="0">
+                        <a:rPr lang="en" altLang="zh-CN" sz="1100" dirty="0">
                           <a:latin typeface="Consolas" panose="020B0609020204030204" pitchFamily="49" charset="0"/>
                           <a:ea typeface="微软雅黑" panose="020B0503020204020204" pitchFamily="34" charset="-122"/>
                           <a:cs typeface="Consolas" panose="020B0609020204030204" pitchFamily="49" charset="0"/>
@@ -18449,7 +18759,7 @@
                         <a:t>0 // evaluate both sides </a:t>
                       </a:r>
                       <a:r>
-                        <a:rPr lang="en" altLang="en-US" sz="1200" dirty="0">
+                        <a:rPr lang="en" altLang="en-US" sz="1100" dirty="0">
                           <a:latin typeface="Consolas" panose="020B0609020204030204" pitchFamily="49" charset="0"/>
                           <a:ea typeface="微软雅黑" panose="020B0503020204020204" pitchFamily="34" charset="-122"/>
                           <a:cs typeface="Consolas" panose="020B0609020204030204" pitchFamily="49" charset="0"/>
@@ -18459,7 +18769,7 @@
                     </a:p>
                     <a:p>
                       <a:r>
-                        <a:rPr lang="en" altLang="en-US" sz="1200" dirty="0">
+                        <a:rPr lang="en" altLang="en-US" sz="1100" dirty="0">
                           <a:latin typeface="Consolas" panose="020B0609020204030204" pitchFamily="49" charset="0"/>
                           <a:ea typeface="微软雅黑" panose="020B0503020204020204" pitchFamily="34" charset="-122"/>
                           <a:cs typeface="Consolas" panose="020B0609020204030204" pitchFamily="49" charset="0"/>
@@ -18469,7 +18779,7 @@
                     </a:p>
                     <a:p>
                       <a:r>
-                        <a:rPr lang="en" altLang="en-US" sz="1200" dirty="0">
+                        <a:rPr lang="en" altLang="en-US" sz="1100" dirty="0">
                           <a:latin typeface="Consolas" panose="020B0609020204030204" pitchFamily="49" charset="0"/>
                           <a:ea typeface="微软雅黑" panose="020B0503020204020204" pitchFamily="34" charset="-122"/>
                           <a:cs typeface="Consolas" panose="020B0609020204030204" pitchFamily="49" charset="0"/>
@@ -18477,7 +18787,7 @@
                         <a:t>Note: After this expression is executed, the values of </a:t>
                       </a:r>
                       <a:r>
-                        <a:rPr lang="en" altLang="zh-CN" sz="1200" dirty="0">
+                        <a:rPr lang="en" altLang="zh-CN" sz="1100" dirty="0">
                           <a:latin typeface="Consolas" panose="020B0609020204030204" pitchFamily="49" charset="0"/>
                           <a:ea typeface="微软雅黑" panose="020B0503020204020204" pitchFamily="34" charset="-122"/>
                           <a:cs typeface="Consolas" panose="020B0609020204030204" pitchFamily="49" charset="0"/>
@@ -18485,7 +18795,7 @@
                         <a:t>a </a:t>
                       </a:r>
                       <a:r>
-                        <a:rPr lang="en" altLang="en-US" sz="1200" dirty="0">
+                        <a:rPr lang="en" altLang="en-US" sz="1100" dirty="0">
                           <a:latin typeface="Consolas" panose="020B0609020204030204" pitchFamily="49" charset="0"/>
                           <a:ea typeface="微软雅黑" panose="020B0503020204020204" pitchFamily="34" charset="-122"/>
                           <a:cs typeface="Consolas" panose="020B0609020204030204" pitchFamily="49" charset="0"/>
@@ -18493,7 +18803,7 @@
                         <a:t>and </a:t>
                       </a:r>
                       <a:r>
-                        <a:rPr lang="en" altLang="zh-CN" sz="1200" dirty="0">
+                        <a:rPr lang="en" altLang="zh-CN" sz="1100" dirty="0">
                           <a:latin typeface="Consolas" panose="020B0609020204030204" pitchFamily="49" charset="0"/>
                           <a:ea typeface="微软雅黑" panose="020B0503020204020204" pitchFamily="34" charset="-122"/>
                           <a:cs typeface="Consolas" panose="020B0609020204030204" pitchFamily="49" charset="0"/>
@@ -18501,7 +18811,7 @@
                         <a:t>b </a:t>
                       </a:r>
                       <a:r>
-                        <a:rPr lang="en" altLang="en-US" sz="1200" dirty="0">
+                        <a:rPr lang="en" altLang="en-US" sz="1100" dirty="0">
                           <a:latin typeface="Consolas" panose="020B0609020204030204" pitchFamily="49" charset="0"/>
                           <a:ea typeface="微软雅黑" panose="020B0503020204020204" pitchFamily="34" charset="-122"/>
                           <a:cs typeface="Consolas" panose="020B0609020204030204" pitchFamily="49" charset="0"/>

</xml_diff>